<commit_message>
World Teachers' Day options: square photo grid, 10-slide bunting version, brand colours only (no gold), no italics
Co-Authored-By: Claude Opus 5.5 <noreply@anthropic.com>
Claude-Session: https://claude.ai/code/session_014HGzAbxBh54nuyJHG7tse8
</commit_message>
<xml_diff>
--- a/templates/posts/october/05-10-2026-mon-ig-teachers-day-option-1-photo.pptx
+++ b/templates/posts/october/05-10-2026-mon-ig-teachers-day-option-1-photo.pptx
@@ -3589,7 +3589,7 @@
       <p:grpSpPr/>
       <p:pic>
         <p:nvPicPr>
-          <p:cNvPr id="2" name="Picture 1" descr="15996378992139931.jpg"/>
+          <p:cNvPr id="2" name="Picture 1" descr="6096515828490417451.jpg"/>
           <p:cNvPicPr>
             <a:picLocks noChangeAspect="1"/>
           </p:cNvPicPr>
@@ -3717,11 +3717,11 @@
               </a:lnSpc>
             </a:pPr>
             <a:r>
-              <a:rPr sz="2800" b="0" i="1">
+              <a:rPr sz="2800" b="0" i="0">
                 <a:solidFill>
                   <a:srgbClr val="1A1A1A"/>
                 </a:solidFill>
-                <a:latin typeface="EB Garamond"/>
+                <a:latin typeface="Source Sans 3"/>
               </a:rPr>
               <a:t>Thank you to the mentors who teach our students to see soil.</a:t>
             </a:r>
@@ -3786,7 +3786,7 @@
         </p:nvSpPr>
         <p:spPr>
           <a:xfrm>
-            <a:off x="762000" y="666750"/>
+            <a:off x="762000" y="1143000"/>
             <a:ext cx="8763000" cy="381000"/>
           </a:xfrm>
           <a:prstGeom prst="rect">
@@ -3819,7 +3819,7 @@
       </p:sp>
       <p:pic>
         <p:nvPicPr>
-          <p:cNvPr id="3" name="Picture 2" descr="8987340700735254398.jpg"/>
+          <p:cNvPr id="3" name="Picture 2" descr="894524731619023401.jpg"/>
           <p:cNvPicPr>
             <a:picLocks noChangeAspect="1"/>
           </p:cNvPicPr>
@@ -3833,24 +3833,70 @@
         </p:blipFill>
         <p:spPr>
           <a:xfrm>
-            <a:off x="766762" y="1333500"/>
-            <a:ext cx="1866900" cy="1866900"/>
-          </a:xfrm>
-          <a:prstGeom prst="ellipse">
+            <a:off x="457200" y="2190750"/>
+            <a:ext cx="2286000" cy="2286000"/>
+          </a:xfrm>
+          <a:prstGeom prst="rect">
             <a:avLst/>
           </a:prstGeom>
         </p:spPr>
       </p:pic>
       <p:sp>
         <p:nvSpPr>
-          <p:cNvPr id="4" name="TextBox 3"/>
+          <p:cNvPr id="4" name="Rectangle 3"/>
+          <p:cNvSpPr/>
+          <p:nvPr/>
+        </p:nvSpPr>
+        <p:spPr>
+          <a:xfrm>
+            <a:off x="457200" y="4057650"/>
+            <a:ext cx="2286000" cy="419100"/>
+          </a:xfrm>
+          <a:prstGeom prst="rect">
+            <a:avLst/>
+          </a:prstGeom>
+          <a:solidFill>
+            <a:srgbClr val="F3F1EA">
+              <a:alpha val="88000"/>
+            </a:srgbClr>
+          </a:solidFill>
+          <a:ln>
+            <a:noFill/>
+          </a:ln>
+          <a:effectLst/>
+        </p:spPr>
+        <p:style>
+          <a:lnRef idx="1">
+            <a:schemeClr val="accent1"/>
+          </a:lnRef>
+          <a:fillRef idx="3">
+            <a:schemeClr val="accent1"/>
+          </a:fillRef>
+          <a:effectRef idx="2">
+            <a:schemeClr val="accent1"/>
+          </a:effectRef>
+          <a:fontRef idx="minor">
+            <a:schemeClr val="lt1"/>
+          </a:fontRef>
+        </p:style>
+        <p:txBody>
+          <a:bodyPr rtlCol="0" anchor="ctr"/>
+          <a:lstStyle/>
+          <a:p>
+            <a:pPr algn="ctr"/>
+          </a:p>
+        </p:txBody>
+      </p:sp>
+      <p:sp>
+        <p:nvSpPr>
+          <p:cNvPr id="5" name="TextBox 4"/>
           <p:cNvSpPr txBox="1"/>
           <p:nvPr/>
         </p:nvSpPr>
         <p:spPr>
           <a:xfrm>
-            <a:off x="538162" y="3276600"/>
-            <a:ext cx="2324100" cy="285750"/>
+            <a:off x="514350" y="4057650"/>
+            <a:ext cx="2171700" cy="419100"/>
           </a:xfrm>
           <a:prstGeom prst="rect">
             <a:avLst/>
@@ -3858,7 +3904,7 @@
           <a:noFill/>
         </p:spPr>
         <p:txBody>
-          <a:bodyPr wrap="square" lIns="0" rIns="0" tIns="0" bIns="0" anchor="t">
+          <a:bodyPr wrap="square" lIns="0" rIns="0" tIns="0" bIns="0" anchor="ctr">
             <a:spAutoFit/>
           </a:bodyPr>
           <a:lstStyle/>
@@ -3869,7 +3915,7 @@
               </a:lnSpc>
             </a:pPr>
             <a:r>
-              <a:rPr sz="1700" b="1" i="0">
+              <a:rPr sz="1500" b="1" i="0">
                 <a:solidFill>
                   <a:srgbClr val="31662F"/>
                 </a:solidFill>
@@ -3882,7 +3928,7 @@
       </p:sp>
       <p:pic>
         <p:nvPicPr>
-          <p:cNvPr id="5" name="Picture 4" descr="1614639297732116231.jpg"/>
+          <p:cNvPr id="6" name="Picture 5" descr="7427239733233723794.jpg"/>
           <p:cNvPicPr>
             <a:picLocks noChangeAspect="1"/>
           </p:cNvPicPr>
@@ -3896,24 +3942,70 @@
         </p:blipFill>
         <p:spPr>
           <a:xfrm>
-            <a:off x="3062287" y="1333500"/>
-            <a:ext cx="1866900" cy="1866900"/>
-          </a:xfrm>
-          <a:prstGeom prst="ellipse">
+            <a:off x="2819400" y="2190750"/>
+            <a:ext cx="2286000" cy="2286000"/>
+          </a:xfrm>
+          <a:prstGeom prst="rect">
             <a:avLst/>
           </a:prstGeom>
         </p:spPr>
       </p:pic>
       <p:sp>
         <p:nvSpPr>
-          <p:cNvPr id="6" name="TextBox 5"/>
+          <p:cNvPr id="7" name="Rectangle 6"/>
+          <p:cNvSpPr/>
+          <p:nvPr/>
+        </p:nvSpPr>
+        <p:spPr>
+          <a:xfrm>
+            <a:off x="2819400" y="4057650"/>
+            <a:ext cx="2286000" cy="419100"/>
+          </a:xfrm>
+          <a:prstGeom prst="rect">
+            <a:avLst/>
+          </a:prstGeom>
+          <a:solidFill>
+            <a:srgbClr val="F3F1EA">
+              <a:alpha val="88000"/>
+            </a:srgbClr>
+          </a:solidFill>
+          <a:ln>
+            <a:noFill/>
+          </a:ln>
+          <a:effectLst/>
+        </p:spPr>
+        <p:style>
+          <a:lnRef idx="1">
+            <a:schemeClr val="accent1"/>
+          </a:lnRef>
+          <a:fillRef idx="3">
+            <a:schemeClr val="accent1"/>
+          </a:fillRef>
+          <a:effectRef idx="2">
+            <a:schemeClr val="accent1"/>
+          </a:effectRef>
+          <a:fontRef idx="minor">
+            <a:schemeClr val="lt1"/>
+          </a:fontRef>
+        </p:style>
+        <p:txBody>
+          <a:bodyPr rtlCol="0" anchor="ctr"/>
+          <a:lstStyle/>
+          <a:p>
+            <a:pPr algn="ctr"/>
+          </a:p>
+        </p:txBody>
+      </p:sp>
+      <p:sp>
+        <p:nvSpPr>
+          <p:cNvPr id="8" name="TextBox 7"/>
           <p:cNvSpPr txBox="1"/>
           <p:nvPr/>
         </p:nvSpPr>
         <p:spPr>
           <a:xfrm>
-            <a:off x="2833687" y="3276600"/>
-            <a:ext cx="2324100" cy="285750"/>
+            <a:off x="2876550" y="4057650"/>
+            <a:ext cx="2171700" cy="419100"/>
           </a:xfrm>
           <a:prstGeom prst="rect">
             <a:avLst/>
@@ -3921,7 +4013,7 @@
           <a:noFill/>
         </p:spPr>
         <p:txBody>
-          <a:bodyPr wrap="square" lIns="0" rIns="0" tIns="0" bIns="0" anchor="t">
+          <a:bodyPr wrap="square" lIns="0" rIns="0" tIns="0" bIns="0" anchor="ctr">
             <a:spAutoFit/>
           </a:bodyPr>
           <a:lstStyle/>
@@ -3932,7 +4024,7 @@
               </a:lnSpc>
             </a:pPr>
             <a:r>
-              <a:rPr sz="1700" b="1" i="0">
+              <a:rPr sz="1500" b="1" i="0">
                 <a:solidFill>
                   <a:srgbClr val="31662F"/>
                 </a:solidFill>
@@ -3945,7 +4037,7 @@
       </p:sp>
       <p:pic>
         <p:nvPicPr>
-          <p:cNvPr id="7" name="Picture 6" descr="7621405335023908523.jpg"/>
+          <p:cNvPr id="9" name="Picture 8" descr="6023360388099870640.jpg"/>
           <p:cNvPicPr>
             <a:picLocks noChangeAspect="1"/>
           </p:cNvPicPr>
@@ -3959,24 +4051,70 @@
         </p:blipFill>
         <p:spPr>
           <a:xfrm>
-            <a:off x="5357812" y="1333500"/>
-            <a:ext cx="1866900" cy="1866900"/>
-          </a:xfrm>
-          <a:prstGeom prst="ellipse">
+            <a:off x="5181600" y="2190750"/>
+            <a:ext cx="2286000" cy="2286000"/>
+          </a:xfrm>
+          <a:prstGeom prst="rect">
             <a:avLst/>
           </a:prstGeom>
         </p:spPr>
       </p:pic>
       <p:sp>
         <p:nvSpPr>
-          <p:cNvPr id="8" name="TextBox 7"/>
+          <p:cNvPr id="10" name="Rectangle 9"/>
+          <p:cNvSpPr/>
+          <p:nvPr/>
+        </p:nvSpPr>
+        <p:spPr>
+          <a:xfrm>
+            <a:off x="5181600" y="4057650"/>
+            <a:ext cx="2286000" cy="419100"/>
+          </a:xfrm>
+          <a:prstGeom prst="rect">
+            <a:avLst/>
+          </a:prstGeom>
+          <a:solidFill>
+            <a:srgbClr val="F3F1EA">
+              <a:alpha val="88000"/>
+            </a:srgbClr>
+          </a:solidFill>
+          <a:ln>
+            <a:noFill/>
+          </a:ln>
+          <a:effectLst/>
+        </p:spPr>
+        <p:style>
+          <a:lnRef idx="1">
+            <a:schemeClr val="accent1"/>
+          </a:lnRef>
+          <a:fillRef idx="3">
+            <a:schemeClr val="accent1"/>
+          </a:fillRef>
+          <a:effectRef idx="2">
+            <a:schemeClr val="accent1"/>
+          </a:effectRef>
+          <a:fontRef idx="minor">
+            <a:schemeClr val="lt1"/>
+          </a:fontRef>
+        </p:style>
+        <p:txBody>
+          <a:bodyPr rtlCol="0" anchor="ctr"/>
+          <a:lstStyle/>
+          <a:p>
+            <a:pPr algn="ctr"/>
+          </a:p>
+        </p:txBody>
+      </p:sp>
+      <p:sp>
+        <p:nvSpPr>
+          <p:cNvPr id="11" name="TextBox 10"/>
           <p:cNvSpPr txBox="1"/>
           <p:nvPr/>
         </p:nvSpPr>
         <p:spPr>
           <a:xfrm>
-            <a:off x="5129212" y="3276600"/>
-            <a:ext cx="2324100" cy="285750"/>
+            <a:off x="5238750" y="4057650"/>
+            <a:ext cx="2171700" cy="419100"/>
           </a:xfrm>
           <a:prstGeom prst="rect">
             <a:avLst/>
@@ -3984,7 +4122,7 @@
           <a:noFill/>
         </p:spPr>
         <p:txBody>
-          <a:bodyPr wrap="square" lIns="0" rIns="0" tIns="0" bIns="0" anchor="t">
+          <a:bodyPr wrap="square" lIns="0" rIns="0" tIns="0" bIns="0" anchor="ctr">
             <a:spAutoFit/>
           </a:bodyPr>
           <a:lstStyle/>
@@ -3995,7 +4133,7 @@
               </a:lnSpc>
             </a:pPr>
             <a:r>
-              <a:rPr sz="1700" b="1" i="0">
+              <a:rPr sz="1500" b="1" i="0">
                 <a:solidFill>
                   <a:srgbClr val="31662F"/>
                 </a:solidFill>
@@ -4008,7 +4146,7 @@
       </p:sp>
       <p:pic>
         <p:nvPicPr>
-          <p:cNvPr id="9" name="Picture 8" descr="1629563765789288468.jpg"/>
+          <p:cNvPr id="12" name="Picture 11" descr="8080359357829165426.jpg"/>
           <p:cNvPicPr>
             <a:picLocks noChangeAspect="1"/>
           </p:cNvPicPr>
@@ -4022,24 +4160,70 @@
         </p:blipFill>
         <p:spPr>
           <a:xfrm>
-            <a:off x="7653337" y="1333500"/>
-            <a:ext cx="1866900" cy="1866900"/>
-          </a:xfrm>
-          <a:prstGeom prst="ellipse">
+            <a:off x="7543800" y="2190750"/>
+            <a:ext cx="2286000" cy="2286000"/>
+          </a:xfrm>
+          <a:prstGeom prst="rect">
             <a:avLst/>
           </a:prstGeom>
         </p:spPr>
       </p:pic>
       <p:sp>
         <p:nvSpPr>
-          <p:cNvPr id="10" name="TextBox 9"/>
+          <p:cNvPr id="13" name="Rectangle 12"/>
+          <p:cNvSpPr/>
+          <p:nvPr/>
+        </p:nvSpPr>
+        <p:spPr>
+          <a:xfrm>
+            <a:off x="7543800" y="4057650"/>
+            <a:ext cx="2286000" cy="419100"/>
+          </a:xfrm>
+          <a:prstGeom prst="rect">
+            <a:avLst/>
+          </a:prstGeom>
+          <a:solidFill>
+            <a:srgbClr val="F3F1EA">
+              <a:alpha val="88000"/>
+            </a:srgbClr>
+          </a:solidFill>
+          <a:ln>
+            <a:noFill/>
+          </a:ln>
+          <a:effectLst/>
+        </p:spPr>
+        <p:style>
+          <a:lnRef idx="1">
+            <a:schemeClr val="accent1"/>
+          </a:lnRef>
+          <a:fillRef idx="3">
+            <a:schemeClr val="accent1"/>
+          </a:fillRef>
+          <a:effectRef idx="2">
+            <a:schemeClr val="accent1"/>
+          </a:effectRef>
+          <a:fontRef idx="minor">
+            <a:schemeClr val="lt1"/>
+          </a:fontRef>
+        </p:style>
+        <p:txBody>
+          <a:bodyPr rtlCol="0" anchor="ctr"/>
+          <a:lstStyle/>
+          <a:p>
+            <a:pPr algn="ctr"/>
+          </a:p>
+        </p:txBody>
+      </p:sp>
+      <p:sp>
+        <p:nvSpPr>
+          <p:cNvPr id="14" name="TextBox 13"/>
           <p:cNvSpPr txBox="1"/>
           <p:nvPr/>
         </p:nvSpPr>
         <p:spPr>
           <a:xfrm>
-            <a:off x="7424737" y="3276600"/>
-            <a:ext cx="2324100" cy="285750"/>
+            <a:off x="7600950" y="4057650"/>
+            <a:ext cx="2171700" cy="419100"/>
           </a:xfrm>
           <a:prstGeom prst="rect">
             <a:avLst/>
@@ -4047,7 +4231,7 @@
           <a:noFill/>
         </p:spPr>
         <p:txBody>
-          <a:bodyPr wrap="square" lIns="0" rIns="0" tIns="0" bIns="0" anchor="t">
+          <a:bodyPr wrap="square" lIns="0" rIns="0" tIns="0" bIns="0" anchor="ctr">
             <a:spAutoFit/>
           </a:bodyPr>
           <a:lstStyle/>
@@ -4058,7 +4242,7 @@
               </a:lnSpc>
             </a:pPr>
             <a:r>
-              <a:rPr sz="1700" b="1" i="0">
+              <a:rPr sz="1500" b="1" i="0">
                 <a:solidFill>
                   <a:srgbClr val="31662F"/>
                 </a:solidFill>
@@ -4071,7 +4255,7 @@
       </p:sp>
       <p:pic>
         <p:nvPicPr>
-          <p:cNvPr id="11" name="Picture 10" descr="9111562122042412833.jpg"/>
+          <p:cNvPr id="15" name="Picture 14" descr="1974356426881197837.jpg"/>
           <p:cNvPicPr>
             <a:picLocks noChangeAspect="1"/>
           </p:cNvPicPr>
@@ -4085,24 +4269,70 @@
         </p:blipFill>
         <p:spPr>
           <a:xfrm>
-            <a:off x="766762" y="4095750"/>
-            <a:ext cx="1866900" cy="1866900"/>
-          </a:xfrm>
-          <a:prstGeom prst="ellipse">
+            <a:off x="457200" y="4552950"/>
+            <a:ext cx="2286000" cy="2286000"/>
+          </a:xfrm>
+          <a:prstGeom prst="rect">
             <a:avLst/>
           </a:prstGeom>
         </p:spPr>
       </p:pic>
       <p:sp>
         <p:nvSpPr>
-          <p:cNvPr id="12" name="TextBox 11"/>
+          <p:cNvPr id="16" name="Rectangle 15"/>
+          <p:cNvSpPr/>
+          <p:nvPr/>
+        </p:nvSpPr>
+        <p:spPr>
+          <a:xfrm>
+            <a:off x="457200" y="6419850"/>
+            <a:ext cx="2286000" cy="419100"/>
+          </a:xfrm>
+          <a:prstGeom prst="rect">
+            <a:avLst/>
+          </a:prstGeom>
+          <a:solidFill>
+            <a:srgbClr val="F3F1EA">
+              <a:alpha val="88000"/>
+            </a:srgbClr>
+          </a:solidFill>
+          <a:ln>
+            <a:noFill/>
+          </a:ln>
+          <a:effectLst/>
+        </p:spPr>
+        <p:style>
+          <a:lnRef idx="1">
+            <a:schemeClr val="accent1"/>
+          </a:lnRef>
+          <a:fillRef idx="3">
+            <a:schemeClr val="accent1"/>
+          </a:fillRef>
+          <a:effectRef idx="2">
+            <a:schemeClr val="accent1"/>
+          </a:effectRef>
+          <a:fontRef idx="minor">
+            <a:schemeClr val="lt1"/>
+          </a:fontRef>
+        </p:style>
+        <p:txBody>
+          <a:bodyPr rtlCol="0" anchor="ctr"/>
+          <a:lstStyle/>
+          <a:p>
+            <a:pPr algn="ctr"/>
+          </a:p>
+        </p:txBody>
+      </p:sp>
+      <p:sp>
+        <p:nvSpPr>
+          <p:cNvPr id="17" name="TextBox 16"/>
           <p:cNvSpPr txBox="1"/>
           <p:nvPr/>
         </p:nvSpPr>
         <p:spPr>
           <a:xfrm>
-            <a:off x="538162" y="6038850"/>
-            <a:ext cx="2324100" cy="285750"/>
+            <a:off x="514350" y="6419850"/>
+            <a:ext cx="2171700" cy="419100"/>
           </a:xfrm>
           <a:prstGeom prst="rect">
             <a:avLst/>
@@ -4110,7 +4340,7 @@
           <a:noFill/>
         </p:spPr>
         <p:txBody>
-          <a:bodyPr wrap="square" lIns="0" rIns="0" tIns="0" bIns="0" anchor="t">
+          <a:bodyPr wrap="square" lIns="0" rIns="0" tIns="0" bIns="0" anchor="ctr">
             <a:spAutoFit/>
           </a:bodyPr>
           <a:lstStyle/>
@@ -4121,7 +4351,7 @@
               </a:lnSpc>
             </a:pPr>
             <a:r>
-              <a:rPr sz="1700" b="1" i="0">
+              <a:rPr sz="1500" b="1" i="0">
                 <a:solidFill>
                   <a:srgbClr val="31662F"/>
                 </a:solidFill>
@@ -4134,7 +4364,7 @@
       </p:sp>
       <p:pic>
         <p:nvPicPr>
-          <p:cNvPr id="13" name="Picture 12" descr="339274882240709968.jpg"/>
+          <p:cNvPr id="18" name="Picture 17" descr="3027816981463207685.jpg"/>
           <p:cNvPicPr>
             <a:picLocks noChangeAspect="1"/>
           </p:cNvPicPr>
@@ -4148,24 +4378,70 @@
         </p:blipFill>
         <p:spPr>
           <a:xfrm>
-            <a:off x="3062287" y="4095750"/>
-            <a:ext cx="1866900" cy="1866900"/>
-          </a:xfrm>
-          <a:prstGeom prst="ellipse">
+            <a:off x="2819400" y="4552950"/>
+            <a:ext cx="2286000" cy="2286000"/>
+          </a:xfrm>
+          <a:prstGeom prst="rect">
             <a:avLst/>
           </a:prstGeom>
         </p:spPr>
       </p:pic>
       <p:sp>
         <p:nvSpPr>
-          <p:cNvPr id="14" name="TextBox 13"/>
+          <p:cNvPr id="19" name="Rectangle 18"/>
+          <p:cNvSpPr/>
+          <p:nvPr/>
+        </p:nvSpPr>
+        <p:spPr>
+          <a:xfrm>
+            <a:off x="2819400" y="6419850"/>
+            <a:ext cx="2286000" cy="419100"/>
+          </a:xfrm>
+          <a:prstGeom prst="rect">
+            <a:avLst/>
+          </a:prstGeom>
+          <a:solidFill>
+            <a:srgbClr val="F3F1EA">
+              <a:alpha val="88000"/>
+            </a:srgbClr>
+          </a:solidFill>
+          <a:ln>
+            <a:noFill/>
+          </a:ln>
+          <a:effectLst/>
+        </p:spPr>
+        <p:style>
+          <a:lnRef idx="1">
+            <a:schemeClr val="accent1"/>
+          </a:lnRef>
+          <a:fillRef idx="3">
+            <a:schemeClr val="accent1"/>
+          </a:fillRef>
+          <a:effectRef idx="2">
+            <a:schemeClr val="accent1"/>
+          </a:effectRef>
+          <a:fontRef idx="minor">
+            <a:schemeClr val="lt1"/>
+          </a:fontRef>
+        </p:style>
+        <p:txBody>
+          <a:bodyPr rtlCol="0" anchor="ctr"/>
+          <a:lstStyle/>
+          <a:p>
+            <a:pPr algn="ctr"/>
+          </a:p>
+        </p:txBody>
+      </p:sp>
+      <p:sp>
+        <p:nvSpPr>
+          <p:cNvPr id="20" name="TextBox 19"/>
           <p:cNvSpPr txBox="1"/>
           <p:nvPr/>
         </p:nvSpPr>
         <p:spPr>
           <a:xfrm>
-            <a:off x="2833687" y="6038850"/>
-            <a:ext cx="2324100" cy="285750"/>
+            <a:off x="2876550" y="6419850"/>
+            <a:ext cx="2171700" cy="419100"/>
           </a:xfrm>
           <a:prstGeom prst="rect">
             <a:avLst/>
@@ -4173,7 +4449,7 @@
           <a:noFill/>
         </p:spPr>
         <p:txBody>
-          <a:bodyPr wrap="square" lIns="0" rIns="0" tIns="0" bIns="0" anchor="t">
+          <a:bodyPr wrap="square" lIns="0" rIns="0" tIns="0" bIns="0" anchor="ctr">
             <a:spAutoFit/>
           </a:bodyPr>
           <a:lstStyle/>
@@ -4184,7 +4460,7 @@
               </a:lnSpc>
             </a:pPr>
             <a:r>
-              <a:rPr sz="1700" b="1" i="0">
+              <a:rPr sz="1500" b="1" i="0">
                 <a:solidFill>
                   <a:srgbClr val="31662F"/>
                 </a:solidFill>
@@ -4197,7 +4473,7 @@
       </p:sp>
       <p:pic>
         <p:nvPicPr>
-          <p:cNvPr id="15" name="Picture 14" descr="4772677272525312890.jpg"/>
+          <p:cNvPr id="21" name="Picture 20" descr="6422877592201863816.jpg"/>
           <p:cNvPicPr>
             <a:picLocks noChangeAspect="1"/>
           </p:cNvPicPr>
@@ -4211,24 +4487,70 @@
         </p:blipFill>
         <p:spPr>
           <a:xfrm>
-            <a:off x="5357812" y="4095750"/>
-            <a:ext cx="1866900" cy="1866900"/>
-          </a:xfrm>
-          <a:prstGeom prst="ellipse">
+            <a:off x="5181600" y="4552950"/>
+            <a:ext cx="2286000" cy="2286000"/>
+          </a:xfrm>
+          <a:prstGeom prst="rect">
             <a:avLst/>
           </a:prstGeom>
         </p:spPr>
       </p:pic>
       <p:sp>
         <p:nvSpPr>
-          <p:cNvPr id="16" name="TextBox 15"/>
+          <p:cNvPr id="22" name="Rectangle 21"/>
+          <p:cNvSpPr/>
+          <p:nvPr/>
+        </p:nvSpPr>
+        <p:spPr>
+          <a:xfrm>
+            <a:off x="5181600" y="6419850"/>
+            <a:ext cx="2286000" cy="419100"/>
+          </a:xfrm>
+          <a:prstGeom prst="rect">
+            <a:avLst/>
+          </a:prstGeom>
+          <a:solidFill>
+            <a:srgbClr val="F3F1EA">
+              <a:alpha val="88000"/>
+            </a:srgbClr>
+          </a:solidFill>
+          <a:ln>
+            <a:noFill/>
+          </a:ln>
+          <a:effectLst/>
+        </p:spPr>
+        <p:style>
+          <a:lnRef idx="1">
+            <a:schemeClr val="accent1"/>
+          </a:lnRef>
+          <a:fillRef idx="3">
+            <a:schemeClr val="accent1"/>
+          </a:fillRef>
+          <a:effectRef idx="2">
+            <a:schemeClr val="accent1"/>
+          </a:effectRef>
+          <a:fontRef idx="minor">
+            <a:schemeClr val="lt1"/>
+          </a:fontRef>
+        </p:style>
+        <p:txBody>
+          <a:bodyPr rtlCol="0" anchor="ctr"/>
+          <a:lstStyle/>
+          <a:p>
+            <a:pPr algn="ctr"/>
+          </a:p>
+        </p:txBody>
+      </p:sp>
+      <p:sp>
+        <p:nvSpPr>
+          <p:cNvPr id="23" name="TextBox 22"/>
           <p:cNvSpPr txBox="1"/>
           <p:nvPr/>
         </p:nvSpPr>
         <p:spPr>
           <a:xfrm>
-            <a:off x="5129212" y="6038850"/>
-            <a:ext cx="2324100" cy="285750"/>
+            <a:off x="5238750" y="6419850"/>
+            <a:ext cx="2171700" cy="419100"/>
           </a:xfrm>
           <a:prstGeom prst="rect">
             <a:avLst/>
@@ -4236,7 +4558,7 @@
           <a:noFill/>
         </p:spPr>
         <p:txBody>
-          <a:bodyPr wrap="square" lIns="0" rIns="0" tIns="0" bIns="0" anchor="t">
+          <a:bodyPr wrap="square" lIns="0" rIns="0" tIns="0" bIns="0" anchor="ctr">
             <a:spAutoFit/>
           </a:bodyPr>
           <a:lstStyle/>
@@ -4247,7 +4569,7 @@
               </a:lnSpc>
             </a:pPr>
             <a:r>
-              <a:rPr sz="1700" b="1" i="0">
+              <a:rPr sz="1500" b="1" i="0">
                 <a:solidFill>
                   <a:srgbClr val="31662F"/>
                 </a:solidFill>
@@ -4260,7 +4582,7 @@
       </p:sp>
       <p:pic>
         <p:nvPicPr>
-          <p:cNvPr id="17" name="Picture 16" descr="3383119350479155580.jpg"/>
+          <p:cNvPr id="24" name="Picture 23" descr="5196354255928742527.jpg"/>
           <p:cNvPicPr>
             <a:picLocks noChangeAspect="1"/>
           </p:cNvPicPr>
@@ -4274,24 +4596,70 @@
         </p:blipFill>
         <p:spPr>
           <a:xfrm>
-            <a:off x="7653337" y="4095750"/>
-            <a:ext cx="1866900" cy="1866900"/>
-          </a:xfrm>
-          <a:prstGeom prst="ellipse">
+            <a:off x="7543800" y="4552950"/>
+            <a:ext cx="2286000" cy="2286000"/>
+          </a:xfrm>
+          <a:prstGeom prst="rect">
             <a:avLst/>
           </a:prstGeom>
         </p:spPr>
       </p:pic>
       <p:sp>
         <p:nvSpPr>
-          <p:cNvPr id="18" name="TextBox 17"/>
+          <p:cNvPr id="25" name="Rectangle 24"/>
+          <p:cNvSpPr/>
+          <p:nvPr/>
+        </p:nvSpPr>
+        <p:spPr>
+          <a:xfrm>
+            <a:off x="7543800" y="6419850"/>
+            <a:ext cx="2286000" cy="419100"/>
+          </a:xfrm>
+          <a:prstGeom prst="rect">
+            <a:avLst/>
+          </a:prstGeom>
+          <a:solidFill>
+            <a:srgbClr val="F3F1EA">
+              <a:alpha val="88000"/>
+            </a:srgbClr>
+          </a:solidFill>
+          <a:ln>
+            <a:noFill/>
+          </a:ln>
+          <a:effectLst/>
+        </p:spPr>
+        <p:style>
+          <a:lnRef idx="1">
+            <a:schemeClr val="accent1"/>
+          </a:lnRef>
+          <a:fillRef idx="3">
+            <a:schemeClr val="accent1"/>
+          </a:fillRef>
+          <a:effectRef idx="2">
+            <a:schemeClr val="accent1"/>
+          </a:effectRef>
+          <a:fontRef idx="minor">
+            <a:schemeClr val="lt1"/>
+          </a:fontRef>
+        </p:style>
+        <p:txBody>
+          <a:bodyPr rtlCol="0" anchor="ctr"/>
+          <a:lstStyle/>
+          <a:p>
+            <a:pPr algn="ctr"/>
+          </a:p>
+        </p:txBody>
+      </p:sp>
+      <p:sp>
+        <p:nvSpPr>
+          <p:cNvPr id="26" name="TextBox 25"/>
           <p:cNvSpPr txBox="1"/>
           <p:nvPr/>
         </p:nvSpPr>
         <p:spPr>
           <a:xfrm>
-            <a:off x="7424737" y="6038850"/>
-            <a:ext cx="2324100" cy="285750"/>
+            <a:off x="7600950" y="6419850"/>
+            <a:ext cx="2171700" cy="419100"/>
           </a:xfrm>
           <a:prstGeom prst="rect">
             <a:avLst/>
@@ -4299,7 +4667,7 @@
           <a:noFill/>
         </p:spPr>
         <p:txBody>
-          <a:bodyPr wrap="square" lIns="0" rIns="0" tIns="0" bIns="0" anchor="t">
+          <a:bodyPr wrap="square" lIns="0" rIns="0" tIns="0" bIns="0" anchor="ctr">
             <a:spAutoFit/>
           </a:bodyPr>
           <a:lstStyle/>
@@ -4310,7 +4678,7 @@
               </a:lnSpc>
             </a:pPr>
             <a:r>
-              <a:rPr sz="1700" b="1" i="0">
+              <a:rPr sz="1500" b="1" i="0">
                 <a:solidFill>
                   <a:srgbClr val="31662F"/>
                 </a:solidFill>
@@ -4323,7 +4691,7 @@
       </p:sp>
       <p:pic>
         <p:nvPicPr>
-          <p:cNvPr id="19" name="Picture 18" descr="766855067931099866.jpg"/>
+          <p:cNvPr id="27" name="Picture 26" descr="1839049045767413403.jpg"/>
           <p:cNvPicPr>
             <a:picLocks noChangeAspect="1"/>
           </p:cNvPicPr>
@@ -4337,24 +4705,70 @@
         </p:blipFill>
         <p:spPr>
           <a:xfrm>
-            <a:off x="766762" y="6858000"/>
-            <a:ext cx="1866900" cy="1866900"/>
-          </a:xfrm>
-          <a:prstGeom prst="ellipse">
+            <a:off x="457200" y="6915150"/>
+            <a:ext cx="2286000" cy="2286000"/>
+          </a:xfrm>
+          <a:prstGeom prst="rect">
             <a:avLst/>
           </a:prstGeom>
         </p:spPr>
       </p:pic>
       <p:sp>
         <p:nvSpPr>
-          <p:cNvPr id="20" name="TextBox 19"/>
+          <p:cNvPr id="28" name="Rectangle 27"/>
+          <p:cNvSpPr/>
+          <p:nvPr/>
+        </p:nvSpPr>
+        <p:spPr>
+          <a:xfrm>
+            <a:off x="457200" y="8782050"/>
+            <a:ext cx="2286000" cy="419100"/>
+          </a:xfrm>
+          <a:prstGeom prst="rect">
+            <a:avLst/>
+          </a:prstGeom>
+          <a:solidFill>
+            <a:srgbClr val="F3F1EA">
+              <a:alpha val="88000"/>
+            </a:srgbClr>
+          </a:solidFill>
+          <a:ln>
+            <a:noFill/>
+          </a:ln>
+          <a:effectLst/>
+        </p:spPr>
+        <p:style>
+          <a:lnRef idx="1">
+            <a:schemeClr val="accent1"/>
+          </a:lnRef>
+          <a:fillRef idx="3">
+            <a:schemeClr val="accent1"/>
+          </a:fillRef>
+          <a:effectRef idx="2">
+            <a:schemeClr val="accent1"/>
+          </a:effectRef>
+          <a:fontRef idx="minor">
+            <a:schemeClr val="lt1"/>
+          </a:fontRef>
+        </p:style>
+        <p:txBody>
+          <a:bodyPr rtlCol="0" anchor="ctr"/>
+          <a:lstStyle/>
+          <a:p>
+            <a:pPr algn="ctr"/>
+          </a:p>
+        </p:txBody>
+      </p:sp>
+      <p:sp>
+        <p:nvSpPr>
+          <p:cNvPr id="29" name="TextBox 28"/>
           <p:cNvSpPr txBox="1"/>
           <p:nvPr/>
         </p:nvSpPr>
         <p:spPr>
           <a:xfrm>
-            <a:off x="538162" y="8801100"/>
-            <a:ext cx="2324100" cy="285750"/>
+            <a:off x="514350" y="8782050"/>
+            <a:ext cx="2171700" cy="419100"/>
           </a:xfrm>
           <a:prstGeom prst="rect">
             <a:avLst/>
@@ -4362,7 +4776,7 @@
           <a:noFill/>
         </p:spPr>
         <p:txBody>
-          <a:bodyPr wrap="square" lIns="0" rIns="0" tIns="0" bIns="0" anchor="t">
+          <a:bodyPr wrap="square" lIns="0" rIns="0" tIns="0" bIns="0" anchor="ctr">
             <a:spAutoFit/>
           </a:bodyPr>
           <a:lstStyle/>
@@ -4373,7 +4787,7 @@
               </a:lnSpc>
             </a:pPr>
             <a:r>
-              <a:rPr sz="1700" b="1" i="0">
+              <a:rPr sz="1500" b="1" i="0">
                 <a:solidFill>
                   <a:srgbClr val="31662F"/>
                 </a:solidFill>
@@ -4386,7 +4800,7 @@
       </p:sp>
       <p:pic>
         <p:nvPicPr>
-          <p:cNvPr id="21" name="Picture 20" descr="59597630003372722.jpg"/>
+          <p:cNvPr id="30" name="Picture 29" descr="3635735852169036292.jpg"/>
           <p:cNvPicPr>
             <a:picLocks noChangeAspect="1"/>
           </p:cNvPicPr>
@@ -4400,24 +4814,70 @@
         </p:blipFill>
         <p:spPr>
           <a:xfrm>
-            <a:off x="3062287" y="6858000"/>
-            <a:ext cx="1866900" cy="1866900"/>
-          </a:xfrm>
-          <a:prstGeom prst="ellipse">
+            <a:off x="2819400" y="6915150"/>
+            <a:ext cx="2286000" cy="2286000"/>
+          </a:xfrm>
+          <a:prstGeom prst="rect">
             <a:avLst/>
           </a:prstGeom>
         </p:spPr>
       </p:pic>
       <p:sp>
         <p:nvSpPr>
-          <p:cNvPr id="22" name="TextBox 21"/>
+          <p:cNvPr id="31" name="Rectangle 30"/>
+          <p:cNvSpPr/>
+          <p:nvPr/>
+        </p:nvSpPr>
+        <p:spPr>
+          <a:xfrm>
+            <a:off x="2819400" y="8782050"/>
+            <a:ext cx="2286000" cy="419100"/>
+          </a:xfrm>
+          <a:prstGeom prst="rect">
+            <a:avLst/>
+          </a:prstGeom>
+          <a:solidFill>
+            <a:srgbClr val="F3F1EA">
+              <a:alpha val="88000"/>
+            </a:srgbClr>
+          </a:solidFill>
+          <a:ln>
+            <a:noFill/>
+          </a:ln>
+          <a:effectLst/>
+        </p:spPr>
+        <p:style>
+          <a:lnRef idx="1">
+            <a:schemeClr val="accent1"/>
+          </a:lnRef>
+          <a:fillRef idx="3">
+            <a:schemeClr val="accent1"/>
+          </a:fillRef>
+          <a:effectRef idx="2">
+            <a:schemeClr val="accent1"/>
+          </a:effectRef>
+          <a:fontRef idx="minor">
+            <a:schemeClr val="lt1"/>
+          </a:fontRef>
+        </p:style>
+        <p:txBody>
+          <a:bodyPr rtlCol="0" anchor="ctr"/>
+          <a:lstStyle/>
+          <a:p>
+            <a:pPr algn="ctr"/>
+          </a:p>
+        </p:txBody>
+      </p:sp>
+      <p:sp>
+        <p:nvSpPr>
+          <p:cNvPr id="32" name="TextBox 31"/>
           <p:cNvSpPr txBox="1"/>
           <p:nvPr/>
         </p:nvSpPr>
         <p:spPr>
           <a:xfrm>
-            <a:off x="2833687" y="8801100"/>
-            <a:ext cx="2324100" cy="285750"/>
+            <a:off x="2876550" y="8782050"/>
+            <a:ext cx="2171700" cy="419100"/>
           </a:xfrm>
           <a:prstGeom prst="rect">
             <a:avLst/>
@@ -4425,7 +4885,7 @@
           <a:noFill/>
         </p:spPr>
         <p:txBody>
-          <a:bodyPr wrap="square" lIns="0" rIns="0" tIns="0" bIns="0" anchor="t">
+          <a:bodyPr wrap="square" lIns="0" rIns="0" tIns="0" bIns="0" anchor="ctr">
             <a:spAutoFit/>
           </a:bodyPr>
           <a:lstStyle/>
@@ -4436,7 +4896,7 @@
               </a:lnSpc>
             </a:pPr>
             <a:r>
-              <a:rPr sz="1700" b="1" i="0">
+              <a:rPr sz="1500" b="1" i="0">
                 <a:solidFill>
                   <a:srgbClr val="31662F"/>
                 </a:solidFill>
@@ -4449,7 +4909,7 @@
       </p:sp>
       <p:pic>
         <p:nvPicPr>
-          <p:cNvPr id="23" name="Picture 22" descr="8518746688478688471.jpg"/>
+          <p:cNvPr id="33" name="Picture 32" descr="5747755529844054742.jpg"/>
           <p:cNvPicPr>
             <a:picLocks noChangeAspect="1"/>
           </p:cNvPicPr>
@@ -4463,24 +4923,70 @@
         </p:blipFill>
         <p:spPr>
           <a:xfrm>
-            <a:off x="5357812" y="6858000"/>
-            <a:ext cx="1866900" cy="1866900"/>
-          </a:xfrm>
-          <a:prstGeom prst="ellipse">
+            <a:off x="5181600" y="6915150"/>
+            <a:ext cx="2286000" cy="2286000"/>
+          </a:xfrm>
+          <a:prstGeom prst="rect">
             <a:avLst/>
           </a:prstGeom>
         </p:spPr>
       </p:pic>
       <p:sp>
         <p:nvSpPr>
-          <p:cNvPr id="24" name="TextBox 23"/>
+          <p:cNvPr id="34" name="Rectangle 33"/>
+          <p:cNvSpPr/>
+          <p:nvPr/>
+        </p:nvSpPr>
+        <p:spPr>
+          <a:xfrm>
+            <a:off x="5181600" y="8782050"/>
+            <a:ext cx="2286000" cy="419100"/>
+          </a:xfrm>
+          <a:prstGeom prst="rect">
+            <a:avLst/>
+          </a:prstGeom>
+          <a:solidFill>
+            <a:srgbClr val="F3F1EA">
+              <a:alpha val="88000"/>
+            </a:srgbClr>
+          </a:solidFill>
+          <a:ln>
+            <a:noFill/>
+          </a:ln>
+          <a:effectLst/>
+        </p:spPr>
+        <p:style>
+          <a:lnRef idx="1">
+            <a:schemeClr val="accent1"/>
+          </a:lnRef>
+          <a:fillRef idx="3">
+            <a:schemeClr val="accent1"/>
+          </a:fillRef>
+          <a:effectRef idx="2">
+            <a:schemeClr val="accent1"/>
+          </a:effectRef>
+          <a:fontRef idx="minor">
+            <a:schemeClr val="lt1"/>
+          </a:fontRef>
+        </p:style>
+        <p:txBody>
+          <a:bodyPr rtlCol="0" anchor="ctr"/>
+          <a:lstStyle/>
+          <a:p>
+            <a:pPr algn="ctr"/>
+          </a:p>
+        </p:txBody>
+      </p:sp>
+      <p:sp>
+        <p:nvSpPr>
+          <p:cNvPr id="35" name="TextBox 34"/>
           <p:cNvSpPr txBox="1"/>
           <p:nvPr/>
         </p:nvSpPr>
         <p:spPr>
           <a:xfrm>
-            <a:off x="5129212" y="8801100"/>
-            <a:ext cx="2324100" cy="285750"/>
+            <a:off x="5238750" y="8782050"/>
+            <a:ext cx="2171700" cy="419100"/>
           </a:xfrm>
           <a:prstGeom prst="rect">
             <a:avLst/>
@@ -4488,7 +4994,7 @@
           <a:noFill/>
         </p:spPr>
         <p:txBody>
-          <a:bodyPr wrap="square" lIns="0" rIns="0" tIns="0" bIns="0" anchor="t">
+          <a:bodyPr wrap="square" lIns="0" rIns="0" tIns="0" bIns="0" anchor="ctr">
             <a:spAutoFit/>
           </a:bodyPr>
           <a:lstStyle/>
@@ -4499,7 +5005,7 @@
               </a:lnSpc>
             </a:pPr>
             <a:r>
-              <a:rPr sz="1700" b="1" i="0">
+              <a:rPr sz="1500" b="1" i="0">
                 <a:solidFill>
                   <a:srgbClr val="31662F"/>
                 </a:solidFill>
@@ -4512,7 +5018,7 @@
       </p:sp>
       <p:pic>
         <p:nvPicPr>
-          <p:cNvPr id="25" name="Picture 24" descr="6918752048174684190.jpg"/>
+          <p:cNvPr id="36" name="Picture 35" descr="8399190351064505002.jpg"/>
           <p:cNvPicPr>
             <a:picLocks noChangeAspect="1"/>
           </p:cNvPicPr>
@@ -4526,24 +5032,70 @@
         </p:blipFill>
         <p:spPr>
           <a:xfrm>
-            <a:off x="7653337" y="6858000"/>
-            <a:ext cx="1866900" cy="1866900"/>
-          </a:xfrm>
-          <a:prstGeom prst="ellipse">
+            <a:off x="7543800" y="6915150"/>
+            <a:ext cx="2286000" cy="2286000"/>
+          </a:xfrm>
+          <a:prstGeom prst="rect">
             <a:avLst/>
           </a:prstGeom>
         </p:spPr>
       </p:pic>
       <p:sp>
         <p:nvSpPr>
-          <p:cNvPr id="26" name="TextBox 25"/>
+          <p:cNvPr id="37" name="Rectangle 36"/>
+          <p:cNvSpPr/>
+          <p:nvPr/>
+        </p:nvSpPr>
+        <p:spPr>
+          <a:xfrm>
+            <a:off x="7543800" y="8782050"/>
+            <a:ext cx="2286000" cy="419100"/>
+          </a:xfrm>
+          <a:prstGeom prst="rect">
+            <a:avLst/>
+          </a:prstGeom>
+          <a:solidFill>
+            <a:srgbClr val="F3F1EA">
+              <a:alpha val="88000"/>
+            </a:srgbClr>
+          </a:solidFill>
+          <a:ln>
+            <a:noFill/>
+          </a:ln>
+          <a:effectLst/>
+        </p:spPr>
+        <p:style>
+          <a:lnRef idx="1">
+            <a:schemeClr val="accent1"/>
+          </a:lnRef>
+          <a:fillRef idx="3">
+            <a:schemeClr val="accent1"/>
+          </a:fillRef>
+          <a:effectRef idx="2">
+            <a:schemeClr val="accent1"/>
+          </a:effectRef>
+          <a:fontRef idx="minor">
+            <a:schemeClr val="lt1"/>
+          </a:fontRef>
+        </p:style>
+        <p:txBody>
+          <a:bodyPr rtlCol="0" anchor="ctr"/>
+          <a:lstStyle/>
+          <a:p>
+            <a:pPr algn="ctr"/>
+          </a:p>
+        </p:txBody>
+      </p:sp>
+      <p:sp>
+        <p:nvSpPr>
+          <p:cNvPr id="38" name="TextBox 37"/>
           <p:cNvSpPr txBox="1"/>
           <p:nvPr/>
         </p:nvSpPr>
         <p:spPr>
           <a:xfrm>
-            <a:off x="7424737" y="8801100"/>
-            <a:ext cx="2324100" cy="285750"/>
+            <a:off x="7600950" y="8782050"/>
+            <a:ext cx="2171700" cy="419100"/>
           </a:xfrm>
           <a:prstGeom prst="rect">
             <a:avLst/>
@@ -4551,7 +5103,7 @@
           <a:noFill/>
         </p:spPr>
         <p:txBody>
-          <a:bodyPr wrap="square" lIns="0" rIns="0" tIns="0" bIns="0" anchor="t">
+          <a:bodyPr wrap="square" lIns="0" rIns="0" tIns="0" bIns="0" anchor="ctr">
             <a:spAutoFit/>
           </a:bodyPr>
           <a:lstStyle/>
@@ -4562,7 +5114,7 @@
               </a:lnSpc>
             </a:pPr>
             <a:r>
-              <a:rPr sz="1700" b="1" i="0">
+              <a:rPr sz="1500" b="1" i="0">
                 <a:solidFill>
                   <a:srgbClr val="31662F"/>
                 </a:solidFill>
@@ -4575,7 +5127,7 @@
       </p:sp>
       <p:pic>
         <p:nvPicPr>
-          <p:cNvPr id="27" name="Picture 26" descr="7053514400107174239.jpg"/>
+          <p:cNvPr id="39" name="Picture 38" descr="5842563647999390999.jpg"/>
           <p:cNvPicPr>
             <a:picLocks noChangeAspect="1"/>
           </p:cNvPicPr>
@@ -4589,24 +5141,70 @@
         </p:blipFill>
         <p:spPr>
           <a:xfrm>
-            <a:off x="3062287" y="9620250"/>
-            <a:ext cx="1866900" cy="1866900"/>
-          </a:xfrm>
-          <a:prstGeom prst="ellipse">
+            <a:off x="457200" y="9277350"/>
+            <a:ext cx="2286000" cy="2286000"/>
+          </a:xfrm>
+          <a:prstGeom prst="rect">
             <a:avLst/>
           </a:prstGeom>
         </p:spPr>
       </p:pic>
       <p:sp>
         <p:nvSpPr>
-          <p:cNvPr id="28" name="TextBox 27"/>
+          <p:cNvPr id="40" name="Rectangle 39"/>
+          <p:cNvSpPr/>
+          <p:nvPr/>
+        </p:nvSpPr>
+        <p:spPr>
+          <a:xfrm>
+            <a:off x="457200" y="11144250"/>
+            <a:ext cx="2286000" cy="419100"/>
+          </a:xfrm>
+          <a:prstGeom prst="rect">
+            <a:avLst/>
+          </a:prstGeom>
+          <a:solidFill>
+            <a:srgbClr val="F3F1EA">
+              <a:alpha val="88000"/>
+            </a:srgbClr>
+          </a:solidFill>
+          <a:ln>
+            <a:noFill/>
+          </a:ln>
+          <a:effectLst/>
+        </p:spPr>
+        <p:style>
+          <a:lnRef idx="1">
+            <a:schemeClr val="accent1"/>
+          </a:lnRef>
+          <a:fillRef idx="3">
+            <a:schemeClr val="accent1"/>
+          </a:fillRef>
+          <a:effectRef idx="2">
+            <a:schemeClr val="accent1"/>
+          </a:effectRef>
+          <a:fontRef idx="minor">
+            <a:schemeClr val="lt1"/>
+          </a:fontRef>
+        </p:style>
+        <p:txBody>
+          <a:bodyPr rtlCol="0" anchor="ctr"/>
+          <a:lstStyle/>
+          <a:p>
+            <a:pPr algn="ctr"/>
+          </a:p>
+        </p:txBody>
+      </p:sp>
+      <p:sp>
+        <p:nvSpPr>
+          <p:cNvPr id="41" name="TextBox 40"/>
           <p:cNvSpPr txBox="1"/>
           <p:nvPr/>
         </p:nvSpPr>
         <p:spPr>
           <a:xfrm>
-            <a:off x="2833687" y="11563350"/>
-            <a:ext cx="2324100" cy="285750"/>
+            <a:off x="514350" y="11144250"/>
+            <a:ext cx="2171700" cy="419100"/>
           </a:xfrm>
           <a:prstGeom prst="rect">
             <a:avLst/>
@@ -4614,7 +5212,7 @@
           <a:noFill/>
         </p:spPr>
         <p:txBody>
-          <a:bodyPr wrap="square" lIns="0" rIns="0" tIns="0" bIns="0" anchor="t">
+          <a:bodyPr wrap="square" lIns="0" rIns="0" tIns="0" bIns="0" anchor="ctr">
             <a:spAutoFit/>
           </a:bodyPr>
           <a:lstStyle/>
@@ -4625,7 +5223,7 @@
               </a:lnSpc>
             </a:pPr>
             <a:r>
-              <a:rPr sz="1700" b="1" i="0">
+              <a:rPr sz="1500" b="1" i="0">
                 <a:solidFill>
                   <a:srgbClr val="31662F"/>
                 </a:solidFill>
@@ -4638,7 +5236,7 @@
       </p:sp>
       <p:pic>
         <p:nvPicPr>
-          <p:cNvPr id="29" name="Picture 28" descr="5442690523363617394.jpg"/>
+          <p:cNvPr id="42" name="Picture 41" descr="1503839733146406453.jpg"/>
           <p:cNvPicPr>
             <a:picLocks noChangeAspect="1"/>
           </p:cNvPicPr>
@@ -4652,24 +5250,70 @@
         </p:blipFill>
         <p:spPr>
           <a:xfrm>
-            <a:off x="5357812" y="9620250"/>
-            <a:ext cx="1866900" cy="1866900"/>
-          </a:xfrm>
-          <a:prstGeom prst="ellipse">
+            <a:off x="2819400" y="9277350"/>
+            <a:ext cx="2286000" cy="2286000"/>
+          </a:xfrm>
+          <a:prstGeom prst="rect">
             <a:avLst/>
           </a:prstGeom>
         </p:spPr>
       </p:pic>
       <p:sp>
         <p:nvSpPr>
-          <p:cNvPr id="30" name="TextBox 29"/>
+          <p:cNvPr id="43" name="Rectangle 42"/>
+          <p:cNvSpPr/>
+          <p:nvPr/>
+        </p:nvSpPr>
+        <p:spPr>
+          <a:xfrm>
+            <a:off x="2819400" y="11144250"/>
+            <a:ext cx="2286000" cy="419100"/>
+          </a:xfrm>
+          <a:prstGeom prst="rect">
+            <a:avLst/>
+          </a:prstGeom>
+          <a:solidFill>
+            <a:srgbClr val="F3F1EA">
+              <a:alpha val="88000"/>
+            </a:srgbClr>
+          </a:solidFill>
+          <a:ln>
+            <a:noFill/>
+          </a:ln>
+          <a:effectLst/>
+        </p:spPr>
+        <p:style>
+          <a:lnRef idx="1">
+            <a:schemeClr val="accent1"/>
+          </a:lnRef>
+          <a:fillRef idx="3">
+            <a:schemeClr val="accent1"/>
+          </a:fillRef>
+          <a:effectRef idx="2">
+            <a:schemeClr val="accent1"/>
+          </a:effectRef>
+          <a:fontRef idx="minor">
+            <a:schemeClr val="lt1"/>
+          </a:fontRef>
+        </p:style>
+        <p:txBody>
+          <a:bodyPr rtlCol="0" anchor="ctr"/>
+          <a:lstStyle/>
+          <a:p>
+            <a:pPr algn="ctr"/>
+          </a:p>
+        </p:txBody>
+      </p:sp>
+      <p:sp>
+        <p:nvSpPr>
+          <p:cNvPr id="44" name="TextBox 43"/>
           <p:cNvSpPr txBox="1"/>
           <p:nvPr/>
         </p:nvSpPr>
         <p:spPr>
           <a:xfrm>
-            <a:off x="5129212" y="11563350"/>
-            <a:ext cx="2324100" cy="285750"/>
+            <a:off x="2876550" y="11144250"/>
+            <a:ext cx="2171700" cy="419100"/>
           </a:xfrm>
           <a:prstGeom prst="rect">
             <a:avLst/>
@@ -4677,7 +5321,7 @@
           <a:noFill/>
         </p:spPr>
         <p:txBody>
-          <a:bodyPr wrap="square" lIns="0" rIns="0" tIns="0" bIns="0" anchor="t">
+          <a:bodyPr wrap="square" lIns="0" rIns="0" tIns="0" bIns="0" anchor="ctr">
             <a:spAutoFit/>
           </a:bodyPr>
           <a:lstStyle/>
@@ -4688,7 +5332,7 @@
               </a:lnSpc>
             </a:pPr>
             <a:r>
-              <a:rPr sz="1700" b="1" i="0">
+              <a:rPr sz="1500" b="1" i="0">
                 <a:solidFill>
                   <a:srgbClr val="31662F"/>
                 </a:solidFill>
@@ -4701,7 +5345,158 @@
       </p:sp>
       <p:sp>
         <p:nvSpPr>
-          <p:cNvPr id="31" name="TextBox 30"/>
+          <p:cNvPr id="45" name="Rectangle 44"/>
+          <p:cNvSpPr/>
+          <p:nvPr/>
+        </p:nvSpPr>
+        <p:spPr>
+          <a:xfrm>
+            <a:off x="5181600" y="9277350"/>
+            <a:ext cx="2286000" cy="2286000"/>
+          </a:xfrm>
+          <a:prstGeom prst="rect">
+            <a:avLst/>
+          </a:prstGeom>
+          <a:solidFill>
+            <a:srgbClr val="31662F"/>
+          </a:solidFill>
+          <a:ln>
+            <a:noFill/>
+          </a:ln>
+          <a:effectLst/>
+        </p:spPr>
+        <p:style>
+          <a:lnRef idx="1">
+            <a:schemeClr val="accent1"/>
+          </a:lnRef>
+          <a:fillRef idx="3">
+            <a:schemeClr val="accent1"/>
+          </a:fillRef>
+          <a:effectRef idx="2">
+            <a:schemeClr val="accent1"/>
+          </a:effectRef>
+          <a:fontRef idx="minor">
+            <a:schemeClr val="lt1"/>
+          </a:fontRef>
+        </p:style>
+        <p:txBody>
+          <a:bodyPr rtlCol="0" anchor="ctr"/>
+          <a:lstStyle/>
+          <a:p>
+            <a:pPr algn="ctr"/>
+          </a:p>
+        </p:txBody>
+      </p:sp>
+      <p:sp>
+        <p:nvSpPr>
+          <p:cNvPr id="46" name="TextBox 45"/>
+          <p:cNvSpPr txBox="1"/>
+          <p:nvPr/>
+        </p:nvSpPr>
+        <p:spPr>
+          <a:xfrm>
+            <a:off x="5353050" y="9277350"/>
+            <a:ext cx="1943100" cy="2286000"/>
+          </a:xfrm>
+          <a:prstGeom prst="rect">
+            <a:avLst/>
+          </a:prstGeom>
+          <a:noFill/>
+        </p:spPr>
+        <p:txBody>
+          <a:bodyPr wrap="square" lIns="0" rIns="0" tIns="0" bIns="0" anchor="ctr">
+            <a:spAutoFit/>
+          </a:bodyPr>
+          <a:lstStyle/>
+          <a:p>
+            <a:pPr algn="ctr">
+              <a:lnSpc>
+                <a:spcPct val="105000"/>
+              </a:lnSpc>
+            </a:pPr>
+            <a:r>
+              <a:rPr sz="2400" b="1" i="0">
+                <a:solidFill>
+                  <a:srgbClr val="F3F1EA"/>
+                </a:solidFill>
+                <a:latin typeface="Montserrat"/>
+              </a:rPr>
+              <a:t>Thank you, mentors!</a:t>
+            </a:r>
+          </a:p>
+        </p:txBody>
+      </p:sp>
+      <p:sp>
+        <p:nvSpPr>
+          <p:cNvPr id="47" name="Rectangle 46"/>
+          <p:cNvSpPr/>
+          <p:nvPr/>
+        </p:nvSpPr>
+        <p:spPr>
+          <a:xfrm>
+            <a:off x="7543800" y="9277350"/>
+            <a:ext cx="2286000" cy="2286000"/>
+          </a:xfrm>
+          <a:prstGeom prst="rect">
+            <a:avLst/>
+          </a:prstGeom>
+          <a:solidFill>
+            <a:srgbClr val="C09D7F"/>
+          </a:solidFill>
+          <a:ln>
+            <a:noFill/>
+          </a:ln>
+          <a:effectLst/>
+        </p:spPr>
+        <p:style>
+          <a:lnRef idx="1">
+            <a:schemeClr val="accent1"/>
+          </a:lnRef>
+          <a:fillRef idx="3">
+            <a:schemeClr val="accent1"/>
+          </a:fillRef>
+          <a:effectRef idx="2">
+            <a:schemeClr val="accent1"/>
+          </a:effectRef>
+          <a:fontRef idx="minor">
+            <a:schemeClr val="lt1"/>
+          </a:fontRef>
+        </p:style>
+        <p:txBody>
+          <a:bodyPr rtlCol="0" anchor="ctr"/>
+          <a:lstStyle/>
+          <a:p>
+            <a:pPr algn="ctr"/>
+          </a:p>
+        </p:txBody>
+      </p:sp>
+      <p:pic>
+        <p:nvPicPr>
+          <p:cNvPr id="48" name="Picture 47" descr="foundation-logo-white.png"/>
+          <p:cNvPicPr>
+            <a:picLocks noChangeAspect="1"/>
+          </p:cNvPicPr>
+          <p:nvPr/>
+        </p:nvPicPr>
+        <p:blipFill>
+          <a:blip r:embed="rId17"/>
+          <a:stretch>
+            <a:fillRect/>
+          </a:stretch>
+        </p:blipFill>
+        <p:spPr>
+          <a:xfrm>
+            <a:off x="8020050" y="9820903"/>
+            <a:ext cx="1333500" cy="1198893"/>
+          </a:xfrm>
+          <a:prstGeom prst="rect">
+            <a:avLst/>
+          </a:prstGeom>
+        </p:spPr>
+      </p:pic>
+      <p:sp>
+        <p:nvSpPr>
+          <p:cNvPr id="49" name="TextBox 48"/>
           <p:cNvSpPr txBox="1"/>
           <p:nvPr/>
         </p:nvSpPr>

</xml_diff>

<commit_message>
World Teachers' Day: four mentors per slide (7 slides), no mentor faces on the covers
Co-Authored-By: Claude Opus 5.5 <noreply@anthropic.com>
Claude-Session: https://claude.ai/code/session_014HGzAbxBh54nuyJHG7tse8
</commit_message>
<xml_diff>
--- a/templates/posts/october/05-10-2026-mon-ig-teachers-day-option-1-photo.pptx
+++ b/templates/posts/october/05-10-2026-mon-ig-teachers-day-option-1-photo.pptx
@@ -3589,7 +3589,7 @@
       <p:grpSpPr/>
       <p:pic>
         <p:nvPicPr>
-          <p:cNvPr id="2" name="Picture 1" descr="6096515828490417451.jpg"/>
+          <p:cNvPr id="2" name="Picture 1" descr="2201132733023345264.jpg"/>
           <p:cNvPicPr>
             <a:picLocks noChangeAspect="1"/>
           </p:cNvPicPr>
@@ -3819,7 +3819,7 @@
       </p:sp>
       <p:pic>
         <p:nvPicPr>
-          <p:cNvPr id="3" name="Picture 2" descr="894524731619023401.jpg"/>
+          <p:cNvPr id="3" name="Picture 2" descr="2434527820232444417.jpg"/>
           <p:cNvPicPr>
             <a:picLocks noChangeAspect="1"/>
           </p:cNvPicPr>
@@ -3928,7 +3928,7 @@
       </p:sp>
       <p:pic>
         <p:nvPicPr>
-          <p:cNvPr id="6" name="Picture 5" descr="7427239733233723794.jpg"/>
+          <p:cNvPr id="6" name="Picture 5" descr="1000714845004509693.jpg"/>
           <p:cNvPicPr>
             <a:picLocks noChangeAspect="1"/>
           </p:cNvPicPr>
@@ -4037,7 +4037,7 @@
       </p:sp>
       <p:pic>
         <p:nvPicPr>
-          <p:cNvPr id="9" name="Picture 8" descr="6023360388099870640.jpg"/>
+          <p:cNvPr id="9" name="Picture 8" descr="4555583047526390395.jpg"/>
           <p:cNvPicPr>
             <a:picLocks noChangeAspect="1"/>
           </p:cNvPicPr>
@@ -4146,7 +4146,7 @@
       </p:sp>
       <p:pic>
         <p:nvPicPr>
-          <p:cNvPr id="12" name="Picture 11" descr="8080359357829165426.jpg"/>
+          <p:cNvPr id="12" name="Picture 11" descr="3404798177016875823.jpg"/>
           <p:cNvPicPr>
             <a:picLocks noChangeAspect="1"/>
           </p:cNvPicPr>
@@ -4255,7 +4255,7 @@
       </p:sp>
       <p:pic>
         <p:nvPicPr>
-          <p:cNvPr id="15" name="Picture 14" descr="1974356426881197837.jpg"/>
+          <p:cNvPr id="15" name="Picture 14" descr="2211596369159362971.jpg"/>
           <p:cNvPicPr>
             <a:picLocks noChangeAspect="1"/>
           </p:cNvPicPr>
@@ -4364,7 +4364,7 @@
       </p:sp>
       <p:pic>
         <p:nvPicPr>
-          <p:cNvPr id="18" name="Picture 17" descr="3027816981463207685.jpg"/>
+          <p:cNvPr id="18" name="Picture 17" descr="4958046341648927289.jpg"/>
           <p:cNvPicPr>
             <a:picLocks noChangeAspect="1"/>
           </p:cNvPicPr>
@@ -4473,7 +4473,7 @@
       </p:sp>
       <p:pic>
         <p:nvPicPr>
-          <p:cNvPr id="21" name="Picture 20" descr="6422877592201863816.jpg"/>
+          <p:cNvPr id="21" name="Picture 20" descr="8688420958633461341.jpg"/>
           <p:cNvPicPr>
             <a:picLocks noChangeAspect="1"/>
           </p:cNvPicPr>
@@ -4582,7 +4582,7 @@
       </p:sp>
       <p:pic>
         <p:nvPicPr>
-          <p:cNvPr id="24" name="Picture 23" descr="5196354255928742527.jpg"/>
+          <p:cNvPr id="24" name="Picture 23" descr="4546600180924043180.jpg"/>
           <p:cNvPicPr>
             <a:picLocks noChangeAspect="1"/>
           </p:cNvPicPr>
@@ -4691,7 +4691,7 @@
       </p:sp>
       <p:pic>
         <p:nvPicPr>
-          <p:cNvPr id="27" name="Picture 26" descr="1839049045767413403.jpg"/>
+          <p:cNvPr id="27" name="Picture 26" descr="1419517534166441101.jpg"/>
           <p:cNvPicPr>
             <a:picLocks noChangeAspect="1"/>
           </p:cNvPicPr>
@@ -4800,7 +4800,7 @@
       </p:sp>
       <p:pic>
         <p:nvPicPr>
-          <p:cNvPr id="30" name="Picture 29" descr="3635735852169036292.jpg"/>
+          <p:cNvPr id="30" name="Picture 29" descr="376603766941083699.jpg"/>
           <p:cNvPicPr>
             <a:picLocks noChangeAspect="1"/>
           </p:cNvPicPr>
@@ -4909,7 +4909,7 @@
       </p:sp>
       <p:pic>
         <p:nvPicPr>
-          <p:cNvPr id="33" name="Picture 32" descr="5747755529844054742.jpg"/>
+          <p:cNvPr id="33" name="Picture 32" descr="2247470644392744674.jpg"/>
           <p:cNvPicPr>
             <a:picLocks noChangeAspect="1"/>
           </p:cNvPicPr>
@@ -5018,7 +5018,7 @@
       </p:sp>
       <p:pic>
         <p:nvPicPr>
-          <p:cNvPr id="36" name="Picture 35" descr="8399190351064505002.jpg"/>
+          <p:cNvPr id="36" name="Picture 35" descr="9158947755014907440.jpg"/>
           <p:cNvPicPr>
             <a:picLocks noChangeAspect="1"/>
           </p:cNvPicPr>
@@ -5127,7 +5127,7 @@
       </p:sp>
       <p:pic>
         <p:nvPicPr>
-          <p:cNvPr id="39" name="Picture 38" descr="5842563647999390999.jpg"/>
+          <p:cNvPr id="39" name="Picture 38" descr="175810135765887123.jpg"/>
           <p:cNvPicPr>
             <a:picLocks noChangeAspect="1"/>
           </p:cNvPicPr>
@@ -5236,7 +5236,7 @@
       </p:sp>
       <p:pic>
         <p:nvPicPr>
-          <p:cNvPr id="42" name="Picture 41" descr="1503839733146406453.jpg"/>
+          <p:cNvPr id="42" name="Picture 41" descr="8454356666220585455.jpg"/>
           <p:cNvPicPr>
             <a:picLocks noChangeAspect="1"/>
           </p:cNvPicPr>

</xml_diff>

<commit_message>
Teachers' Day option 4: no filler squares, 4/4/3/3 mentors, staggered grid, plain closing slide
Co-Authored-By: Claude Opus 5.5 <noreply@anthropic.com>
Claude-Session: https://claude.ai/code/session_014HGzAbxBh54nuyJHG7tse8
</commit_message>
<xml_diff>
--- a/templates/posts/october/05-10-2026-mon-ig-teachers-day-option-1-photo.pptx
+++ b/templates/posts/october/05-10-2026-mon-ig-teachers-day-option-1-photo.pptx
@@ -3589,7 +3589,7 @@
       <p:grpSpPr/>
       <p:pic>
         <p:nvPicPr>
-          <p:cNvPr id="2" name="Picture 1" descr="2201132733023345264.jpg"/>
+          <p:cNvPr id="2" name="Picture 1" descr="6410525844330123788.jpg"/>
           <p:cNvPicPr>
             <a:picLocks noChangeAspect="1"/>
           </p:cNvPicPr>
@@ -3819,7 +3819,7 @@
       </p:sp>
       <p:pic>
         <p:nvPicPr>
-          <p:cNvPr id="3" name="Picture 2" descr="2434527820232444417.jpg"/>
+          <p:cNvPr id="3" name="Picture 2" descr="2270990918217472394.jpg"/>
           <p:cNvPicPr>
             <a:picLocks noChangeAspect="1"/>
           </p:cNvPicPr>
@@ -3928,7 +3928,7 @@
       </p:sp>
       <p:pic>
         <p:nvPicPr>
-          <p:cNvPr id="6" name="Picture 5" descr="1000714845004509693.jpg"/>
+          <p:cNvPr id="6" name="Picture 5" descr="7392069005057952215.jpg"/>
           <p:cNvPicPr>
             <a:picLocks noChangeAspect="1"/>
           </p:cNvPicPr>
@@ -4037,7 +4037,7 @@
       </p:sp>
       <p:pic>
         <p:nvPicPr>
-          <p:cNvPr id="9" name="Picture 8" descr="4555583047526390395.jpg"/>
+          <p:cNvPr id="9" name="Picture 8" descr="2120264185869255123.jpg"/>
           <p:cNvPicPr>
             <a:picLocks noChangeAspect="1"/>
           </p:cNvPicPr>
@@ -4146,7 +4146,7 @@
       </p:sp>
       <p:pic>
         <p:nvPicPr>
-          <p:cNvPr id="12" name="Picture 11" descr="3404798177016875823.jpg"/>
+          <p:cNvPr id="12" name="Picture 11" descr="9218185789869299862.jpg"/>
           <p:cNvPicPr>
             <a:picLocks noChangeAspect="1"/>
           </p:cNvPicPr>
@@ -4255,7 +4255,7 @@
       </p:sp>
       <p:pic>
         <p:nvPicPr>
-          <p:cNvPr id="15" name="Picture 14" descr="2211596369159362971.jpg"/>
+          <p:cNvPr id="15" name="Picture 14" descr="764028230434961015.jpg"/>
           <p:cNvPicPr>
             <a:picLocks noChangeAspect="1"/>
           </p:cNvPicPr>
@@ -4269,7 +4269,7 @@
         </p:blipFill>
         <p:spPr>
           <a:xfrm>
-            <a:off x="457200" y="4552950"/>
+            <a:off x="1638300" y="4552950"/>
             <a:ext cx="2286000" cy="2286000"/>
           </a:xfrm>
           <a:prstGeom prst="rect">
@@ -4285,7 +4285,7 @@
         </p:nvSpPr>
         <p:spPr>
           <a:xfrm>
-            <a:off x="457200" y="6419850"/>
+            <a:off x="1638300" y="6419850"/>
             <a:ext cx="2286000" cy="419100"/>
           </a:xfrm>
           <a:prstGeom prst="rect">
@@ -4331,7 +4331,7 @@
         </p:nvSpPr>
         <p:spPr>
           <a:xfrm>
-            <a:off x="514350" y="6419850"/>
+            <a:off x="1695450" y="6419850"/>
             <a:ext cx="2171700" cy="419100"/>
           </a:xfrm>
           <a:prstGeom prst="rect">
@@ -4364,7 +4364,7 @@
       </p:sp>
       <p:pic>
         <p:nvPicPr>
-          <p:cNvPr id="18" name="Picture 17" descr="4958046341648927289.jpg"/>
+          <p:cNvPr id="18" name="Picture 17" descr="3872467728124968485.jpg"/>
           <p:cNvPicPr>
             <a:picLocks noChangeAspect="1"/>
           </p:cNvPicPr>
@@ -4378,7 +4378,7 @@
         </p:blipFill>
         <p:spPr>
           <a:xfrm>
-            <a:off x="2819400" y="4552950"/>
+            <a:off x="4000500" y="4552950"/>
             <a:ext cx="2286000" cy="2286000"/>
           </a:xfrm>
           <a:prstGeom prst="rect">
@@ -4394,7 +4394,7 @@
         </p:nvSpPr>
         <p:spPr>
           <a:xfrm>
-            <a:off x="2819400" y="6419850"/>
+            <a:off x="4000500" y="6419850"/>
             <a:ext cx="2286000" cy="419100"/>
           </a:xfrm>
           <a:prstGeom prst="rect">
@@ -4440,7 +4440,7 @@
         </p:nvSpPr>
         <p:spPr>
           <a:xfrm>
-            <a:off x="2876550" y="6419850"/>
+            <a:off x="4057650" y="6419850"/>
             <a:ext cx="2171700" cy="419100"/>
           </a:xfrm>
           <a:prstGeom prst="rect">
@@ -4473,7 +4473,7 @@
       </p:sp>
       <p:pic>
         <p:nvPicPr>
-          <p:cNvPr id="21" name="Picture 20" descr="8688420958633461341.jpg"/>
+          <p:cNvPr id="21" name="Picture 20" descr="7768563020045296748.jpg"/>
           <p:cNvPicPr>
             <a:picLocks noChangeAspect="1"/>
           </p:cNvPicPr>
@@ -4487,7 +4487,7 @@
         </p:blipFill>
         <p:spPr>
           <a:xfrm>
-            <a:off x="5181600" y="4552950"/>
+            <a:off x="6362700" y="4552950"/>
             <a:ext cx="2286000" cy="2286000"/>
           </a:xfrm>
           <a:prstGeom prst="rect">
@@ -4503,7 +4503,7 @@
         </p:nvSpPr>
         <p:spPr>
           <a:xfrm>
-            <a:off x="5181600" y="6419850"/>
+            <a:off x="6362700" y="6419850"/>
             <a:ext cx="2286000" cy="419100"/>
           </a:xfrm>
           <a:prstGeom prst="rect">
@@ -4549,7 +4549,7 @@
         </p:nvSpPr>
         <p:spPr>
           <a:xfrm>
-            <a:off x="5238750" y="6419850"/>
+            <a:off x="6419850" y="6419850"/>
             <a:ext cx="2171700" cy="419100"/>
           </a:xfrm>
           <a:prstGeom prst="rect">
@@ -4582,7 +4582,7 @@
       </p:sp>
       <p:pic>
         <p:nvPicPr>
-          <p:cNvPr id="24" name="Picture 23" descr="4546600180924043180.jpg"/>
+          <p:cNvPr id="24" name="Picture 23" descr="188478169412812041.jpg"/>
           <p:cNvPicPr>
             <a:picLocks noChangeAspect="1"/>
           </p:cNvPicPr>
@@ -4596,7 +4596,7 @@
         </p:blipFill>
         <p:spPr>
           <a:xfrm>
-            <a:off x="7543800" y="4552950"/>
+            <a:off x="457200" y="6915150"/>
             <a:ext cx="2286000" cy="2286000"/>
           </a:xfrm>
           <a:prstGeom prst="rect">
@@ -4612,7 +4612,7 @@
         </p:nvSpPr>
         <p:spPr>
           <a:xfrm>
-            <a:off x="7543800" y="6419850"/>
+            <a:off x="457200" y="8782050"/>
             <a:ext cx="2286000" cy="419100"/>
           </a:xfrm>
           <a:prstGeom prst="rect">
@@ -4658,7 +4658,7 @@
         </p:nvSpPr>
         <p:spPr>
           <a:xfrm>
-            <a:off x="7600950" y="6419850"/>
+            <a:off x="514350" y="8782050"/>
             <a:ext cx="2171700" cy="419100"/>
           </a:xfrm>
           <a:prstGeom prst="rect">
@@ -4691,7 +4691,7 @@
       </p:sp>
       <p:pic>
         <p:nvPicPr>
-          <p:cNvPr id="27" name="Picture 26" descr="1419517534166441101.jpg"/>
+          <p:cNvPr id="27" name="Picture 26" descr="7285083055156648169.jpg"/>
           <p:cNvPicPr>
             <a:picLocks noChangeAspect="1"/>
           </p:cNvPicPr>
@@ -4705,7 +4705,7 @@
         </p:blipFill>
         <p:spPr>
           <a:xfrm>
-            <a:off x="457200" y="6915150"/>
+            <a:off x="2819400" y="6915150"/>
             <a:ext cx="2286000" cy="2286000"/>
           </a:xfrm>
           <a:prstGeom prst="rect">
@@ -4721,7 +4721,7 @@
         </p:nvSpPr>
         <p:spPr>
           <a:xfrm>
-            <a:off x="457200" y="8782050"/>
+            <a:off x="2819400" y="8782050"/>
             <a:ext cx="2286000" cy="419100"/>
           </a:xfrm>
           <a:prstGeom prst="rect">
@@ -4767,7 +4767,7 @@
         </p:nvSpPr>
         <p:spPr>
           <a:xfrm>
-            <a:off x="514350" y="8782050"/>
+            <a:off x="2876550" y="8782050"/>
             <a:ext cx="2171700" cy="419100"/>
           </a:xfrm>
           <a:prstGeom prst="rect">
@@ -4800,7 +4800,7 @@
       </p:sp>
       <p:pic>
         <p:nvPicPr>
-          <p:cNvPr id="30" name="Picture 29" descr="376603766941083699.jpg"/>
+          <p:cNvPr id="30" name="Picture 29" descr="3298387358523767450.jpg"/>
           <p:cNvPicPr>
             <a:picLocks noChangeAspect="1"/>
           </p:cNvPicPr>
@@ -4814,7 +4814,7 @@
         </p:blipFill>
         <p:spPr>
           <a:xfrm>
-            <a:off x="2819400" y="6915150"/>
+            <a:off x="5181600" y="6915150"/>
             <a:ext cx="2286000" cy="2286000"/>
           </a:xfrm>
           <a:prstGeom prst="rect">
@@ -4830,7 +4830,7 @@
         </p:nvSpPr>
         <p:spPr>
           <a:xfrm>
-            <a:off x="2819400" y="8782050"/>
+            <a:off x="5181600" y="8782050"/>
             <a:ext cx="2286000" cy="419100"/>
           </a:xfrm>
           <a:prstGeom prst="rect">
@@ -4876,7 +4876,7 @@
         </p:nvSpPr>
         <p:spPr>
           <a:xfrm>
-            <a:off x="2876550" y="8782050"/>
+            <a:off x="5238750" y="8782050"/>
             <a:ext cx="2171700" cy="419100"/>
           </a:xfrm>
           <a:prstGeom prst="rect">
@@ -4909,7 +4909,7 @@
       </p:sp>
       <p:pic>
         <p:nvPicPr>
-          <p:cNvPr id="33" name="Picture 32" descr="2247470644392744674.jpg"/>
+          <p:cNvPr id="33" name="Picture 32" descr="2984603724377360682.jpg"/>
           <p:cNvPicPr>
             <a:picLocks noChangeAspect="1"/>
           </p:cNvPicPr>
@@ -4923,7 +4923,7 @@
         </p:blipFill>
         <p:spPr>
           <a:xfrm>
-            <a:off x="5181600" y="6915150"/>
+            <a:off x="7543800" y="6915150"/>
             <a:ext cx="2286000" cy="2286000"/>
           </a:xfrm>
           <a:prstGeom prst="rect">
@@ -4939,7 +4939,7 @@
         </p:nvSpPr>
         <p:spPr>
           <a:xfrm>
-            <a:off x="5181600" y="8782050"/>
+            <a:off x="7543800" y="8782050"/>
             <a:ext cx="2286000" cy="419100"/>
           </a:xfrm>
           <a:prstGeom prst="rect">
@@ -4985,7 +4985,7 @@
         </p:nvSpPr>
         <p:spPr>
           <a:xfrm>
-            <a:off x="5238750" y="8782050"/>
+            <a:off x="7600950" y="8782050"/>
             <a:ext cx="2171700" cy="419100"/>
           </a:xfrm>
           <a:prstGeom prst="rect">
@@ -5018,7 +5018,7 @@
       </p:sp>
       <p:pic>
         <p:nvPicPr>
-          <p:cNvPr id="36" name="Picture 35" descr="9158947755014907440.jpg"/>
+          <p:cNvPr id="36" name="Picture 35" descr="3815489264604009436.jpg"/>
           <p:cNvPicPr>
             <a:picLocks noChangeAspect="1"/>
           </p:cNvPicPr>
@@ -5032,7 +5032,7 @@
         </p:blipFill>
         <p:spPr>
           <a:xfrm>
-            <a:off x="7543800" y="6915150"/>
+            <a:off x="1638300" y="9277350"/>
             <a:ext cx="2286000" cy="2286000"/>
           </a:xfrm>
           <a:prstGeom prst="rect">
@@ -5048,7 +5048,7 @@
         </p:nvSpPr>
         <p:spPr>
           <a:xfrm>
-            <a:off x="7543800" y="8782050"/>
+            <a:off x="1638300" y="11144250"/>
             <a:ext cx="2286000" cy="419100"/>
           </a:xfrm>
           <a:prstGeom prst="rect">
@@ -5094,7 +5094,7 @@
         </p:nvSpPr>
         <p:spPr>
           <a:xfrm>
-            <a:off x="7600950" y="8782050"/>
+            <a:off x="1695450" y="11144250"/>
             <a:ext cx="2171700" cy="419100"/>
           </a:xfrm>
           <a:prstGeom prst="rect">
@@ -5127,7 +5127,7 @@
       </p:sp>
       <p:pic>
         <p:nvPicPr>
-          <p:cNvPr id="39" name="Picture 38" descr="175810135765887123.jpg"/>
+          <p:cNvPr id="39" name="Picture 38" descr="6333570285111628965.jpg"/>
           <p:cNvPicPr>
             <a:picLocks noChangeAspect="1"/>
           </p:cNvPicPr>
@@ -5141,7 +5141,7 @@
         </p:blipFill>
         <p:spPr>
           <a:xfrm>
-            <a:off x="457200" y="9277350"/>
+            <a:off x="4000500" y="9277350"/>
             <a:ext cx="2286000" cy="2286000"/>
           </a:xfrm>
           <a:prstGeom prst="rect">
@@ -5157,7 +5157,7 @@
         </p:nvSpPr>
         <p:spPr>
           <a:xfrm>
-            <a:off x="457200" y="11144250"/>
+            <a:off x="4000500" y="11144250"/>
             <a:ext cx="2286000" cy="419100"/>
           </a:xfrm>
           <a:prstGeom prst="rect">
@@ -5203,7 +5203,7 @@
         </p:nvSpPr>
         <p:spPr>
           <a:xfrm>
-            <a:off x="514350" y="11144250"/>
+            <a:off x="4057650" y="11144250"/>
             <a:ext cx="2171700" cy="419100"/>
           </a:xfrm>
           <a:prstGeom prst="rect">
@@ -5236,7 +5236,7 @@
       </p:sp>
       <p:pic>
         <p:nvPicPr>
-          <p:cNvPr id="42" name="Picture 41" descr="8454356666220585455.jpg"/>
+          <p:cNvPr id="42" name="Picture 41" descr="4832778074727187405.jpg"/>
           <p:cNvPicPr>
             <a:picLocks noChangeAspect="1"/>
           </p:cNvPicPr>
@@ -5250,7 +5250,7 @@
         </p:blipFill>
         <p:spPr>
           <a:xfrm>
-            <a:off x="2819400" y="9277350"/>
+            <a:off x="6362700" y="9277350"/>
             <a:ext cx="2286000" cy="2286000"/>
           </a:xfrm>
           <a:prstGeom prst="rect">
@@ -5266,7 +5266,7 @@
         </p:nvSpPr>
         <p:spPr>
           <a:xfrm>
-            <a:off x="2819400" y="11144250"/>
+            <a:off x="6362700" y="11144250"/>
             <a:ext cx="2286000" cy="419100"/>
           </a:xfrm>
           <a:prstGeom prst="rect">
@@ -5312,7 +5312,7 @@
         </p:nvSpPr>
         <p:spPr>
           <a:xfrm>
-            <a:off x="2876550" y="11144250"/>
+            <a:off x="6419850" y="11144250"/>
             <a:ext cx="2171700" cy="419100"/>
           </a:xfrm>
           <a:prstGeom prst="rect">
@@ -5345,158 +5345,7 @@
       </p:sp>
       <p:sp>
         <p:nvSpPr>
-          <p:cNvPr id="45" name="Rectangle 44"/>
-          <p:cNvSpPr/>
-          <p:nvPr/>
-        </p:nvSpPr>
-        <p:spPr>
-          <a:xfrm>
-            <a:off x="5181600" y="9277350"/>
-            <a:ext cx="2286000" cy="2286000"/>
-          </a:xfrm>
-          <a:prstGeom prst="rect">
-            <a:avLst/>
-          </a:prstGeom>
-          <a:solidFill>
-            <a:srgbClr val="31662F"/>
-          </a:solidFill>
-          <a:ln>
-            <a:noFill/>
-          </a:ln>
-          <a:effectLst/>
-        </p:spPr>
-        <p:style>
-          <a:lnRef idx="1">
-            <a:schemeClr val="accent1"/>
-          </a:lnRef>
-          <a:fillRef idx="3">
-            <a:schemeClr val="accent1"/>
-          </a:fillRef>
-          <a:effectRef idx="2">
-            <a:schemeClr val="accent1"/>
-          </a:effectRef>
-          <a:fontRef idx="minor">
-            <a:schemeClr val="lt1"/>
-          </a:fontRef>
-        </p:style>
-        <p:txBody>
-          <a:bodyPr rtlCol="0" anchor="ctr"/>
-          <a:lstStyle/>
-          <a:p>
-            <a:pPr algn="ctr"/>
-          </a:p>
-        </p:txBody>
-      </p:sp>
-      <p:sp>
-        <p:nvSpPr>
-          <p:cNvPr id="46" name="TextBox 45"/>
-          <p:cNvSpPr txBox="1"/>
-          <p:nvPr/>
-        </p:nvSpPr>
-        <p:spPr>
-          <a:xfrm>
-            <a:off x="5353050" y="9277350"/>
-            <a:ext cx="1943100" cy="2286000"/>
-          </a:xfrm>
-          <a:prstGeom prst="rect">
-            <a:avLst/>
-          </a:prstGeom>
-          <a:noFill/>
-        </p:spPr>
-        <p:txBody>
-          <a:bodyPr wrap="square" lIns="0" rIns="0" tIns="0" bIns="0" anchor="ctr">
-            <a:spAutoFit/>
-          </a:bodyPr>
-          <a:lstStyle/>
-          <a:p>
-            <a:pPr algn="ctr">
-              <a:lnSpc>
-                <a:spcPct val="105000"/>
-              </a:lnSpc>
-            </a:pPr>
-            <a:r>
-              <a:rPr sz="2400" b="1" i="0">
-                <a:solidFill>
-                  <a:srgbClr val="F3F1EA"/>
-                </a:solidFill>
-                <a:latin typeface="Montserrat"/>
-              </a:rPr>
-              <a:t>Thank you, mentors!</a:t>
-            </a:r>
-          </a:p>
-        </p:txBody>
-      </p:sp>
-      <p:sp>
-        <p:nvSpPr>
-          <p:cNvPr id="47" name="Rectangle 46"/>
-          <p:cNvSpPr/>
-          <p:nvPr/>
-        </p:nvSpPr>
-        <p:spPr>
-          <a:xfrm>
-            <a:off x="7543800" y="9277350"/>
-            <a:ext cx="2286000" cy="2286000"/>
-          </a:xfrm>
-          <a:prstGeom prst="rect">
-            <a:avLst/>
-          </a:prstGeom>
-          <a:solidFill>
-            <a:srgbClr val="C09D7F"/>
-          </a:solidFill>
-          <a:ln>
-            <a:noFill/>
-          </a:ln>
-          <a:effectLst/>
-        </p:spPr>
-        <p:style>
-          <a:lnRef idx="1">
-            <a:schemeClr val="accent1"/>
-          </a:lnRef>
-          <a:fillRef idx="3">
-            <a:schemeClr val="accent1"/>
-          </a:fillRef>
-          <a:effectRef idx="2">
-            <a:schemeClr val="accent1"/>
-          </a:effectRef>
-          <a:fontRef idx="minor">
-            <a:schemeClr val="lt1"/>
-          </a:fontRef>
-        </p:style>
-        <p:txBody>
-          <a:bodyPr rtlCol="0" anchor="ctr"/>
-          <a:lstStyle/>
-          <a:p>
-            <a:pPr algn="ctr"/>
-          </a:p>
-        </p:txBody>
-      </p:sp>
-      <p:pic>
-        <p:nvPicPr>
-          <p:cNvPr id="48" name="Picture 47" descr="foundation-logo-white.png"/>
-          <p:cNvPicPr>
-            <a:picLocks noChangeAspect="1"/>
-          </p:cNvPicPr>
-          <p:nvPr/>
-        </p:nvPicPr>
-        <p:blipFill>
-          <a:blip r:embed="rId17"/>
-          <a:stretch>
-            <a:fillRect/>
-          </a:stretch>
-        </p:blipFill>
-        <p:spPr>
-          <a:xfrm>
-            <a:off x="8020050" y="9820903"/>
-            <a:ext cx="1333500" cy="1198893"/>
-          </a:xfrm>
-          <a:prstGeom prst="rect">
-            <a:avLst/>
-          </a:prstGeom>
-        </p:spPr>
-      </p:pic>
-      <p:sp>
-        <p:nvSpPr>
-          <p:cNvPr id="49" name="TextBox 48"/>
+          <p:cNvPr id="45" name="TextBox 44"/>
           <p:cNvSpPr txBox="1"/>
           <p:nvPr/>
         </p:nvSpPr>

</xml_diff>

<commit_message>
Teachers' Day: 10 slides, two mentors per slide, every photo the same size, alphabetical
Co-Authored-By: Claude Opus 5.5 <noreply@anthropic.com>
Claude-Session: https://claude.ai/code/session_014HGzAbxBh54nuyJHG7tse8
</commit_message>
<xml_diff>
--- a/templates/posts/october/05-10-2026-mon-ig-teachers-day-option-1-photo.pptx
+++ b/templates/posts/october/05-10-2026-mon-ig-teachers-day-option-1-photo.pptx
@@ -3589,7 +3589,7 @@
       <p:grpSpPr/>
       <p:pic>
         <p:nvPicPr>
-          <p:cNvPr id="2" name="Picture 1" descr="6410525844330123788.jpg"/>
+          <p:cNvPr id="2" name="Picture 1" descr="6989278539617577273.jpg"/>
           <p:cNvPicPr>
             <a:picLocks noChangeAspect="1"/>
           </p:cNvPicPr>
@@ -3819,7 +3819,7 @@
       </p:sp>
       <p:pic>
         <p:nvPicPr>
-          <p:cNvPr id="3" name="Picture 2" descr="2270990918217472394.jpg"/>
+          <p:cNvPr id="3" name="Picture 2" descr="9036284228287914251.jpg"/>
           <p:cNvPicPr>
             <a:picLocks noChangeAspect="1"/>
           </p:cNvPicPr>
@@ -3928,7 +3928,7 @@
       </p:sp>
       <p:pic>
         <p:nvPicPr>
-          <p:cNvPr id="6" name="Picture 5" descr="7392069005057952215.jpg"/>
+          <p:cNvPr id="6" name="Picture 5" descr="7264490724320908151.jpg"/>
           <p:cNvPicPr>
             <a:picLocks noChangeAspect="1"/>
           </p:cNvPicPr>
@@ -4037,7 +4037,7 @@
       </p:sp>
       <p:pic>
         <p:nvPicPr>
-          <p:cNvPr id="9" name="Picture 8" descr="2120264185869255123.jpg"/>
+          <p:cNvPr id="9" name="Picture 8" descr="9106841745323230857.jpg"/>
           <p:cNvPicPr>
             <a:picLocks noChangeAspect="1"/>
           </p:cNvPicPr>
@@ -4146,7 +4146,7 @@
       </p:sp>
       <p:pic>
         <p:nvPicPr>
-          <p:cNvPr id="12" name="Picture 11" descr="9218185789869299862.jpg"/>
+          <p:cNvPr id="12" name="Picture 11" descr="6445759230204725191.jpg"/>
           <p:cNvPicPr>
             <a:picLocks noChangeAspect="1"/>
           </p:cNvPicPr>
@@ -4255,7 +4255,7 @@
       </p:sp>
       <p:pic>
         <p:nvPicPr>
-          <p:cNvPr id="15" name="Picture 14" descr="764028230434961015.jpg"/>
+          <p:cNvPr id="15" name="Picture 14" descr="8803819581641044895.jpg"/>
           <p:cNvPicPr>
             <a:picLocks noChangeAspect="1"/>
           </p:cNvPicPr>
@@ -4364,7 +4364,7 @@
       </p:sp>
       <p:pic>
         <p:nvPicPr>
-          <p:cNvPr id="18" name="Picture 17" descr="3872467728124968485.jpg"/>
+          <p:cNvPr id="18" name="Picture 17" descr="8536373804798833227.jpg"/>
           <p:cNvPicPr>
             <a:picLocks noChangeAspect="1"/>
           </p:cNvPicPr>
@@ -4473,7 +4473,7 @@
       </p:sp>
       <p:pic>
         <p:nvPicPr>
-          <p:cNvPr id="21" name="Picture 20" descr="7768563020045296748.jpg"/>
+          <p:cNvPr id="21" name="Picture 20" descr="8164580861635186193.jpg"/>
           <p:cNvPicPr>
             <a:picLocks noChangeAspect="1"/>
           </p:cNvPicPr>
@@ -4582,7 +4582,7 @@
       </p:sp>
       <p:pic>
         <p:nvPicPr>
-          <p:cNvPr id="24" name="Picture 23" descr="188478169412812041.jpg"/>
+          <p:cNvPr id="24" name="Picture 23" descr="2894971483344189381.jpg"/>
           <p:cNvPicPr>
             <a:picLocks noChangeAspect="1"/>
           </p:cNvPicPr>
@@ -4691,7 +4691,7 @@
       </p:sp>
       <p:pic>
         <p:nvPicPr>
-          <p:cNvPr id="27" name="Picture 26" descr="7285083055156648169.jpg"/>
+          <p:cNvPr id="27" name="Picture 26" descr="454656652608966177.jpg"/>
           <p:cNvPicPr>
             <a:picLocks noChangeAspect="1"/>
           </p:cNvPicPr>
@@ -4800,7 +4800,7 @@
       </p:sp>
       <p:pic>
         <p:nvPicPr>
-          <p:cNvPr id="30" name="Picture 29" descr="3298387358523767450.jpg"/>
+          <p:cNvPr id="30" name="Picture 29" descr="3512431765128565377.jpg"/>
           <p:cNvPicPr>
             <a:picLocks noChangeAspect="1"/>
           </p:cNvPicPr>
@@ -4909,7 +4909,7 @@
       </p:sp>
       <p:pic>
         <p:nvPicPr>
-          <p:cNvPr id="33" name="Picture 32" descr="2984603724377360682.jpg"/>
+          <p:cNvPr id="33" name="Picture 32" descr="9208379026975339746.jpg"/>
           <p:cNvPicPr>
             <a:picLocks noChangeAspect="1"/>
           </p:cNvPicPr>
@@ -5018,7 +5018,7 @@
       </p:sp>
       <p:pic>
         <p:nvPicPr>
-          <p:cNvPr id="36" name="Picture 35" descr="3815489264604009436.jpg"/>
+          <p:cNvPr id="36" name="Picture 35" descr="8672761161464777380.jpg"/>
           <p:cNvPicPr>
             <a:picLocks noChangeAspect="1"/>
           </p:cNvPicPr>
@@ -5127,7 +5127,7 @@
       </p:sp>
       <p:pic>
         <p:nvPicPr>
-          <p:cNvPr id="39" name="Picture 38" descr="6333570285111628965.jpg"/>
+          <p:cNvPr id="39" name="Picture 38" descr="3359842666902028946.jpg"/>
           <p:cNvPicPr>
             <a:picLocks noChangeAspect="1"/>
           </p:cNvPicPr>
@@ -5236,7 +5236,7 @@
       </p:sp>
       <p:pic>
         <p:nvPicPr>
-          <p:cNvPr id="42" name="Picture 41" descr="4832778074727187405.jpg"/>
+          <p:cNvPr id="42" name="Picture 41" descr="8025998113937040021.jpg"/>
           <p:cNvPicPr>
             <a:picLocks noChangeAspect="1"/>
           </p:cNvPicPr>

</xml_diff>

<commit_message>
Teachers' Day grid: regular 4-column grid, title in the first two cells, centred
Co-Authored-By: Claude Opus 5.5 <noreply@anthropic.com>
Claude-Session: https://claude.ai/code/session_014HGzAbxBh54nuyJHG7tse8
</commit_message>
<xml_diff>
--- a/templates/posts/october/05-10-2026-mon-ig-teachers-day-option-1-photo.pptx
+++ b/templates/posts/october/05-10-2026-mon-ig-teachers-day-option-1-photo.pptx
@@ -3589,7 +3589,7 @@
       <p:grpSpPr/>
       <p:pic>
         <p:nvPicPr>
-          <p:cNvPr id="2" name="Picture 1" descr="6989278539617577273.jpg"/>
+          <p:cNvPr id="2" name="Picture 1" descr="8851306644178481794.jpg"/>
           <p:cNvPicPr>
             <a:picLocks noChangeAspect="1"/>
           </p:cNvPicPr>
@@ -3817,9 +3817,48 @@
           </a:p>
         </p:txBody>
       </p:sp>
+      <p:sp>
+        <p:nvSpPr>
+          <p:cNvPr id="3" name="TextBox 2"/>
+          <p:cNvSpPr txBox="1"/>
+          <p:nvPr/>
+        </p:nvSpPr>
+        <p:spPr>
+          <a:xfrm>
+            <a:off x="495300" y="2190750"/>
+            <a:ext cx="4572000" cy="2286000"/>
+          </a:xfrm>
+          <a:prstGeom prst="rect">
+            <a:avLst/>
+          </a:prstGeom>
+          <a:noFill/>
+        </p:spPr>
+        <p:txBody>
+          <a:bodyPr wrap="square" lIns="0" rIns="0" tIns="0" bIns="0" anchor="ctr">
+            <a:spAutoFit/>
+          </a:bodyPr>
+          <a:lstStyle/>
+          <a:p>
+            <a:pPr algn="l">
+              <a:lnSpc>
+                <a:spcPct val="100000"/>
+              </a:lnSpc>
+            </a:pPr>
+            <a:r>
+              <a:rPr sz="4000" b="1" i="0">
+                <a:solidFill>
+                  <a:srgbClr val="31662F"/>
+                </a:solidFill>
+                <a:latin typeface="Montserrat"/>
+              </a:rPr>
+              <a:t>Happy World Teachers' Day</a:t>
+            </a:r>
+          </a:p>
+        </p:txBody>
+      </p:sp>
       <p:pic>
         <p:nvPicPr>
-          <p:cNvPr id="3" name="Picture 2" descr="9036284228287914251.jpg"/>
+          <p:cNvPr id="4" name="Picture 3" descr="4408951095294771185.jpg"/>
           <p:cNvPicPr>
             <a:picLocks noChangeAspect="1"/>
           </p:cNvPicPr>
@@ -3833,7 +3872,7 @@
         </p:blipFill>
         <p:spPr>
           <a:xfrm>
-            <a:off x="457200" y="2190750"/>
+            <a:off x="5181600" y="2190750"/>
             <a:ext cx="2286000" cy="2286000"/>
           </a:xfrm>
           <a:prstGeom prst="rect">
@@ -3843,13 +3882,13 @@
       </p:pic>
       <p:sp>
         <p:nvSpPr>
-          <p:cNvPr id="4" name="Rectangle 3"/>
+          <p:cNvPr id="5" name="Rectangle 4"/>
           <p:cNvSpPr/>
           <p:nvPr/>
         </p:nvSpPr>
         <p:spPr>
           <a:xfrm>
-            <a:off x="457200" y="4057650"/>
+            <a:off x="5181600" y="4057650"/>
             <a:ext cx="2286000" cy="419100"/>
           </a:xfrm>
           <a:prstGeom prst="rect">
@@ -3889,13 +3928,13 @@
       </p:sp>
       <p:sp>
         <p:nvSpPr>
-          <p:cNvPr id="5" name="TextBox 4"/>
+          <p:cNvPr id="6" name="TextBox 5"/>
           <p:cNvSpPr txBox="1"/>
           <p:nvPr/>
         </p:nvSpPr>
         <p:spPr>
           <a:xfrm>
-            <a:off x="514350" y="4057650"/>
+            <a:off x="5238750" y="4057650"/>
             <a:ext cx="2171700" cy="419100"/>
           </a:xfrm>
           <a:prstGeom prst="rect">
@@ -3928,7 +3967,7 @@
       </p:sp>
       <p:pic>
         <p:nvPicPr>
-          <p:cNvPr id="6" name="Picture 5" descr="7264490724320908151.jpg"/>
+          <p:cNvPr id="7" name="Picture 6" descr="2053480673178515544.jpg"/>
           <p:cNvPicPr>
             <a:picLocks noChangeAspect="1"/>
           </p:cNvPicPr>
@@ -3942,7 +3981,7 @@
         </p:blipFill>
         <p:spPr>
           <a:xfrm>
-            <a:off x="2819400" y="2190750"/>
+            <a:off x="7543800" y="2190750"/>
             <a:ext cx="2286000" cy="2286000"/>
           </a:xfrm>
           <a:prstGeom prst="rect">
@@ -3952,13 +3991,13 @@
       </p:pic>
       <p:sp>
         <p:nvSpPr>
-          <p:cNvPr id="7" name="Rectangle 6"/>
+          <p:cNvPr id="8" name="Rectangle 7"/>
           <p:cNvSpPr/>
           <p:nvPr/>
         </p:nvSpPr>
         <p:spPr>
           <a:xfrm>
-            <a:off x="2819400" y="4057650"/>
+            <a:off x="7543800" y="4057650"/>
             <a:ext cx="2286000" cy="419100"/>
           </a:xfrm>
           <a:prstGeom prst="rect">
@@ -3998,13 +4037,13 @@
       </p:sp>
       <p:sp>
         <p:nvSpPr>
-          <p:cNvPr id="8" name="TextBox 7"/>
+          <p:cNvPr id="9" name="TextBox 8"/>
           <p:cNvSpPr txBox="1"/>
           <p:nvPr/>
         </p:nvSpPr>
         <p:spPr>
           <a:xfrm>
-            <a:off x="2876550" y="4057650"/>
+            <a:off x="7600950" y="4057650"/>
             <a:ext cx="2171700" cy="419100"/>
           </a:xfrm>
           <a:prstGeom prst="rect">
@@ -4037,7 +4076,7 @@
       </p:sp>
       <p:pic>
         <p:nvPicPr>
-          <p:cNvPr id="9" name="Picture 8" descr="9106841745323230857.jpg"/>
+          <p:cNvPr id="10" name="Picture 9" descr="8526052707322937247.jpg"/>
           <p:cNvPicPr>
             <a:picLocks noChangeAspect="1"/>
           </p:cNvPicPr>
@@ -4051,7 +4090,7 @@
         </p:blipFill>
         <p:spPr>
           <a:xfrm>
-            <a:off x="5181600" y="2190750"/>
+            <a:off x="457200" y="4552950"/>
             <a:ext cx="2286000" cy="2286000"/>
           </a:xfrm>
           <a:prstGeom prst="rect">
@@ -4061,13 +4100,13 @@
       </p:pic>
       <p:sp>
         <p:nvSpPr>
-          <p:cNvPr id="10" name="Rectangle 9"/>
+          <p:cNvPr id="11" name="Rectangle 10"/>
           <p:cNvSpPr/>
           <p:nvPr/>
         </p:nvSpPr>
         <p:spPr>
           <a:xfrm>
-            <a:off x="5181600" y="4057650"/>
+            <a:off x="457200" y="6419850"/>
             <a:ext cx="2286000" cy="419100"/>
           </a:xfrm>
           <a:prstGeom prst="rect">
@@ -4107,13 +4146,13 @@
       </p:sp>
       <p:sp>
         <p:nvSpPr>
-          <p:cNvPr id="11" name="TextBox 10"/>
+          <p:cNvPr id="12" name="TextBox 11"/>
           <p:cNvSpPr txBox="1"/>
           <p:nvPr/>
         </p:nvSpPr>
         <p:spPr>
           <a:xfrm>
-            <a:off x="5238750" y="4057650"/>
+            <a:off x="514350" y="6419850"/>
             <a:ext cx="2171700" cy="419100"/>
           </a:xfrm>
           <a:prstGeom prst="rect">
@@ -4146,7 +4185,7 @@
       </p:sp>
       <p:pic>
         <p:nvPicPr>
-          <p:cNvPr id="12" name="Picture 11" descr="6445759230204725191.jpg"/>
+          <p:cNvPr id="13" name="Picture 12" descr="4463640484023020558.jpg"/>
           <p:cNvPicPr>
             <a:picLocks noChangeAspect="1"/>
           </p:cNvPicPr>
@@ -4160,7 +4199,7 @@
         </p:blipFill>
         <p:spPr>
           <a:xfrm>
-            <a:off x="7543800" y="2190750"/>
+            <a:off x="2819400" y="4552950"/>
             <a:ext cx="2286000" cy="2286000"/>
           </a:xfrm>
           <a:prstGeom prst="rect">
@@ -4170,13 +4209,13 @@
       </p:pic>
       <p:sp>
         <p:nvSpPr>
-          <p:cNvPr id="13" name="Rectangle 12"/>
+          <p:cNvPr id="14" name="Rectangle 13"/>
           <p:cNvSpPr/>
           <p:nvPr/>
         </p:nvSpPr>
         <p:spPr>
           <a:xfrm>
-            <a:off x="7543800" y="4057650"/>
+            <a:off x="2819400" y="6419850"/>
             <a:ext cx="2286000" cy="419100"/>
           </a:xfrm>
           <a:prstGeom prst="rect">
@@ -4216,13 +4255,13 @@
       </p:sp>
       <p:sp>
         <p:nvSpPr>
-          <p:cNvPr id="14" name="TextBox 13"/>
+          <p:cNvPr id="15" name="TextBox 14"/>
           <p:cNvSpPr txBox="1"/>
           <p:nvPr/>
         </p:nvSpPr>
         <p:spPr>
           <a:xfrm>
-            <a:off x="7600950" y="4057650"/>
+            <a:off x="2876550" y="6419850"/>
             <a:ext cx="2171700" cy="419100"/>
           </a:xfrm>
           <a:prstGeom prst="rect">
@@ -4255,7 +4294,7 @@
       </p:sp>
       <p:pic>
         <p:nvPicPr>
-          <p:cNvPr id="15" name="Picture 14" descr="8803819581641044895.jpg"/>
+          <p:cNvPr id="16" name="Picture 15" descr="2262292987271407235.jpg"/>
           <p:cNvPicPr>
             <a:picLocks noChangeAspect="1"/>
           </p:cNvPicPr>
@@ -4269,7 +4308,7 @@
         </p:blipFill>
         <p:spPr>
           <a:xfrm>
-            <a:off x="1638300" y="4552950"/>
+            <a:off x="5181600" y="4552950"/>
             <a:ext cx="2286000" cy="2286000"/>
           </a:xfrm>
           <a:prstGeom prst="rect">
@@ -4279,13 +4318,13 @@
       </p:pic>
       <p:sp>
         <p:nvSpPr>
-          <p:cNvPr id="16" name="Rectangle 15"/>
+          <p:cNvPr id="17" name="Rectangle 16"/>
           <p:cNvSpPr/>
           <p:nvPr/>
         </p:nvSpPr>
         <p:spPr>
           <a:xfrm>
-            <a:off x="1638300" y="6419850"/>
+            <a:off x="5181600" y="6419850"/>
             <a:ext cx="2286000" cy="419100"/>
           </a:xfrm>
           <a:prstGeom prst="rect">
@@ -4325,13 +4364,13 @@
       </p:sp>
       <p:sp>
         <p:nvSpPr>
-          <p:cNvPr id="17" name="TextBox 16"/>
+          <p:cNvPr id="18" name="TextBox 17"/>
           <p:cNvSpPr txBox="1"/>
           <p:nvPr/>
         </p:nvSpPr>
         <p:spPr>
           <a:xfrm>
-            <a:off x="1695450" y="6419850"/>
+            <a:off x="5238750" y="6419850"/>
             <a:ext cx="2171700" cy="419100"/>
           </a:xfrm>
           <a:prstGeom prst="rect">
@@ -4364,7 +4403,7 @@
       </p:sp>
       <p:pic>
         <p:nvPicPr>
-          <p:cNvPr id="18" name="Picture 17" descr="8536373804798833227.jpg"/>
+          <p:cNvPr id="19" name="Picture 18" descr="9013575186157804863.jpg"/>
           <p:cNvPicPr>
             <a:picLocks noChangeAspect="1"/>
           </p:cNvPicPr>
@@ -4378,7 +4417,7 @@
         </p:blipFill>
         <p:spPr>
           <a:xfrm>
-            <a:off x="4000500" y="4552950"/>
+            <a:off x="7543800" y="4552950"/>
             <a:ext cx="2286000" cy="2286000"/>
           </a:xfrm>
           <a:prstGeom prst="rect">
@@ -4388,13 +4427,13 @@
       </p:pic>
       <p:sp>
         <p:nvSpPr>
-          <p:cNvPr id="19" name="Rectangle 18"/>
+          <p:cNvPr id="20" name="Rectangle 19"/>
           <p:cNvSpPr/>
           <p:nvPr/>
         </p:nvSpPr>
         <p:spPr>
           <a:xfrm>
-            <a:off x="4000500" y="6419850"/>
+            <a:off x="7543800" y="6419850"/>
             <a:ext cx="2286000" cy="419100"/>
           </a:xfrm>
           <a:prstGeom prst="rect">
@@ -4434,13 +4473,13 @@
       </p:sp>
       <p:sp>
         <p:nvSpPr>
-          <p:cNvPr id="20" name="TextBox 19"/>
+          <p:cNvPr id="21" name="TextBox 20"/>
           <p:cNvSpPr txBox="1"/>
           <p:nvPr/>
         </p:nvSpPr>
         <p:spPr>
           <a:xfrm>
-            <a:off x="4057650" y="6419850"/>
+            <a:off x="7600950" y="6419850"/>
             <a:ext cx="2171700" cy="419100"/>
           </a:xfrm>
           <a:prstGeom prst="rect">
@@ -4473,7 +4512,7 @@
       </p:sp>
       <p:pic>
         <p:nvPicPr>
-          <p:cNvPr id="21" name="Picture 20" descr="8164580861635186193.jpg"/>
+          <p:cNvPr id="22" name="Picture 21" descr="5529725699895573590.jpg"/>
           <p:cNvPicPr>
             <a:picLocks noChangeAspect="1"/>
           </p:cNvPicPr>
@@ -4487,7 +4526,7 @@
         </p:blipFill>
         <p:spPr>
           <a:xfrm>
-            <a:off x="6362700" y="4552950"/>
+            <a:off x="457200" y="6915150"/>
             <a:ext cx="2286000" cy="2286000"/>
           </a:xfrm>
           <a:prstGeom prst="rect">
@@ -4497,13 +4536,13 @@
       </p:pic>
       <p:sp>
         <p:nvSpPr>
-          <p:cNvPr id="22" name="Rectangle 21"/>
+          <p:cNvPr id="23" name="Rectangle 22"/>
           <p:cNvSpPr/>
           <p:nvPr/>
         </p:nvSpPr>
         <p:spPr>
           <a:xfrm>
-            <a:off x="6362700" y="6419850"/>
+            <a:off x="457200" y="8782050"/>
             <a:ext cx="2286000" cy="419100"/>
           </a:xfrm>
           <a:prstGeom prst="rect">
@@ -4543,13 +4582,13 @@
       </p:sp>
       <p:sp>
         <p:nvSpPr>
-          <p:cNvPr id="23" name="TextBox 22"/>
+          <p:cNvPr id="24" name="TextBox 23"/>
           <p:cNvSpPr txBox="1"/>
           <p:nvPr/>
         </p:nvSpPr>
         <p:spPr>
           <a:xfrm>
-            <a:off x="6419850" y="6419850"/>
+            <a:off x="514350" y="8782050"/>
             <a:ext cx="2171700" cy="419100"/>
           </a:xfrm>
           <a:prstGeom prst="rect">
@@ -4582,7 +4621,7 @@
       </p:sp>
       <p:pic>
         <p:nvPicPr>
-          <p:cNvPr id="24" name="Picture 23" descr="2894971483344189381.jpg"/>
+          <p:cNvPr id="25" name="Picture 24" descr="2407624395823463407.jpg"/>
           <p:cNvPicPr>
             <a:picLocks noChangeAspect="1"/>
           </p:cNvPicPr>
@@ -4596,7 +4635,7 @@
         </p:blipFill>
         <p:spPr>
           <a:xfrm>
-            <a:off x="457200" y="6915150"/>
+            <a:off x="2819400" y="6915150"/>
             <a:ext cx="2286000" cy="2286000"/>
           </a:xfrm>
           <a:prstGeom prst="rect">
@@ -4606,13 +4645,13 @@
       </p:pic>
       <p:sp>
         <p:nvSpPr>
-          <p:cNvPr id="25" name="Rectangle 24"/>
+          <p:cNvPr id="26" name="Rectangle 25"/>
           <p:cNvSpPr/>
           <p:nvPr/>
         </p:nvSpPr>
         <p:spPr>
           <a:xfrm>
-            <a:off x="457200" y="8782050"/>
+            <a:off x="2819400" y="8782050"/>
             <a:ext cx="2286000" cy="419100"/>
           </a:xfrm>
           <a:prstGeom prst="rect">
@@ -4652,13 +4691,13 @@
       </p:sp>
       <p:sp>
         <p:nvSpPr>
-          <p:cNvPr id="26" name="TextBox 25"/>
+          <p:cNvPr id="27" name="TextBox 26"/>
           <p:cNvSpPr txBox="1"/>
           <p:nvPr/>
         </p:nvSpPr>
         <p:spPr>
           <a:xfrm>
-            <a:off x="514350" y="8782050"/>
+            <a:off x="2876550" y="8782050"/>
             <a:ext cx="2171700" cy="419100"/>
           </a:xfrm>
           <a:prstGeom prst="rect">
@@ -4691,7 +4730,7 @@
       </p:sp>
       <p:pic>
         <p:nvPicPr>
-          <p:cNvPr id="27" name="Picture 26" descr="454656652608966177.jpg"/>
+          <p:cNvPr id="28" name="Picture 27" descr="1164985834360799692.jpg"/>
           <p:cNvPicPr>
             <a:picLocks noChangeAspect="1"/>
           </p:cNvPicPr>
@@ -4705,7 +4744,7 @@
         </p:blipFill>
         <p:spPr>
           <a:xfrm>
-            <a:off x="2819400" y="6915150"/>
+            <a:off x="5181600" y="6915150"/>
             <a:ext cx="2286000" cy="2286000"/>
           </a:xfrm>
           <a:prstGeom prst="rect">
@@ -4715,13 +4754,13 @@
       </p:pic>
       <p:sp>
         <p:nvSpPr>
-          <p:cNvPr id="28" name="Rectangle 27"/>
+          <p:cNvPr id="29" name="Rectangle 28"/>
           <p:cNvSpPr/>
           <p:nvPr/>
         </p:nvSpPr>
         <p:spPr>
           <a:xfrm>
-            <a:off x="2819400" y="8782050"/>
+            <a:off x="5181600" y="8782050"/>
             <a:ext cx="2286000" cy="419100"/>
           </a:xfrm>
           <a:prstGeom prst="rect">
@@ -4761,13 +4800,13 @@
       </p:sp>
       <p:sp>
         <p:nvSpPr>
-          <p:cNvPr id="29" name="TextBox 28"/>
+          <p:cNvPr id="30" name="TextBox 29"/>
           <p:cNvSpPr txBox="1"/>
           <p:nvPr/>
         </p:nvSpPr>
         <p:spPr>
           <a:xfrm>
-            <a:off x="2876550" y="8782050"/>
+            <a:off x="5238750" y="8782050"/>
             <a:ext cx="2171700" cy="419100"/>
           </a:xfrm>
           <a:prstGeom prst="rect">
@@ -4800,7 +4839,7 @@
       </p:sp>
       <p:pic>
         <p:nvPicPr>
-          <p:cNvPr id="30" name="Picture 29" descr="3512431765128565377.jpg"/>
+          <p:cNvPr id="31" name="Picture 30" descr="2031739261793493277.jpg"/>
           <p:cNvPicPr>
             <a:picLocks noChangeAspect="1"/>
           </p:cNvPicPr>
@@ -4814,7 +4853,7 @@
         </p:blipFill>
         <p:spPr>
           <a:xfrm>
-            <a:off x="5181600" y="6915150"/>
+            <a:off x="7543800" y="6915150"/>
             <a:ext cx="2286000" cy="2286000"/>
           </a:xfrm>
           <a:prstGeom prst="rect">
@@ -4824,13 +4863,13 @@
       </p:pic>
       <p:sp>
         <p:nvSpPr>
-          <p:cNvPr id="31" name="Rectangle 30"/>
+          <p:cNvPr id="32" name="Rectangle 31"/>
           <p:cNvSpPr/>
           <p:nvPr/>
         </p:nvSpPr>
         <p:spPr>
           <a:xfrm>
-            <a:off x="5181600" y="8782050"/>
+            <a:off x="7543800" y="8782050"/>
             <a:ext cx="2286000" cy="419100"/>
           </a:xfrm>
           <a:prstGeom prst="rect">
@@ -4870,13 +4909,13 @@
       </p:sp>
       <p:sp>
         <p:nvSpPr>
-          <p:cNvPr id="32" name="TextBox 31"/>
+          <p:cNvPr id="33" name="TextBox 32"/>
           <p:cNvSpPr txBox="1"/>
           <p:nvPr/>
         </p:nvSpPr>
         <p:spPr>
           <a:xfrm>
-            <a:off x="5238750" y="8782050"/>
+            <a:off x="7600950" y="8782050"/>
             <a:ext cx="2171700" cy="419100"/>
           </a:xfrm>
           <a:prstGeom prst="rect">
@@ -4909,7 +4948,7 @@
       </p:sp>
       <p:pic>
         <p:nvPicPr>
-          <p:cNvPr id="33" name="Picture 32" descr="9208379026975339746.jpg"/>
+          <p:cNvPr id="34" name="Picture 33" descr="4102834731964614266.jpg"/>
           <p:cNvPicPr>
             <a:picLocks noChangeAspect="1"/>
           </p:cNvPicPr>
@@ -4923,7 +4962,7 @@
         </p:blipFill>
         <p:spPr>
           <a:xfrm>
-            <a:off x="7543800" y="6915150"/>
+            <a:off x="457200" y="9277350"/>
             <a:ext cx="2286000" cy="2286000"/>
           </a:xfrm>
           <a:prstGeom prst="rect">
@@ -4933,13 +4972,13 @@
       </p:pic>
       <p:sp>
         <p:nvSpPr>
-          <p:cNvPr id="34" name="Rectangle 33"/>
+          <p:cNvPr id="35" name="Rectangle 34"/>
           <p:cNvSpPr/>
           <p:nvPr/>
         </p:nvSpPr>
         <p:spPr>
           <a:xfrm>
-            <a:off x="7543800" y="8782050"/>
+            <a:off x="457200" y="11144250"/>
             <a:ext cx="2286000" cy="419100"/>
           </a:xfrm>
           <a:prstGeom prst="rect">
@@ -4979,13 +5018,13 @@
       </p:sp>
       <p:sp>
         <p:nvSpPr>
-          <p:cNvPr id="35" name="TextBox 34"/>
+          <p:cNvPr id="36" name="TextBox 35"/>
           <p:cNvSpPr txBox="1"/>
           <p:nvPr/>
         </p:nvSpPr>
         <p:spPr>
           <a:xfrm>
-            <a:off x="7600950" y="8782050"/>
+            <a:off x="514350" y="11144250"/>
             <a:ext cx="2171700" cy="419100"/>
           </a:xfrm>
           <a:prstGeom prst="rect">
@@ -5018,7 +5057,7 @@
       </p:sp>
       <p:pic>
         <p:nvPicPr>
-          <p:cNvPr id="36" name="Picture 35" descr="8672761161464777380.jpg"/>
+          <p:cNvPr id="37" name="Picture 36" descr="8877044523468660322.jpg"/>
           <p:cNvPicPr>
             <a:picLocks noChangeAspect="1"/>
           </p:cNvPicPr>
@@ -5032,7 +5071,7 @@
         </p:blipFill>
         <p:spPr>
           <a:xfrm>
-            <a:off x="1638300" y="9277350"/>
+            <a:off x="2819400" y="9277350"/>
             <a:ext cx="2286000" cy="2286000"/>
           </a:xfrm>
           <a:prstGeom prst="rect">
@@ -5042,13 +5081,13 @@
       </p:pic>
       <p:sp>
         <p:nvSpPr>
-          <p:cNvPr id="37" name="Rectangle 36"/>
+          <p:cNvPr id="38" name="Rectangle 37"/>
           <p:cNvSpPr/>
           <p:nvPr/>
         </p:nvSpPr>
         <p:spPr>
           <a:xfrm>
-            <a:off x="1638300" y="11144250"/>
+            <a:off x="2819400" y="11144250"/>
             <a:ext cx="2286000" cy="419100"/>
           </a:xfrm>
           <a:prstGeom prst="rect">
@@ -5088,13 +5127,13 @@
       </p:sp>
       <p:sp>
         <p:nvSpPr>
-          <p:cNvPr id="38" name="TextBox 37"/>
+          <p:cNvPr id="39" name="TextBox 38"/>
           <p:cNvSpPr txBox="1"/>
           <p:nvPr/>
         </p:nvSpPr>
         <p:spPr>
           <a:xfrm>
-            <a:off x="1695450" y="11144250"/>
+            <a:off x="2876550" y="11144250"/>
             <a:ext cx="2171700" cy="419100"/>
           </a:xfrm>
           <a:prstGeom prst="rect">
@@ -5127,7 +5166,7 @@
       </p:sp>
       <p:pic>
         <p:nvPicPr>
-          <p:cNvPr id="39" name="Picture 38" descr="3359842666902028946.jpg"/>
+          <p:cNvPr id="40" name="Picture 39" descr="8585654983711146034.jpg"/>
           <p:cNvPicPr>
             <a:picLocks noChangeAspect="1"/>
           </p:cNvPicPr>
@@ -5141,7 +5180,7 @@
         </p:blipFill>
         <p:spPr>
           <a:xfrm>
-            <a:off x="4000500" y="9277350"/>
+            <a:off x="5181600" y="9277350"/>
             <a:ext cx="2286000" cy="2286000"/>
           </a:xfrm>
           <a:prstGeom prst="rect">
@@ -5151,13 +5190,13 @@
       </p:pic>
       <p:sp>
         <p:nvSpPr>
-          <p:cNvPr id="40" name="Rectangle 39"/>
+          <p:cNvPr id="41" name="Rectangle 40"/>
           <p:cNvSpPr/>
           <p:nvPr/>
         </p:nvSpPr>
         <p:spPr>
           <a:xfrm>
-            <a:off x="4000500" y="11144250"/>
+            <a:off x="5181600" y="11144250"/>
             <a:ext cx="2286000" cy="419100"/>
           </a:xfrm>
           <a:prstGeom prst="rect">
@@ -5197,13 +5236,13 @@
       </p:sp>
       <p:sp>
         <p:nvSpPr>
-          <p:cNvPr id="41" name="TextBox 40"/>
+          <p:cNvPr id="42" name="TextBox 41"/>
           <p:cNvSpPr txBox="1"/>
           <p:nvPr/>
         </p:nvSpPr>
         <p:spPr>
           <a:xfrm>
-            <a:off x="4057650" y="11144250"/>
+            <a:off x="5238750" y="11144250"/>
             <a:ext cx="2171700" cy="419100"/>
           </a:xfrm>
           <a:prstGeom prst="rect">
@@ -5236,7 +5275,7 @@
       </p:sp>
       <p:pic>
         <p:nvPicPr>
-          <p:cNvPr id="42" name="Picture 41" descr="8025998113937040021.jpg"/>
+          <p:cNvPr id="43" name="Picture 42" descr="8174182683401141233.jpg"/>
           <p:cNvPicPr>
             <a:picLocks noChangeAspect="1"/>
           </p:cNvPicPr>
@@ -5250,7 +5289,7 @@
         </p:blipFill>
         <p:spPr>
           <a:xfrm>
-            <a:off x="6362700" y="9277350"/>
+            <a:off x="7543800" y="9277350"/>
             <a:ext cx="2286000" cy="2286000"/>
           </a:xfrm>
           <a:prstGeom prst="rect">
@@ -5260,13 +5299,13 @@
       </p:pic>
       <p:sp>
         <p:nvSpPr>
-          <p:cNvPr id="43" name="Rectangle 42"/>
+          <p:cNvPr id="44" name="Rectangle 43"/>
           <p:cNvSpPr/>
           <p:nvPr/>
         </p:nvSpPr>
         <p:spPr>
           <a:xfrm>
-            <a:off x="6362700" y="11144250"/>
+            <a:off x="7543800" y="11144250"/>
             <a:ext cx="2286000" cy="419100"/>
           </a:xfrm>
           <a:prstGeom prst="rect">
@@ -5306,13 +5345,13 @@
       </p:sp>
       <p:sp>
         <p:nvSpPr>
-          <p:cNvPr id="44" name="TextBox 43"/>
+          <p:cNvPr id="45" name="TextBox 44"/>
           <p:cNvSpPr txBox="1"/>
           <p:nvPr/>
         </p:nvSpPr>
         <p:spPr>
           <a:xfrm>
-            <a:off x="6419850" y="11144250"/>
+            <a:off x="7600950" y="11144250"/>
             <a:ext cx="2171700" cy="419100"/>
           </a:xfrm>
           <a:prstGeom prst="rect">
@@ -5345,7 +5384,7 @@
       </p:sp>
       <p:sp>
         <p:nvSpPr>
-          <p:cNvPr id="45" name="TextBox 44"/>
+          <p:cNvPr id="46" name="TextBox 45"/>
           <p:cNvSpPr txBox="1"/>
           <p:nvPr/>
         </p:nvSpPr>

</xml_diff>

<commit_message>
Teachers' Day: body text #333130 per brand doc; Wesley Sanders confirmed by Linnea
Co-Authored-By: Claude Opus 5.5 <noreply@anthropic.com>
Claude-Session: https://claude.ai/code/session_014HGzAbxBh54nuyJHG7tse8
</commit_message>
<xml_diff>
--- a/templates/posts/october/05-10-2026-mon-ig-teachers-day-option-1-photo.pptx
+++ b/templates/posts/october/05-10-2026-mon-ig-teachers-day-option-1-photo.pptx
@@ -3589,7 +3589,7 @@
       <p:grpSpPr/>
       <p:pic>
         <p:nvPicPr>
-          <p:cNvPr id="2" name="Picture 1" descr="8851306644178481794.jpg"/>
+          <p:cNvPr id="2" name="Picture 1" descr="250474640508004617.jpg"/>
           <p:cNvPicPr>
             <a:picLocks noChangeAspect="1"/>
           </p:cNvPicPr>
@@ -3719,7 +3719,7 @@
             <a:r>
               <a:rPr sz="2800" b="0" i="0">
                 <a:solidFill>
-                  <a:srgbClr val="1A1A1A"/>
+                  <a:srgbClr val="333130"/>
                 </a:solidFill>
                 <a:latin typeface="Source Sans 3"/>
               </a:rPr>
@@ -3858,7 +3858,7 @@
       </p:sp>
       <p:pic>
         <p:nvPicPr>
-          <p:cNvPr id="4" name="Picture 3" descr="4408951095294771185.jpg"/>
+          <p:cNvPr id="4" name="Picture 3" descr="6234609011925723337.jpg"/>
           <p:cNvPicPr>
             <a:picLocks noChangeAspect="1"/>
           </p:cNvPicPr>
@@ -3967,7 +3967,7 @@
       </p:sp>
       <p:pic>
         <p:nvPicPr>
-          <p:cNvPr id="7" name="Picture 6" descr="2053480673178515544.jpg"/>
+          <p:cNvPr id="7" name="Picture 6" descr="2885865381636175526.jpg"/>
           <p:cNvPicPr>
             <a:picLocks noChangeAspect="1"/>
           </p:cNvPicPr>
@@ -4076,7 +4076,7 @@
       </p:sp>
       <p:pic>
         <p:nvPicPr>
-          <p:cNvPr id="10" name="Picture 9" descr="8526052707322937247.jpg"/>
+          <p:cNvPr id="10" name="Picture 9" descr="4596608046275292327.jpg"/>
           <p:cNvPicPr>
             <a:picLocks noChangeAspect="1"/>
           </p:cNvPicPr>
@@ -4185,7 +4185,7 @@
       </p:sp>
       <p:pic>
         <p:nvPicPr>
-          <p:cNvPr id="13" name="Picture 12" descr="4463640484023020558.jpg"/>
+          <p:cNvPr id="13" name="Picture 12" descr="4332968967792942556.jpg"/>
           <p:cNvPicPr>
             <a:picLocks noChangeAspect="1"/>
           </p:cNvPicPr>
@@ -4294,7 +4294,7 @@
       </p:sp>
       <p:pic>
         <p:nvPicPr>
-          <p:cNvPr id="16" name="Picture 15" descr="2262292987271407235.jpg"/>
+          <p:cNvPr id="16" name="Picture 15" descr="8468941578046363424.jpg"/>
           <p:cNvPicPr>
             <a:picLocks noChangeAspect="1"/>
           </p:cNvPicPr>
@@ -4403,7 +4403,7 @@
       </p:sp>
       <p:pic>
         <p:nvPicPr>
-          <p:cNvPr id="19" name="Picture 18" descr="9013575186157804863.jpg"/>
+          <p:cNvPr id="19" name="Picture 18" descr="8881565924270927158.jpg"/>
           <p:cNvPicPr>
             <a:picLocks noChangeAspect="1"/>
           </p:cNvPicPr>
@@ -4512,7 +4512,7 @@
       </p:sp>
       <p:pic>
         <p:nvPicPr>
-          <p:cNvPr id="22" name="Picture 21" descr="5529725699895573590.jpg"/>
+          <p:cNvPr id="22" name="Picture 21" descr="4356876515863862456.jpg"/>
           <p:cNvPicPr>
             <a:picLocks noChangeAspect="1"/>
           </p:cNvPicPr>
@@ -4621,7 +4621,7 @@
       </p:sp>
       <p:pic>
         <p:nvPicPr>
-          <p:cNvPr id="25" name="Picture 24" descr="2407624395823463407.jpg"/>
+          <p:cNvPr id="25" name="Picture 24" descr="1621609621900963801.jpg"/>
           <p:cNvPicPr>
             <a:picLocks noChangeAspect="1"/>
           </p:cNvPicPr>
@@ -4730,7 +4730,7 @@
       </p:sp>
       <p:pic>
         <p:nvPicPr>
-          <p:cNvPr id="28" name="Picture 27" descr="1164985834360799692.jpg"/>
+          <p:cNvPr id="28" name="Picture 27" descr="6265112960125145205.jpg"/>
           <p:cNvPicPr>
             <a:picLocks noChangeAspect="1"/>
           </p:cNvPicPr>
@@ -4839,7 +4839,7 @@
       </p:sp>
       <p:pic>
         <p:nvPicPr>
-          <p:cNvPr id="31" name="Picture 30" descr="2031739261793493277.jpg"/>
+          <p:cNvPr id="31" name="Picture 30" descr="4497001751860755788.jpg"/>
           <p:cNvPicPr>
             <a:picLocks noChangeAspect="1"/>
           </p:cNvPicPr>
@@ -4948,7 +4948,7 @@
       </p:sp>
       <p:pic>
         <p:nvPicPr>
-          <p:cNvPr id="34" name="Picture 33" descr="4102834731964614266.jpg"/>
+          <p:cNvPr id="34" name="Picture 33" descr="6015455580736178253.jpg"/>
           <p:cNvPicPr>
             <a:picLocks noChangeAspect="1"/>
           </p:cNvPicPr>
@@ -5057,7 +5057,7 @@
       </p:sp>
       <p:pic>
         <p:nvPicPr>
-          <p:cNvPr id="37" name="Picture 36" descr="8877044523468660322.jpg"/>
+          <p:cNvPr id="37" name="Picture 36" descr="8671595325082427723.jpg"/>
           <p:cNvPicPr>
             <a:picLocks noChangeAspect="1"/>
           </p:cNvPicPr>
@@ -5166,7 +5166,7 @@
       </p:sp>
       <p:pic>
         <p:nvPicPr>
-          <p:cNvPr id="40" name="Picture 39" descr="8585654983711146034.jpg"/>
+          <p:cNvPr id="40" name="Picture 39" descr="530489703401159089.jpg"/>
           <p:cNvPicPr>
             <a:picLocks noChangeAspect="1"/>
           </p:cNvPicPr>
@@ -5275,7 +5275,7 @@
       </p:sp>
       <p:pic>
         <p:nvPicPr>
-          <p:cNvPr id="43" name="Picture 42" descr="8174182683401141233.jpg"/>
+          <p:cNvPr id="43" name="Picture 42" descr="1961223670800779458.jpg"/>
           <p:cNvPicPr>
             <a:picLocks noChangeAspect="1"/>
           </p:cNvPicPr>

</xml_diff>

<commit_message>
Teachers' Day: names and roles from the SFW team page, name and role only for every mentor
Co-Authored-By: Claude Opus 5.5 <noreply@anthropic.com>
Claude-Session: https://claude.ai/code/session_014HGzAbxBh54nuyJHG7tse8
</commit_message>
<xml_diff>
--- a/templates/posts/october/05-10-2026-mon-ig-teachers-day-option-1-photo.pptx
+++ b/templates/posts/october/05-10-2026-mon-ig-teachers-day-option-1-photo.pptx
@@ -3589,7 +3589,7 @@
       <p:grpSpPr/>
       <p:pic>
         <p:nvPicPr>
-          <p:cNvPr id="2" name="Picture 1" descr="250474640508004617.jpg"/>
+          <p:cNvPr id="2" name="Picture 1" descr="5089101134904945839.jpg"/>
           <p:cNvPicPr>
             <a:picLocks noChangeAspect="1"/>
           </p:cNvPicPr>
@@ -3858,7 +3858,7 @@
       </p:sp>
       <p:pic>
         <p:nvPicPr>
-          <p:cNvPr id="4" name="Picture 3" descr="6234609011925723337.jpg"/>
+          <p:cNvPr id="4" name="Picture 3" descr="3423127874932208630.jpg"/>
           <p:cNvPicPr>
             <a:picLocks noChangeAspect="1"/>
           </p:cNvPicPr>
@@ -3967,7 +3967,7 @@
       </p:sp>
       <p:pic>
         <p:nvPicPr>
-          <p:cNvPr id="7" name="Picture 6" descr="2885865381636175526.jpg"/>
+          <p:cNvPr id="7" name="Picture 6" descr="3297107423503027276.jpg"/>
           <p:cNvPicPr>
             <a:picLocks noChangeAspect="1"/>
           </p:cNvPicPr>
@@ -4076,7 +4076,7 @@
       </p:sp>
       <p:pic>
         <p:nvPicPr>
-          <p:cNvPr id="10" name="Picture 9" descr="4596608046275292327.jpg"/>
+          <p:cNvPr id="10" name="Picture 9" descr="6959830007125462775.jpg"/>
           <p:cNvPicPr>
             <a:picLocks noChangeAspect="1"/>
           </p:cNvPicPr>
@@ -4185,7 +4185,7 @@
       </p:sp>
       <p:pic>
         <p:nvPicPr>
-          <p:cNvPr id="13" name="Picture 12" descr="4332968967792942556.jpg"/>
+          <p:cNvPr id="13" name="Picture 12" descr="2532088052200438377.jpg"/>
           <p:cNvPicPr>
             <a:picLocks noChangeAspect="1"/>
           </p:cNvPicPr>
@@ -4294,7 +4294,7 @@
       </p:sp>
       <p:pic>
         <p:nvPicPr>
-          <p:cNvPr id="16" name="Picture 15" descr="8468941578046363424.jpg"/>
+          <p:cNvPr id="16" name="Picture 15" descr="7677503132644364983.jpg"/>
           <p:cNvPicPr>
             <a:picLocks noChangeAspect="1"/>
           </p:cNvPicPr>
@@ -4403,7 +4403,7 @@
       </p:sp>
       <p:pic>
         <p:nvPicPr>
-          <p:cNvPr id="19" name="Picture 18" descr="8881565924270927158.jpg"/>
+          <p:cNvPr id="19" name="Picture 18" descr="2495813991993553482.jpg"/>
           <p:cNvPicPr>
             <a:picLocks noChangeAspect="1"/>
           </p:cNvPicPr>
@@ -4512,7 +4512,7 @@
       </p:sp>
       <p:pic>
         <p:nvPicPr>
-          <p:cNvPr id="22" name="Picture 21" descr="4356876515863862456.jpg"/>
+          <p:cNvPr id="22" name="Picture 21" descr="992375284083682736.jpg"/>
           <p:cNvPicPr>
             <a:picLocks noChangeAspect="1"/>
           </p:cNvPicPr>
@@ -4621,7 +4621,7 @@
       </p:sp>
       <p:pic>
         <p:nvPicPr>
-          <p:cNvPr id="25" name="Picture 24" descr="1621609621900963801.jpg"/>
+          <p:cNvPr id="25" name="Picture 24" descr="4636357773151813356.jpg"/>
           <p:cNvPicPr>
             <a:picLocks noChangeAspect="1"/>
           </p:cNvPicPr>
@@ -4723,14 +4723,14 @@
                 </a:solidFill>
                 <a:latin typeface="Montserrat"/>
               </a:rPr>
-              <a:t>Aysen Ustunay</a:t>
+              <a:t>Ayşen Üstünay</a:t>
             </a:r>
           </a:p>
         </p:txBody>
       </p:sp>
       <p:pic>
         <p:nvPicPr>
-          <p:cNvPr id="28" name="Picture 27" descr="6265112960125145205.jpg"/>
+          <p:cNvPr id="28" name="Picture 27" descr="4337694397078735279.jpg"/>
           <p:cNvPicPr>
             <a:picLocks noChangeAspect="1"/>
           </p:cNvPicPr>
@@ -4839,7 +4839,7 @@
       </p:sp>
       <p:pic>
         <p:nvPicPr>
-          <p:cNvPr id="31" name="Picture 30" descr="4497001751860755788.jpg"/>
+          <p:cNvPr id="31" name="Picture 30" descr="8062215383129015180.jpg"/>
           <p:cNvPicPr>
             <a:picLocks noChangeAspect="1"/>
           </p:cNvPicPr>
@@ -4941,14 +4941,14 @@
                 </a:solidFill>
                 <a:latin typeface="Montserrat"/>
               </a:rPr>
-              <a:t>Gerald Ramirez</a:t>
+              <a:t>Gerald Ramírez</a:t>
             </a:r>
           </a:p>
         </p:txBody>
       </p:sp>
       <p:pic>
         <p:nvPicPr>
-          <p:cNvPr id="34" name="Picture 33" descr="6015455580736178253.jpg"/>
+          <p:cNvPr id="34" name="Picture 33" descr="2684707124881562698.jpg"/>
           <p:cNvPicPr>
             <a:picLocks noChangeAspect="1"/>
           </p:cNvPicPr>
@@ -5057,7 +5057,7 @@
       </p:sp>
       <p:pic>
         <p:nvPicPr>
-          <p:cNvPr id="37" name="Picture 36" descr="8671595325082427723.jpg"/>
+          <p:cNvPr id="37" name="Picture 36" descr="3303125404541949075.jpg"/>
           <p:cNvPicPr>
             <a:picLocks noChangeAspect="1"/>
           </p:cNvPicPr>
@@ -5159,14 +5159,14 @@
                 </a:solidFill>
                 <a:latin typeface="Montserrat"/>
               </a:rPr>
-              <a:t>Ib Borup Pederson</a:t>
+              <a:t>Ib Borup Pedersen</a:t>
             </a:r>
           </a:p>
         </p:txBody>
       </p:sp>
       <p:pic>
         <p:nvPicPr>
-          <p:cNvPr id="40" name="Picture 39" descr="530489703401159089.jpg"/>
+          <p:cNvPr id="40" name="Picture 39" descr="2484353581637585657.jpg"/>
           <p:cNvPicPr>
             <a:picLocks noChangeAspect="1"/>
           </p:cNvPicPr>
@@ -5275,7 +5275,7 @@
       </p:sp>
       <p:pic>
         <p:nvPicPr>
-          <p:cNvPr id="43" name="Picture 42" descr="1961223670800779458.jpg"/>
+          <p:cNvPr id="43" name="Picture 42" descr="5194115076089133331.jpg"/>
           <p:cNvPicPr>
             <a:picLocks noChangeAspect="1"/>
           </p:cNvPicPr>

</xml_diff>

<commit_message>
Teachers' Day: add Elina Psara, Caterina Capri, Laura Campos, Nora Levay; 18 mentors, three per slide, 9 slides
Co-Authored-By: Claude Opus 5.5 <noreply@anthropic.com>
Claude-Session: https://claude.ai/code/session_014HGzAbxBh54nuyJHG7tse8
</commit_message>
<xml_diff>
--- a/templates/posts/october/05-10-2026-mon-ig-teachers-day-option-1-photo.pptx
+++ b/templates/posts/october/05-10-2026-mon-ig-teachers-day-option-1-photo.pptx
@@ -3589,7 +3589,7 @@
       <p:grpSpPr/>
       <p:pic>
         <p:nvPicPr>
-          <p:cNvPr id="2" name="Picture 1" descr="5089101134904945839.jpg"/>
+          <p:cNvPr id="2" name="Picture 1" descr="209207550916773552.jpg"/>
           <p:cNvPicPr>
             <a:picLocks noChangeAspect="1"/>
           </p:cNvPicPr>
@@ -3826,7 +3826,7 @@
         <p:spPr>
           <a:xfrm>
             <a:off x="495300" y="2190750"/>
-            <a:ext cx="4572000" cy="2286000"/>
+            <a:ext cx="3627120" cy="1813560"/>
           </a:xfrm>
           <a:prstGeom prst="rect">
             <a:avLst/>
@@ -3845,7 +3845,7 @@
               </a:lnSpc>
             </a:pPr>
             <a:r>
-              <a:rPr sz="4000" b="1" i="0">
+              <a:rPr sz="3400" b="1" i="0">
                 <a:solidFill>
                   <a:srgbClr val="31662F"/>
                 </a:solidFill>
@@ -3858,7 +3858,7 @@
       </p:sp>
       <p:pic>
         <p:nvPicPr>
-          <p:cNvPr id="4" name="Picture 3" descr="3423127874932208630.jpg"/>
+          <p:cNvPr id="4" name="Picture 3" descr="1752988849223235031.jpg"/>
           <p:cNvPicPr>
             <a:picLocks noChangeAspect="1"/>
           </p:cNvPicPr>
@@ -3872,8 +3872,8 @@
         </p:blipFill>
         <p:spPr>
           <a:xfrm>
-            <a:off x="5181600" y="2190750"/>
-            <a:ext cx="2286000" cy="2286000"/>
+            <a:off x="4236720" y="2190750"/>
+            <a:ext cx="1813560" cy="1813560"/>
           </a:xfrm>
           <a:prstGeom prst="rect">
             <a:avLst/>
@@ -3888,8 +3888,8 @@
         </p:nvSpPr>
         <p:spPr>
           <a:xfrm>
-            <a:off x="5181600" y="4057650"/>
-            <a:ext cx="2286000" cy="419100"/>
+            <a:off x="4236720" y="3661410"/>
+            <a:ext cx="1813560" cy="342900"/>
           </a:xfrm>
           <a:prstGeom prst="rect">
             <a:avLst/>
@@ -3934,8 +3934,8 @@
         </p:nvSpPr>
         <p:spPr>
           <a:xfrm>
-            <a:off x="5238750" y="4057650"/>
-            <a:ext cx="2171700" cy="419100"/>
+            <a:off x="4274820" y="3661410"/>
+            <a:ext cx="1737360" cy="342900"/>
           </a:xfrm>
           <a:prstGeom prst="rect">
             <a:avLst/>
@@ -3954,7 +3954,7 @@
               </a:lnSpc>
             </a:pPr>
             <a:r>
-              <a:rPr sz="1500" b="1" i="0">
+              <a:rPr sz="1200" b="1" i="0">
                 <a:solidFill>
                   <a:srgbClr val="31662F"/>
                 </a:solidFill>
@@ -3967,7 +3967,7 @@
       </p:sp>
       <p:pic>
         <p:nvPicPr>
-          <p:cNvPr id="7" name="Picture 6" descr="3297107423503027276.jpg"/>
+          <p:cNvPr id="7" name="Picture 6" descr="2612131318617217853.jpg"/>
           <p:cNvPicPr>
             <a:picLocks noChangeAspect="1"/>
           </p:cNvPicPr>
@@ -3981,8 +3981,8 @@
         </p:blipFill>
         <p:spPr>
           <a:xfrm>
-            <a:off x="7543800" y="2190750"/>
-            <a:ext cx="2286000" cy="2286000"/>
+            <a:off x="6126480" y="2190750"/>
+            <a:ext cx="1813560" cy="1813560"/>
           </a:xfrm>
           <a:prstGeom prst="rect">
             <a:avLst/>
@@ -3997,8 +3997,8 @@
         </p:nvSpPr>
         <p:spPr>
           <a:xfrm>
-            <a:off x="7543800" y="4057650"/>
-            <a:ext cx="2286000" cy="419100"/>
+            <a:off x="6126480" y="3661410"/>
+            <a:ext cx="1813560" cy="342900"/>
           </a:xfrm>
           <a:prstGeom prst="rect">
             <a:avLst/>
@@ -4043,8 +4043,8 @@
         </p:nvSpPr>
         <p:spPr>
           <a:xfrm>
-            <a:off x="7600950" y="4057650"/>
-            <a:ext cx="2171700" cy="419100"/>
+            <a:off x="6164580" y="3661410"/>
+            <a:ext cx="1737360" cy="342900"/>
           </a:xfrm>
           <a:prstGeom prst="rect">
             <a:avLst/>
@@ -4063,7 +4063,7 @@
               </a:lnSpc>
             </a:pPr>
             <a:r>
-              <a:rPr sz="1500" b="1" i="0">
+              <a:rPr sz="1200" b="1" i="0">
                 <a:solidFill>
                   <a:srgbClr val="31662F"/>
                 </a:solidFill>
@@ -4076,7 +4076,7 @@
       </p:sp>
       <p:pic>
         <p:nvPicPr>
-          <p:cNvPr id="10" name="Picture 9" descr="6959830007125462775.jpg"/>
+          <p:cNvPr id="10" name="Picture 9" descr="7144932367790493661.jpg"/>
           <p:cNvPicPr>
             <a:picLocks noChangeAspect="1"/>
           </p:cNvPicPr>
@@ -4090,8 +4090,8 @@
         </p:blipFill>
         <p:spPr>
           <a:xfrm>
-            <a:off x="457200" y="4552950"/>
-            <a:ext cx="2286000" cy="2286000"/>
+            <a:off x="8016240" y="2190750"/>
+            <a:ext cx="1813560" cy="1813560"/>
           </a:xfrm>
           <a:prstGeom prst="rect">
             <a:avLst/>
@@ -4106,8 +4106,8 @@
         </p:nvSpPr>
         <p:spPr>
           <a:xfrm>
-            <a:off x="457200" y="6419850"/>
-            <a:ext cx="2286000" cy="419100"/>
+            <a:off x="8016240" y="3661410"/>
+            <a:ext cx="1813560" cy="342900"/>
           </a:xfrm>
           <a:prstGeom prst="rect">
             <a:avLst/>
@@ -4152,8 +4152,8 @@
         </p:nvSpPr>
         <p:spPr>
           <a:xfrm>
-            <a:off x="514350" y="6419850"/>
-            <a:ext cx="2171700" cy="419100"/>
+            <a:off x="8054340" y="3661410"/>
+            <a:ext cx="1737360" cy="342900"/>
           </a:xfrm>
           <a:prstGeom prst="rect">
             <a:avLst/>
@@ -4172,7 +4172,7 @@
               </a:lnSpc>
             </a:pPr>
             <a:r>
-              <a:rPr sz="1500" b="1" i="0">
+              <a:rPr sz="1200" b="1" i="0">
                 <a:solidFill>
                   <a:srgbClr val="31662F"/>
                 </a:solidFill>
@@ -4185,7 +4185,7 @@
       </p:sp>
       <p:pic>
         <p:nvPicPr>
-          <p:cNvPr id="13" name="Picture 12" descr="2532088052200438377.jpg"/>
+          <p:cNvPr id="13" name="Picture 12" descr="1194488140148190033.jpg"/>
           <p:cNvPicPr>
             <a:picLocks noChangeAspect="1"/>
           </p:cNvPicPr>
@@ -4199,8 +4199,8 @@
         </p:blipFill>
         <p:spPr>
           <a:xfrm>
-            <a:off x="2819400" y="4552950"/>
-            <a:ext cx="2286000" cy="2286000"/>
+            <a:off x="457200" y="4080510"/>
+            <a:ext cx="1813560" cy="1813560"/>
           </a:xfrm>
           <a:prstGeom prst="rect">
             <a:avLst/>
@@ -4215,8 +4215,8 @@
         </p:nvSpPr>
         <p:spPr>
           <a:xfrm>
-            <a:off x="2819400" y="6419850"/>
-            <a:ext cx="2286000" cy="419100"/>
+            <a:off x="457200" y="5551170"/>
+            <a:ext cx="1813560" cy="342900"/>
           </a:xfrm>
           <a:prstGeom prst="rect">
             <a:avLst/>
@@ -4261,8 +4261,8 @@
         </p:nvSpPr>
         <p:spPr>
           <a:xfrm>
-            <a:off x="2876550" y="6419850"/>
-            <a:ext cx="2171700" cy="419100"/>
+            <a:off x="495300" y="5551170"/>
+            <a:ext cx="1737360" cy="342900"/>
           </a:xfrm>
           <a:prstGeom prst="rect">
             <a:avLst/>
@@ -4281,7 +4281,7 @@
               </a:lnSpc>
             </a:pPr>
             <a:r>
-              <a:rPr sz="1500" b="1" i="0">
+              <a:rPr sz="1200" b="1" i="0">
                 <a:solidFill>
                   <a:srgbClr val="31662F"/>
                 </a:solidFill>
@@ -4294,7 +4294,7 @@
       </p:sp>
       <p:pic>
         <p:nvPicPr>
-          <p:cNvPr id="16" name="Picture 15" descr="7677503132644364983.jpg"/>
+          <p:cNvPr id="16" name="Picture 15" descr="8647953704869287552.jpg"/>
           <p:cNvPicPr>
             <a:picLocks noChangeAspect="1"/>
           </p:cNvPicPr>
@@ -4308,8 +4308,8 @@
         </p:blipFill>
         <p:spPr>
           <a:xfrm>
-            <a:off x="5181600" y="4552950"/>
-            <a:ext cx="2286000" cy="2286000"/>
+            <a:off x="2346960" y="4080510"/>
+            <a:ext cx="1813560" cy="1813560"/>
           </a:xfrm>
           <a:prstGeom prst="rect">
             <a:avLst/>
@@ -4324,8 +4324,8 @@
         </p:nvSpPr>
         <p:spPr>
           <a:xfrm>
-            <a:off x="5181600" y="6419850"/>
-            <a:ext cx="2286000" cy="419100"/>
+            <a:off x="2346960" y="5551170"/>
+            <a:ext cx="1813560" cy="342900"/>
           </a:xfrm>
           <a:prstGeom prst="rect">
             <a:avLst/>
@@ -4370,8 +4370,8 @@
         </p:nvSpPr>
         <p:spPr>
           <a:xfrm>
-            <a:off x="5238750" y="6419850"/>
-            <a:ext cx="2171700" cy="419100"/>
+            <a:off x="2385060" y="5551170"/>
+            <a:ext cx="1737360" cy="342900"/>
           </a:xfrm>
           <a:prstGeom prst="rect">
             <a:avLst/>
@@ -4390,7 +4390,7 @@
               </a:lnSpc>
             </a:pPr>
             <a:r>
-              <a:rPr sz="1500" b="1" i="0">
+              <a:rPr sz="1200" b="1" i="0">
                 <a:solidFill>
                   <a:srgbClr val="31662F"/>
                 </a:solidFill>
@@ -4403,7 +4403,7 @@
       </p:sp>
       <p:pic>
         <p:nvPicPr>
-          <p:cNvPr id="19" name="Picture 18" descr="2495813991993553482.jpg"/>
+          <p:cNvPr id="19" name="Picture 18" descr="6026637821407471426.jpg"/>
           <p:cNvPicPr>
             <a:picLocks noChangeAspect="1"/>
           </p:cNvPicPr>
@@ -4417,8 +4417,8 @@
         </p:blipFill>
         <p:spPr>
           <a:xfrm>
-            <a:off x="7543800" y="4552950"/>
-            <a:ext cx="2286000" cy="2286000"/>
+            <a:off x="4236720" y="4080510"/>
+            <a:ext cx="1813560" cy="1813560"/>
           </a:xfrm>
           <a:prstGeom prst="rect">
             <a:avLst/>
@@ -4433,8 +4433,8 @@
         </p:nvSpPr>
         <p:spPr>
           <a:xfrm>
-            <a:off x="7543800" y="6419850"/>
-            <a:ext cx="2286000" cy="419100"/>
+            <a:off x="4236720" y="5551170"/>
+            <a:ext cx="1813560" cy="342900"/>
           </a:xfrm>
           <a:prstGeom prst="rect">
             <a:avLst/>
@@ -4479,8 +4479,8 @@
         </p:nvSpPr>
         <p:spPr>
           <a:xfrm>
-            <a:off x="7600950" y="6419850"/>
-            <a:ext cx="2171700" cy="419100"/>
+            <a:off x="4274820" y="5551170"/>
+            <a:ext cx="1737360" cy="342900"/>
           </a:xfrm>
           <a:prstGeom prst="rect">
             <a:avLst/>
@@ -4499,7 +4499,7 @@
               </a:lnSpc>
             </a:pPr>
             <a:r>
-              <a:rPr sz="1500" b="1" i="0">
+              <a:rPr sz="1200" b="1" i="0">
                 <a:solidFill>
                   <a:srgbClr val="31662F"/>
                 </a:solidFill>
@@ -4512,7 +4512,7 @@
       </p:sp>
       <p:pic>
         <p:nvPicPr>
-          <p:cNvPr id="22" name="Picture 21" descr="992375284083682736.jpg"/>
+          <p:cNvPr id="22" name="Picture 21" descr="3723017669234027646.jpg"/>
           <p:cNvPicPr>
             <a:picLocks noChangeAspect="1"/>
           </p:cNvPicPr>
@@ -4526,8 +4526,8 @@
         </p:blipFill>
         <p:spPr>
           <a:xfrm>
-            <a:off x="457200" y="6915150"/>
-            <a:ext cx="2286000" cy="2286000"/>
+            <a:off x="6126480" y="4080510"/>
+            <a:ext cx="1813560" cy="1813560"/>
           </a:xfrm>
           <a:prstGeom prst="rect">
             <a:avLst/>
@@ -4542,8 +4542,8 @@
         </p:nvSpPr>
         <p:spPr>
           <a:xfrm>
-            <a:off x="457200" y="8782050"/>
-            <a:ext cx="2286000" cy="419100"/>
+            <a:off x="6126480" y="5551170"/>
+            <a:ext cx="1813560" cy="342900"/>
           </a:xfrm>
           <a:prstGeom prst="rect">
             <a:avLst/>
@@ -4588,8 +4588,8 @@
         </p:nvSpPr>
         <p:spPr>
           <a:xfrm>
-            <a:off x="514350" y="8782050"/>
-            <a:ext cx="2171700" cy="419100"/>
+            <a:off x="6164580" y="5551170"/>
+            <a:ext cx="1737360" cy="342900"/>
           </a:xfrm>
           <a:prstGeom prst="rect">
             <a:avLst/>
@@ -4608,7 +4608,7 @@
               </a:lnSpc>
             </a:pPr>
             <a:r>
-              <a:rPr sz="1500" b="1" i="0">
+              <a:rPr sz="1200" b="1" i="0">
                 <a:solidFill>
                   <a:srgbClr val="31662F"/>
                 </a:solidFill>
@@ -4621,7 +4621,7 @@
       </p:sp>
       <p:pic>
         <p:nvPicPr>
-          <p:cNvPr id="25" name="Picture 24" descr="4636357773151813356.jpg"/>
+          <p:cNvPr id="25" name="Picture 24" descr="3113535558271719414.jpg"/>
           <p:cNvPicPr>
             <a:picLocks noChangeAspect="1"/>
           </p:cNvPicPr>
@@ -4635,8 +4635,8 @@
         </p:blipFill>
         <p:spPr>
           <a:xfrm>
-            <a:off x="2819400" y="6915150"/>
-            <a:ext cx="2286000" cy="2286000"/>
+            <a:off x="8016240" y="4080510"/>
+            <a:ext cx="1813560" cy="1813560"/>
           </a:xfrm>
           <a:prstGeom prst="rect">
             <a:avLst/>
@@ -4651,8 +4651,8 @@
         </p:nvSpPr>
         <p:spPr>
           <a:xfrm>
-            <a:off x="2819400" y="8782050"/>
-            <a:ext cx="2286000" cy="419100"/>
+            <a:off x="8016240" y="5551170"/>
+            <a:ext cx="1813560" cy="342900"/>
           </a:xfrm>
           <a:prstGeom prst="rect">
             <a:avLst/>
@@ -4697,8 +4697,8 @@
         </p:nvSpPr>
         <p:spPr>
           <a:xfrm>
-            <a:off x="2876550" y="8782050"/>
-            <a:ext cx="2171700" cy="419100"/>
+            <a:off x="8054340" y="5551170"/>
+            <a:ext cx="1737360" cy="342900"/>
           </a:xfrm>
           <a:prstGeom prst="rect">
             <a:avLst/>
@@ -4717,7 +4717,7 @@
               </a:lnSpc>
             </a:pPr>
             <a:r>
-              <a:rPr sz="1500" b="1" i="0">
+              <a:rPr sz="1200" b="1" i="0">
                 <a:solidFill>
                   <a:srgbClr val="31662F"/>
                 </a:solidFill>
@@ -4730,7 +4730,7 @@
       </p:sp>
       <p:pic>
         <p:nvPicPr>
-          <p:cNvPr id="28" name="Picture 27" descr="4337694397078735279.jpg"/>
+          <p:cNvPr id="28" name="Picture 27" descr="5414851247296223470.jpg"/>
           <p:cNvPicPr>
             <a:picLocks noChangeAspect="1"/>
           </p:cNvPicPr>
@@ -4744,8 +4744,8 @@
         </p:blipFill>
         <p:spPr>
           <a:xfrm>
-            <a:off x="5181600" y="6915150"/>
-            <a:ext cx="2286000" cy="2286000"/>
+            <a:off x="457200" y="5970270"/>
+            <a:ext cx="1813560" cy="1813560"/>
           </a:xfrm>
           <a:prstGeom prst="rect">
             <a:avLst/>
@@ -4760,8 +4760,8 @@
         </p:nvSpPr>
         <p:spPr>
           <a:xfrm>
-            <a:off x="5181600" y="8782050"/>
-            <a:ext cx="2286000" cy="419100"/>
+            <a:off x="457200" y="7440929"/>
+            <a:ext cx="1813560" cy="342900"/>
           </a:xfrm>
           <a:prstGeom prst="rect">
             <a:avLst/>
@@ -4806,8 +4806,8 @@
         </p:nvSpPr>
         <p:spPr>
           <a:xfrm>
-            <a:off x="5238750" y="8782050"/>
-            <a:ext cx="2171700" cy="419100"/>
+            <a:off x="495300" y="7440929"/>
+            <a:ext cx="1737360" cy="342900"/>
           </a:xfrm>
           <a:prstGeom prst="rect">
             <a:avLst/>
@@ -4826,7 +4826,7 @@
               </a:lnSpc>
             </a:pPr>
             <a:r>
-              <a:rPr sz="1500" b="1" i="0">
+              <a:rPr sz="1200" b="1" i="0">
                 <a:solidFill>
                   <a:srgbClr val="31662F"/>
                 </a:solidFill>
@@ -4839,7 +4839,7 @@
       </p:sp>
       <p:pic>
         <p:nvPicPr>
-          <p:cNvPr id="31" name="Picture 30" descr="8062215383129015180.jpg"/>
+          <p:cNvPr id="31" name="Picture 30" descr="6759120478498615729.jpg"/>
           <p:cNvPicPr>
             <a:picLocks noChangeAspect="1"/>
           </p:cNvPicPr>
@@ -4853,8 +4853,8 @@
         </p:blipFill>
         <p:spPr>
           <a:xfrm>
-            <a:off x="7543800" y="6915150"/>
-            <a:ext cx="2286000" cy="2286000"/>
+            <a:off x="2346960" y="5970270"/>
+            <a:ext cx="1813560" cy="1813560"/>
           </a:xfrm>
           <a:prstGeom prst="rect">
             <a:avLst/>
@@ -4869,8 +4869,8 @@
         </p:nvSpPr>
         <p:spPr>
           <a:xfrm>
-            <a:off x="7543800" y="8782050"/>
-            <a:ext cx="2286000" cy="419100"/>
+            <a:off x="2346960" y="7440929"/>
+            <a:ext cx="1813560" cy="342900"/>
           </a:xfrm>
           <a:prstGeom prst="rect">
             <a:avLst/>
@@ -4915,8 +4915,8 @@
         </p:nvSpPr>
         <p:spPr>
           <a:xfrm>
-            <a:off x="7600950" y="8782050"/>
-            <a:ext cx="2171700" cy="419100"/>
+            <a:off x="2385060" y="7440929"/>
+            <a:ext cx="1737360" cy="342900"/>
           </a:xfrm>
           <a:prstGeom prst="rect">
             <a:avLst/>
@@ -4935,7 +4935,7 @@
               </a:lnSpc>
             </a:pPr>
             <a:r>
-              <a:rPr sz="1500" b="1" i="0">
+              <a:rPr sz="1200" b="1" i="0">
                 <a:solidFill>
                   <a:srgbClr val="31662F"/>
                 </a:solidFill>
@@ -4948,7 +4948,7 @@
       </p:sp>
       <p:pic>
         <p:nvPicPr>
-          <p:cNvPr id="34" name="Picture 33" descr="2684707124881562698.jpg"/>
+          <p:cNvPr id="34" name="Picture 33" descr="9169552863569812281.jpg"/>
           <p:cNvPicPr>
             <a:picLocks noChangeAspect="1"/>
           </p:cNvPicPr>
@@ -4962,8 +4962,8 @@
         </p:blipFill>
         <p:spPr>
           <a:xfrm>
-            <a:off x="457200" y="9277350"/>
-            <a:ext cx="2286000" cy="2286000"/>
+            <a:off x="4236720" y="5970270"/>
+            <a:ext cx="1813560" cy="1813560"/>
           </a:xfrm>
           <a:prstGeom prst="rect">
             <a:avLst/>
@@ -4978,8 +4978,8 @@
         </p:nvSpPr>
         <p:spPr>
           <a:xfrm>
-            <a:off x="457200" y="11144250"/>
-            <a:ext cx="2286000" cy="419100"/>
+            <a:off x="4236720" y="7440929"/>
+            <a:ext cx="1813560" cy="342900"/>
           </a:xfrm>
           <a:prstGeom prst="rect">
             <a:avLst/>
@@ -5024,8 +5024,8 @@
         </p:nvSpPr>
         <p:spPr>
           <a:xfrm>
-            <a:off x="514350" y="11144250"/>
-            <a:ext cx="2171700" cy="419100"/>
+            <a:off x="4274820" y="7440929"/>
+            <a:ext cx="1737360" cy="342900"/>
           </a:xfrm>
           <a:prstGeom prst="rect">
             <a:avLst/>
@@ -5044,7 +5044,7 @@
               </a:lnSpc>
             </a:pPr>
             <a:r>
-              <a:rPr sz="1500" b="1" i="0">
+              <a:rPr sz="1200" b="1" i="0">
                 <a:solidFill>
                   <a:srgbClr val="31662F"/>
                 </a:solidFill>
@@ -5057,7 +5057,7 @@
       </p:sp>
       <p:pic>
         <p:nvPicPr>
-          <p:cNvPr id="37" name="Picture 36" descr="3303125404541949075.jpg"/>
+          <p:cNvPr id="37" name="Picture 36" descr="6225129540398821112.jpg"/>
           <p:cNvPicPr>
             <a:picLocks noChangeAspect="1"/>
           </p:cNvPicPr>
@@ -5071,8 +5071,8 @@
         </p:blipFill>
         <p:spPr>
           <a:xfrm>
-            <a:off x="2819400" y="9277350"/>
-            <a:ext cx="2286000" cy="2286000"/>
+            <a:off x="6126480" y="5970270"/>
+            <a:ext cx="1813560" cy="1813560"/>
           </a:xfrm>
           <a:prstGeom prst="rect">
             <a:avLst/>
@@ -5087,8 +5087,8 @@
         </p:nvSpPr>
         <p:spPr>
           <a:xfrm>
-            <a:off x="2819400" y="11144250"/>
-            <a:ext cx="2286000" cy="419100"/>
+            <a:off x="6126480" y="7440929"/>
+            <a:ext cx="1813560" cy="342900"/>
           </a:xfrm>
           <a:prstGeom prst="rect">
             <a:avLst/>
@@ -5133,8 +5133,8 @@
         </p:nvSpPr>
         <p:spPr>
           <a:xfrm>
-            <a:off x="2876550" y="11144250"/>
-            <a:ext cx="2171700" cy="419100"/>
+            <a:off x="6164580" y="7440929"/>
+            <a:ext cx="1737360" cy="342900"/>
           </a:xfrm>
           <a:prstGeom prst="rect">
             <a:avLst/>
@@ -5153,7 +5153,7 @@
               </a:lnSpc>
             </a:pPr>
             <a:r>
-              <a:rPr sz="1500" b="1" i="0">
+              <a:rPr sz="1200" b="1" i="0">
                 <a:solidFill>
                   <a:srgbClr val="31662F"/>
                 </a:solidFill>
@@ -5166,7 +5166,7 @@
       </p:sp>
       <p:pic>
         <p:nvPicPr>
-          <p:cNvPr id="40" name="Picture 39" descr="2484353581637585657.jpg"/>
+          <p:cNvPr id="40" name="Picture 39" descr="6957233813328317874.jpg"/>
           <p:cNvPicPr>
             <a:picLocks noChangeAspect="1"/>
           </p:cNvPicPr>
@@ -5180,8 +5180,8 @@
         </p:blipFill>
         <p:spPr>
           <a:xfrm>
-            <a:off x="5181600" y="9277350"/>
-            <a:ext cx="2286000" cy="2286000"/>
+            <a:off x="8016240" y="5970270"/>
+            <a:ext cx="1813560" cy="1813560"/>
           </a:xfrm>
           <a:prstGeom prst="rect">
             <a:avLst/>
@@ -5196,8 +5196,8 @@
         </p:nvSpPr>
         <p:spPr>
           <a:xfrm>
-            <a:off x="5181600" y="11144250"/>
-            <a:ext cx="2286000" cy="419100"/>
+            <a:off x="8016240" y="7440929"/>
+            <a:ext cx="1813560" cy="342900"/>
           </a:xfrm>
           <a:prstGeom prst="rect">
             <a:avLst/>
@@ -5242,8 +5242,8 @@
         </p:nvSpPr>
         <p:spPr>
           <a:xfrm>
-            <a:off x="5238750" y="11144250"/>
-            <a:ext cx="2171700" cy="419100"/>
+            <a:off x="8054340" y="7440929"/>
+            <a:ext cx="1737360" cy="342900"/>
           </a:xfrm>
           <a:prstGeom prst="rect">
             <a:avLst/>
@@ -5262,7 +5262,7 @@
               </a:lnSpc>
             </a:pPr>
             <a:r>
-              <a:rPr sz="1500" b="1" i="0">
+              <a:rPr sz="1200" b="1" i="0">
                 <a:solidFill>
                   <a:srgbClr val="31662F"/>
                 </a:solidFill>
@@ -5275,7 +5275,7 @@
       </p:sp>
       <p:pic>
         <p:nvPicPr>
-          <p:cNvPr id="43" name="Picture 42" descr="5194115076089133331.jpg"/>
+          <p:cNvPr id="43" name="Picture 42" descr="6998284926264825370.jpg"/>
           <p:cNvPicPr>
             <a:picLocks noChangeAspect="1"/>
           </p:cNvPicPr>
@@ -5289,8 +5289,8 @@
         </p:blipFill>
         <p:spPr>
           <a:xfrm>
-            <a:off x="7543800" y="9277350"/>
-            <a:ext cx="2286000" cy="2286000"/>
+            <a:off x="457200" y="7860030"/>
+            <a:ext cx="1813560" cy="1813560"/>
           </a:xfrm>
           <a:prstGeom prst="rect">
             <a:avLst/>
@@ -5305,8 +5305,8 @@
         </p:nvSpPr>
         <p:spPr>
           <a:xfrm>
-            <a:off x="7543800" y="11144250"/>
-            <a:ext cx="2286000" cy="419100"/>
+            <a:off x="457200" y="9330690"/>
+            <a:ext cx="1813560" cy="342900"/>
           </a:xfrm>
           <a:prstGeom prst="rect">
             <a:avLst/>
@@ -5351,8 +5351,8 @@
         </p:nvSpPr>
         <p:spPr>
           <a:xfrm>
-            <a:off x="7600950" y="11144250"/>
-            <a:ext cx="2171700" cy="419100"/>
+            <a:off x="495300" y="9330690"/>
+            <a:ext cx="1737360" cy="342900"/>
           </a:xfrm>
           <a:prstGeom prst="rect">
             <a:avLst/>
@@ -5371,7 +5371,7 @@
               </a:lnSpc>
             </a:pPr>
             <a:r>
-              <a:rPr sz="1500" b="1" i="0">
+              <a:rPr sz="1200" b="1" i="0">
                 <a:solidFill>
                   <a:srgbClr val="31662F"/>
                 </a:solidFill>
@@ -5382,9 +5382,445 @@
           </a:p>
         </p:txBody>
       </p:sp>
-      <p:sp>
-        <p:nvSpPr>
-          <p:cNvPr id="46" name="TextBox 45"/>
+      <p:pic>
+        <p:nvPicPr>
+          <p:cNvPr id="46" name="Picture 45" descr="2904139003338272881.jpg"/>
+          <p:cNvPicPr>
+            <a:picLocks noChangeAspect="1"/>
+          </p:cNvPicPr>
+          <p:nvPr/>
+        </p:nvPicPr>
+        <p:blipFill>
+          <a:blip r:embed="rId17"/>
+          <a:stretch>
+            <a:fillRect/>
+          </a:stretch>
+        </p:blipFill>
+        <p:spPr>
+          <a:xfrm>
+            <a:off x="2346960" y="7860030"/>
+            <a:ext cx="1813560" cy="1813560"/>
+          </a:xfrm>
+          <a:prstGeom prst="rect">
+            <a:avLst/>
+          </a:prstGeom>
+        </p:spPr>
+      </p:pic>
+      <p:sp>
+        <p:nvSpPr>
+          <p:cNvPr id="47" name="Rectangle 46"/>
+          <p:cNvSpPr/>
+          <p:nvPr/>
+        </p:nvSpPr>
+        <p:spPr>
+          <a:xfrm>
+            <a:off x="2346960" y="9330690"/>
+            <a:ext cx="1813560" cy="342900"/>
+          </a:xfrm>
+          <a:prstGeom prst="rect">
+            <a:avLst/>
+          </a:prstGeom>
+          <a:solidFill>
+            <a:srgbClr val="F3F1EA">
+              <a:alpha val="88000"/>
+            </a:srgbClr>
+          </a:solidFill>
+          <a:ln>
+            <a:noFill/>
+          </a:ln>
+          <a:effectLst/>
+        </p:spPr>
+        <p:style>
+          <a:lnRef idx="1">
+            <a:schemeClr val="accent1"/>
+          </a:lnRef>
+          <a:fillRef idx="3">
+            <a:schemeClr val="accent1"/>
+          </a:fillRef>
+          <a:effectRef idx="2">
+            <a:schemeClr val="accent1"/>
+          </a:effectRef>
+          <a:fontRef idx="minor">
+            <a:schemeClr val="lt1"/>
+          </a:fontRef>
+        </p:style>
+        <p:txBody>
+          <a:bodyPr rtlCol="0" anchor="ctr"/>
+          <a:lstStyle/>
+          <a:p>
+            <a:pPr algn="ctr"/>
+          </a:p>
+        </p:txBody>
+      </p:sp>
+      <p:sp>
+        <p:nvSpPr>
+          <p:cNvPr id="48" name="TextBox 47"/>
+          <p:cNvSpPr txBox="1"/>
+          <p:nvPr/>
+        </p:nvSpPr>
+        <p:spPr>
+          <a:xfrm>
+            <a:off x="2385060" y="9330690"/>
+            <a:ext cx="1737360" cy="342900"/>
+          </a:xfrm>
+          <a:prstGeom prst="rect">
+            <a:avLst/>
+          </a:prstGeom>
+          <a:noFill/>
+        </p:spPr>
+        <p:txBody>
+          <a:bodyPr wrap="square" lIns="0" rIns="0" tIns="0" bIns="0" anchor="ctr">
+            <a:spAutoFit/>
+          </a:bodyPr>
+          <a:lstStyle/>
+          <a:p>
+            <a:pPr algn="ctr">
+              <a:lnSpc>
+                <a:spcPct val="120000"/>
+              </a:lnSpc>
+            </a:pPr>
+            <a:r>
+              <a:rPr sz="1200" b="1" i="0">
+                <a:solidFill>
+                  <a:srgbClr val="31662F"/>
+                </a:solidFill>
+                <a:latin typeface="Montserrat"/>
+              </a:rPr>
+              <a:t>Elina Psara</a:t>
+            </a:r>
+          </a:p>
+        </p:txBody>
+      </p:sp>
+      <p:pic>
+        <p:nvPicPr>
+          <p:cNvPr id="49" name="Picture 48" descr="7454114753255690645.jpg"/>
+          <p:cNvPicPr>
+            <a:picLocks noChangeAspect="1"/>
+          </p:cNvPicPr>
+          <p:nvPr/>
+        </p:nvPicPr>
+        <p:blipFill>
+          <a:blip r:embed="rId18"/>
+          <a:stretch>
+            <a:fillRect/>
+          </a:stretch>
+        </p:blipFill>
+        <p:spPr>
+          <a:xfrm>
+            <a:off x="4236720" y="7860030"/>
+            <a:ext cx="1813560" cy="1813560"/>
+          </a:xfrm>
+          <a:prstGeom prst="rect">
+            <a:avLst/>
+          </a:prstGeom>
+        </p:spPr>
+      </p:pic>
+      <p:sp>
+        <p:nvSpPr>
+          <p:cNvPr id="50" name="Rectangle 49"/>
+          <p:cNvSpPr/>
+          <p:nvPr/>
+        </p:nvSpPr>
+        <p:spPr>
+          <a:xfrm>
+            <a:off x="4236720" y="9330690"/>
+            <a:ext cx="1813560" cy="342900"/>
+          </a:xfrm>
+          <a:prstGeom prst="rect">
+            <a:avLst/>
+          </a:prstGeom>
+          <a:solidFill>
+            <a:srgbClr val="F3F1EA">
+              <a:alpha val="88000"/>
+            </a:srgbClr>
+          </a:solidFill>
+          <a:ln>
+            <a:noFill/>
+          </a:ln>
+          <a:effectLst/>
+        </p:spPr>
+        <p:style>
+          <a:lnRef idx="1">
+            <a:schemeClr val="accent1"/>
+          </a:lnRef>
+          <a:fillRef idx="3">
+            <a:schemeClr val="accent1"/>
+          </a:fillRef>
+          <a:effectRef idx="2">
+            <a:schemeClr val="accent1"/>
+          </a:effectRef>
+          <a:fontRef idx="minor">
+            <a:schemeClr val="lt1"/>
+          </a:fontRef>
+        </p:style>
+        <p:txBody>
+          <a:bodyPr rtlCol="0" anchor="ctr"/>
+          <a:lstStyle/>
+          <a:p>
+            <a:pPr algn="ctr"/>
+          </a:p>
+        </p:txBody>
+      </p:sp>
+      <p:sp>
+        <p:nvSpPr>
+          <p:cNvPr id="51" name="TextBox 50"/>
+          <p:cNvSpPr txBox="1"/>
+          <p:nvPr/>
+        </p:nvSpPr>
+        <p:spPr>
+          <a:xfrm>
+            <a:off x="4274820" y="9330690"/>
+            <a:ext cx="1737360" cy="342900"/>
+          </a:xfrm>
+          <a:prstGeom prst="rect">
+            <a:avLst/>
+          </a:prstGeom>
+          <a:noFill/>
+        </p:spPr>
+        <p:txBody>
+          <a:bodyPr wrap="square" lIns="0" rIns="0" tIns="0" bIns="0" anchor="ctr">
+            <a:spAutoFit/>
+          </a:bodyPr>
+          <a:lstStyle/>
+          <a:p>
+            <a:pPr algn="ctr">
+              <a:lnSpc>
+                <a:spcPct val="120000"/>
+              </a:lnSpc>
+            </a:pPr>
+            <a:r>
+              <a:rPr sz="1200" b="1" i="0">
+                <a:solidFill>
+                  <a:srgbClr val="31662F"/>
+                </a:solidFill>
+                <a:latin typeface="Montserrat"/>
+              </a:rPr>
+              <a:t>Caterina Capri</a:t>
+            </a:r>
+          </a:p>
+        </p:txBody>
+      </p:sp>
+      <p:pic>
+        <p:nvPicPr>
+          <p:cNvPr id="52" name="Picture 51" descr="8055802890071954999.jpg"/>
+          <p:cNvPicPr>
+            <a:picLocks noChangeAspect="1"/>
+          </p:cNvPicPr>
+          <p:nvPr/>
+        </p:nvPicPr>
+        <p:blipFill>
+          <a:blip r:embed="rId19"/>
+          <a:stretch>
+            <a:fillRect/>
+          </a:stretch>
+        </p:blipFill>
+        <p:spPr>
+          <a:xfrm>
+            <a:off x="6126480" y="7860030"/>
+            <a:ext cx="1813560" cy="1813560"/>
+          </a:xfrm>
+          <a:prstGeom prst="rect">
+            <a:avLst/>
+          </a:prstGeom>
+        </p:spPr>
+      </p:pic>
+      <p:sp>
+        <p:nvSpPr>
+          <p:cNvPr id="53" name="Rectangle 52"/>
+          <p:cNvSpPr/>
+          <p:nvPr/>
+        </p:nvSpPr>
+        <p:spPr>
+          <a:xfrm>
+            <a:off x="6126480" y="9330690"/>
+            <a:ext cx="1813560" cy="342900"/>
+          </a:xfrm>
+          <a:prstGeom prst="rect">
+            <a:avLst/>
+          </a:prstGeom>
+          <a:solidFill>
+            <a:srgbClr val="F3F1EA">
+              <a:alpha val="88000"/>
+            </a:srgbClr>
+          </a:solidFill>
+          <a:ln>
+            <a:noFill/>
+          </a:ln>
+          <a:effectLst/>
+        </p:spPr>
+        <p:style>
+          <a:lnRef idx="1">
+            <a:schemeClr val="accent1"/>
+          </a:lnRef>
+          <a:fillRef idx="3">
+            <a:schemeClr val="accent1"/>
+          </a:fillRef>
+          <a:effectRef idx="2">
+            <a:schemeClr val="accent1"/>
+          </a:effectRef>
+          <a:fontRef idx="minor">
+            <a:schemeClr val="lt1"/>
+          </a:fontRef>
+        </p:style>
+        <p:txBody>
+          <a:bodyPr rtlCol="0" anchor="ctr"/>
+          <a:lstStyle/>
+          <a:p>
+            <a:pPr algn="ctr"/>
+          </a:p>
+        </p:txBody>
+      </p:sp>
+      <p:sp>
+        <p:nvSpPr>
+          <p:cNvPr id="54" name="TextBox 53"/>
+          <p:cNvSpPr txBox="1"/>
+          <p:nvPr/>
+        </p:nvSpPr>
+        <p:spPr>
+          <a:xfrm>
+            <a:off x="6164580" y="9330690"/>
+            <a:ext cx="1737360" cy="342900"/>
+          </a:xfrm>
+          <a:prstGeom prst="rect">
+            <a:avLst/>
+          </a:prstGeom>
+          <a:noFill/>
+        </p:spPr>
+        <p:txBody>
+          <a:bodyPr wrap="square" lIns="0" rIns="0" tIns="0" bIns="0" anchor="ctr">
+            <a:spAutoFit/>
+          </a:bodyPr>
+          <a:lstStyle/>
+          <a:p>
+            <a:pPr algn="ctr">
+              <a:lnSpc>
+                <a:spcPct val="120000"/>
+              </a:lnSpc>
+            </a:pPr>
+            <a:r>
+              <a:rPr sz="1200" b="1" i="0">
+                <a:solidFill>
+                  <a:srgbClr val="31662F"/>
+                </a:solidFill>
+                <a:latin typeface="Montserrat"/>
+              </a:rPr>
+              <a:t>Laura Campos</a:t>
+            </a:r>
+          </a:p>
+        </p:txBody>
+      </p:sp>
+      <p:pic>
+        <p:nvPicPr>
+          <p:cNvPr id="55" name="Picture 54" descr="6327792871960472773.jpg"/>
+          <p:cNvPicPr>
+            <a:picLocks noChangeAspect="1"/>
+          </p:cNvPicPr>
+          <p:nvPr/>
+        </p:nvPicPr>
+        <p:blipFill>
+          <a:blip r:embed="rId20"/>
+          <a:stretch>
+            <a:fillRect/>
+          </a:stretch>
+        </p:blipFill>
+        <p:spPr>
+          <a:xfrm>
+            <a:off x="8016240" y="7860030"/>
+            <a:ext cx="1813560" cy="1813560"/>
+          </a:xfrm>
+          <a:prstGeom prst="rect">
+            <a:avLst/>
+          </a:prstGeom>
+        </p:spPr>
+      </p:pic>
+      <p:sp>
+        <p:nvSpPr>
+          <p:cNvPr id="56" name="Rectangle 55"/>
+          <p:cNvSpPr/>
+          <p:nvPr/>
+        </p:nvSpPr>
+        <p:spPr>
+          <a:xfrm>
+            <a:off x="8016240" y="9330690"/>
+            <a:ext cx="1813560" cy="342900"/>
+          </a:xfrm>
+          <a:prstGeom prst="rect">
+            <a:avLst/>
+          </a:prstGeom>
+          <a:solidFill>
+            <a:srgbClr val="F3F1EA">
+              <a:alpha val="88000"/>
+            </a:srgbClr>
+          </a:solidFill>
+          <a:ln>
+            <a:noFill/>
+          </a:ln>
+          <a:effectLst/>
+        </p:spPr>
+        <p:style>
+          <a:lnRef idx="1">
+            <a:schemeClr val="accent1"/>
+          </a:lnRef>
+          <a:fillRef idx="3">
+            <a:schemeClr val="accent1"/>
+          </a:fillRef>
+          <a:effectRef idx="2">
+            <a:schemeClr val="accent1"/>
+          </a:effectRef>
+          <a:fontRef idx="minor">
+            <a:schemeClr val="lt1"/>
+          </a:fontRef>
+        </p:style>
+        <p:txBody>
+          <a:bodyPr rtlCol="0" anchor="ctr"/>
+          <a:lstStyle/>
+          <a:p>
+            <a:pPr algn="ctr"/>
+          </a:p>
+        </p:txBody>
+      </p:sp>
+      <p:sp>
+        <p:nvSpPr>
+          <p:cNvPr id="57" name="TextBox 56"/>
+          <p:cNvSpPr txBox="1"/>
+          <p:nvPr/>
+        </p:nvSpPr>
+        <p:spPr>
+          <a:xfrm>
+            <a:off x="8054340" y="9330690"/>
+            <a:ext cx="1737360" cy="342900"/>
+          </a:xfrm>
+          <a:prstGeom prst="rect">
+            <a:avLst/>
+          </a:prstGeom>
+          <a:noFill/>
+        </p:spPr>
+        <p:txBody>
+          <a:bodyPr wrap="square" lIns="0" rIns="0" tIns="0" bIns="0" anchor="ctr">
+            <a:spAutoFit/>
+          </a:bodyPr>
+          <a:lstStyle/>
+          <a:p>
+            <a:pPr algn="ctr">
+              <a:lnSpc>
+                <a:spcPct val="120000"/>
+              </a:lnSpc>
+            </a:pPr>
+            <a:r>
+              <a:rPr sz="1200" b="1" i="0">
+                <a:solidFill>
+                  <a:srgbClr val="31662F"/>
+                </a:solidFill>
+                <a:latin typeface="Montserrat"/>
+              </a:rPr>
+              <a:t>Nora Levay</a:t>
+            </a:r>
+          </a:p>
+        </p:txBody>
+      </p:sp>
+      <p:sp>
+        <p:nvSpPr>
+          <p:cNvPr id="58" name="TextBox 57"/>
           <p:cNvSpPr txBox="1"/>
           <p:nvPr/>
         </p:nvSpPr>

</xml_diff>

<commit_message>
Teachers' Day: remove four people not on the team now; 14 mentors, two per slide, 10 slides; names as Linnea gave them
Co-Authored-By: Claude Opus 5.5 <noreply@anthropic.com>
Claude-Session: https://claude.ai/code/session_014HGzAbxBh54nuyJHG7tse8
</commit_message>
<xml_diff>
--- a/templates/posts/october/05-10-2026-mon-ig-teachers-day-option-1-photo.pptx
+++ b/templates/posts/october/05-10-2026-mon-ig-teachers-day-option-1-photo.pptx
@@ -3589,7 +3589,7 @@
       <p:grpSpPr/>
       <p:pic>
         <p:nvPicPr>
-          <p:cNvPr id="2" name="Picture 1" descr="209207550916773552.jpg"/>
+          <p:cNvPr id="2" name="Picture 1" descr="3532853474161955303.jpg"/>
           <p:cNvPicPr>
             <a:picLocks noChangeAspect="1"/>
           </p:cNvPicPr>
@@ -3826,7 +3826,7 @@
         <p:spPr>
           <a:xfrm>
             <a:off x="495300" y="2190750"/>
-            <a:ext cx="3627120" cy="1813560"/>
+            <a:ext cx="4572000" cy="2286000"/>
           </a:xfrm>
           <a:prstGeom prst="rect">
             <a:avLst/>
@@ -3845,7 +3845,7 @@
               </a:lnSpc>
             </a:pPr>
             <a:r>
-              <a:rPr sz="3400" b="1" i="0">
+              <a:rPr sz="4000" b="1" i="0">
                 <a:solidFill>
                   <a:srgbClr val="31662F"/>
                 </a:solidFill>
@@ -3858,7 +3858,7 @@
       </p:sp>
       <p:pic>
         <p:nvPicPr>
-          <p:cNvPr id="4" name="Picture 3" descr="1752988849223235031.jpg"/>
+          <p:cNvPr id="4" name="Picture 3" descr="7297811591439890433.jpg"/>
           <p:cNvPicPr>
             <a:picLocks noChangeAspect="1"/>
           </p:cNvPicPr>
@@ -3872,8 +3872,8 @@
         </p:blipFill>
         <p:spPr>
           <a:xfrm>
-            <a:off x="4236720" y="2190750"/>
-            <a:ext cx="1813560" cy="1813560"/>
+            <a:off x="5181600" y="2190750"/>
+            <a:ext cx="2286000" cy="2286000"/>
           </a:xfrm>
           <a:prstGeom prst="rect">
             <a:avLst/>
@@ -3888,8 +3888,8 @@
         </p:nvSpPr>
         <p:spPr>
           <a:xfrm>
-            <a:off x="4236720" y="3661410"/>
-            <a:ext cx="1813560" cy="342900"/>
+            <a:off x="5181600" y="4133850"/>
+            <a:ext cx="2286000" cy="342900"/>
           </a:xfrm>
           <a:prstGeom prst="rect">
             <a:avLst/>
@@ -3934,8 +3934,8 @@
         </p:nvSpPr>
         <p:spPr>
           <a:xfrm>
-            <a:off x="4274820" y="3661410"/>
-            <a:ext cx="1737360" cy="342900"/>
+            <a:off x="5219700" y="4133850"/>
+            <a:ext cx="2209800" cy="342900"/>
           </a:xfrm>
           <a:prstGeom prst="rect">
             <a:avLst/>
@@ -3954,20 +3954,20 @@
               </a:lnSpc>
             </a:pPr>
             <a:r>
-              <a:rPr sz="1200" b="1" i="0">
+              <a:rPr sz="1500" b="1" i="0">
                 <a:solidFill>
                   <a:srgbClr val="31662F"/>
                 </a:solidFill>
                 <a:latin typeface="Montserrat"/>
               </a:rPr>
-              <a:t>Tommy Tepper</a:t>
+              <a:t>Tommy Tapper</a:t>
             </a:r>
           </a:p>
         </p:txBody>
       </p:sp>
       <p:pic>
         <p:nvPicPr>
-          <p:cNvPr id="7" name="Picture 6" descr="2612131318617217853.jpg"/>
+          <p:cNvPr id="7" name="Picture 6" descr="8728437986854537801.jpg"/>
           <p:cNvPicPr>
             <a:picLocks noChangeAspect="1"/>
           </p:cNvPicPr>
@@ -3981,8 +3981,8 @@
         </p:blipFill>
         <p:spPr>
           <a:xfrm>
-            <a:off x="6126480" y="2190750"/>
-            <a:ext cx="1813560" cy="1813560"/>
+            <a:off x="7543800" y="2190750"/>
+            <a:ext cx="2286000" cy="2286000"/>
           </a:xfrm>
           <a:prstGeom prst="rect">
             <a:avLst/>
@@ -3997,8 +3997,8 @@
         </p:nvSpPr>
         <p:spPr>
           <a:xfrm>
-            <a:off x="6126480" y="3661410"/>
-            <a:ext cx="1813560" cy="342900"/>
+            <a:off x="7543800" y="4133850"/>
+            <a:ext cx="2286000" cy="342900"/>
           </a:xfrm>
           <a:prstGeom prst="rect">
             <a:avLst/>
@@ -4043,8 +4043,8 @@
         </p:nvSpPr>
         <p:spPr>
           <a:xfrm>
-            <a:off x="6164580" y="3661410"/>
-            <a:ext cx="1737360" cy="342900"/>
+            <a:off x="7581900" y="4133850"/>
+            <a:ext cx="2209800" cy="342900"/>
           </a:xfrm>
           <a:prstGeom prst="rect">
             <a:avLst/>
@@ -4063,7 +4063,7 @@
               </a:lnSpc>
             </a:pPr>
             <a:r>
-              <a:rPr sz="1200" b="1" i="0">
+              <a:rPr sz="1500" b="1" i="0">
                 <a:solidFill>
                   <a:srgbClr val="31662F"/>
                 </a:solidFill>
@@ -4076,7 +4076,7 @@
       </p:sp>
       <p:pic>
         <p:nvPicPr>
-          <p:cNvPr id="10" name="Picture 9" descr="7144932367790493661.jpg"/>
+          <p:cNvPr id="10" name="Picture 9" descr="8499503155804001537.jpg"/>
           <p:cNvPicPr>
             <a:picLocks noChangeAspect="1"/>
           </p:cNvPicPr>
@@ -4090,8 +4090,8 @@
         </p:blipFill>
         <p:spPr>
           <a:xfrm>
-            <a:off x="8016240" y="2190750"/>
-            <a:ext cx="1813560" cy="1813560"/>
+            <a:off x="457200" y="4552950"/>
+            <a:ext cx="2286000" cy="2286000"/>
           </a:xfrm>
           <a:prstGeom prst="rect">
             <a:avLst/>
@@ -4106,8 +4106,8 @@
         </p:nvSpPr>
         <p:spPr>
           <a:xfrm>
-            <a:off x="8016240" y="3661410"/>
-            <a:ext cx="1813560" cy="342900"/>
+            <a:off x="457200" y="6496050"/>
+            <a:ext cx="2286000" cy="342900"/>
           </a:xfrm>
           <a:prstGeom prst="rect">
             <a:avLst/>
@@ -4152,8 +4152,8 @@
         </p:nvSpPr>
         <p:spPr>
           <a:xfrm>
-            <a:off x="8054340" y="3661410"/>
-            <a:ext cx="1737360" cy="342900"/>
+            <a:off x="495300" y="6496050"/>
+            <a:ext cx="2209800" cy="342900"/>
           </a:xfrm>
           <a:prstGeom prst="rect">
             <a:avLst/>
@@ -4172,7 +4172,7 @@
               </a:lnSpc>
             </a:pPr>
             <a:r>
-              <a:rPr sz="1200" b="1" i="0">
+              <a:rPr sz="1500" b="1" i="0">
                 <a:solidFill>
                   <a:srgbClr val="31662F"/>
                 </a:solidFill>
@@ -4185,7 +4185,7 @@
       </p:sp>
       <p:pic>
         <p:nvPicPr>
-          <p:cNvPr id="13" name="Picture 12" descr="1194488140148190033.jpg"/>
+          <p:cNvPr id="13" name="Picture 12" descr="8664505731163078658.jpg"/>
           <p:cNvPicPr>
             <a:picLocks noChangeAspect="1"/>
           </p:cNvPicPr>
@@ -4199,8 +4199,8 @@
         </p:blipFill>
         <p:spPr>
           <a:xfrm>
-            <a:off x="457200" y="4080510"/>
-            <a:ext cx="1813560" cy="1813560"/>
+            <a:off x="2819400" y="4552950"/>
+            <a:ext cx="2286000" cy="2286000"/>
           </a:xfrm>
           <a:prstGeom prst="rect">
             <a:avLst/>
@@ -4215,8 +4215,8 @@
         </p:nvSpPr>
         <p:spPr>
           <a:xfrm>
-            <a:off x="457200" y="5551170"/>
-            <a:ext cx="1813560" cy="342900"/>
+            <a:off x="2819400" y="6496050"/>
+            <a:ext cx="2286000" cy="342900"/>
           </a:xfrm>
           <a:prstGeom prst="rect">
             <a:avLst/>
@@ -4261,8 +4261,8 @@
         </p:nvSpPr>
         <p:spPr>
           <a:xfrm>
-            <a:off x="495300" y="5551170"/>
-            <a:ext cx="1737360" cy="342900"/>
+            <a:off x="2857500" y="6496050"/>
+            <a:ext cx="2209800" cy="342900"/>
           </a:xfrm>
           <a:prstGeom prst="rect">
             <a:avLst/>
@@ -4281,20 +4281,20 @@
               </a:lnSpc>
             </a:pPr>
             <a:r>
-              <a:rPr sz="1200" b="1" i="0">
+              <a:rPr sz="1500" b="1" i="0">
                 <a:solidFill>
                   <a:srgbClr val="31662F"/>
                 </a:solidFill>
                 <a:latin typeface="Montserrat"/>
               </a:rPr>
-              <a:t>Wesley Sanders</a:t>
+              <a:t>Wesley Sander</a:t>
             </a:r>
           </a:p>
         </p:txBody>
       </p:sp>
       <p:pic>
         <p:nvPicPr>
-          <p:cNvPr id="16" name="Picture 15" descr="8647953704869287552.jpg"/>
+          <p:cNvPr id="16" name="Picture 15" descr="7695145214115977211.jpg"/>
           <p:cNvPicPr>
             <a:picLocks noChangeAspect="1"/>
           </p:cNvPicPr>
@@ -4308,8 +4308,8 @@
         </p:blipFill>
         <p:spPr>
           <a:xfrm>
-            <a:off x="2346960" y="4080510"/>
-            <a:ext cx="1813560" cy="1813560"/>
+            <a:off x="5181600" y="4552950"/>
+            <a:ext cx="2286000" cy="2286000"/>
           </a:xfrm>
           <a:prstGeom prst="rect">
             <a:avLst/>
@@ -4324,8 +4324,8 @@
         </p:nvSpPr>
         <p:spPr>
           <a:xfrm>
-            <a:off x="2346960" y="5551170"/>
-            <a:ext cx="1813560" cy="342900"/>
+            <a:off x="5181600" y="6496050"/>
+            <a:ext cx="2286000" cy="342900"/>
           </a:xfrm>
           <a:prstGeom prst="rect">
             <a:avLst/>
@@ -4370,8 +4370,8 @@
         </p:nvSpPr>
         <p:spPr>
           <a:xfrm>
-            <a:off x="2385060" y="5551170"/>
-            <a:ext cx="1737360" cy="342900"/>
+            <a:off x="5219700" y="6496050"/>
+            <a:ext cx="2209800" cy="342900"/>
           </a:xfrm>
           <a:prstGeom prst="rect">
             <a:avLst/>
@@ -4390,7 +4390,7 @@
               </a:lnSpc>
             </a:pPr>
             <a:r>
-              <a:rPr sz="1200" b="1" i="0">
+              <a:rPr sz="1500" b="1" i="0">
                 <a:solidFill>
                   <a:srgbClr val="31662F"/>
                 </a:solidFill>
@@ -4403,7 +4403,7 @@
       </p:sp>
       <p:pic>
         <p:nvPicPr>
-          <p:cNvPr id="19" name="Picture 18" descr="6026637821407471426.jpg"/>
+          <p:cNvPr id="19" name="Picture 18" descr="1311806062584278399.jpg"/>
           <p:cNvPicPr>
             <a:picLocks noChangeAspect="1"/>
           </p:cNvPicPr>
@@ -4417,8 +4417,8 @@
         </p:blipFill>
         <p:spPr>
           <a:xfrm>
-            <a:off x="4236720" y="4080510"/>
-            <a:ext cx="1813560" cy="1813560"/>
+            <a:off x="7543800" y="4552950"/>
+            <a:ext cx="2286000" cy="2286000"/>
           </a:xfrm>
           <a:prstGeom prst="rect">
             <a:avLst/>
@@ -4433,8 +4433,8 @@
         </p:nvSpPr>
         <p:spPr>
           <a:xfrm>
-            <a:off x="4236720" y="5551170"/>
-            <a:ext cx="1813560" cy="342900"/>
+            <a:off x="7543800" y="6496050"/>
+            <a:ext cx="2286000" cy="342900"/>
           </a:xfrm>
           <a:prstGeom prst="rect">
             <a:avLst/>
@@ -4479,8 +4479,8 @@
         </p:nvSpPr>
         <p:spPr>
           <a:xfrm>
-            <a:off x="4274820" y="5551170"/>
-            <a:ext cx="1737360" cy="342900"/>
+            <a:off x="7581900" y="6496050"/>
+            <a:ext cx="2209800" cy="342900"/>
           </a:xfrm>
           <a:prstGeom prst="rect">
             <a:avLst/>
@@ -4499,7 +4499,7 @@
               </a:lnSpc>
             </a:pPr>
             <a:r>
-              <a:rPr sz="1200" b="1" i="0">
+              <a:rPr sz="1500" b="1" i="0">
                 <a:solidFill>
                   <a:srgbClr val="31662F"/>
                 </a:solidFill>
@@ -4512,7 +4512,7 @@
       </p:sp>
       <p:pic>
         <p:nvPicPr>
-          <p:cNvPr id="22" name="Picture 21" descr="3723017669234027646.jpg"/>
+          <p:cNvPr id="22" name="Picture 21" descr="5215010633690581301.jpg"/>
           <p:cNvPicPr>
             <a:picLocks noChangeAspect="1"/>
           </p:cNvPicPr>
@@ -4526,8 +4526,8 @@
         </p:blipFill>
         <p:spPr>
           <a:xfrm>
-            <a:off x="6126480" y="4080510"/>
-            <a:ext cx="1813560" cy="1813560"/>
+            <a:off x="457200" y="6915150"/>
+            <a:ext cx="2286000" cy="2286000"/>
           </a:xfrm>
           <a:prstGeom prst="rect">
             <a:avLst/>
@@ -4542,8 +4542,8 @@
         </p:nvSpPr>
         <p:spPr>
           <a:xfrm>
-            <a:off x="6126480" y="5551170"/>
-            <a:ext cx="1813560" cy="342900"/>
+            <a:off x="457200" y="8858250"/>
+            <a:ext cx="2286000" cy="342900"/>
           </a:xfrm>
           <a:prstGeom prst="rect">
             <a:avLst/>
@@ -4588,8 +4588,8 @@
         </p:nvSpPr>
         <p:spPr>
           <a:xfrm>
-            <a:off x="6164580" y="5551170"/>
-            <a:ext cx="1737360" cy="342900"/>
+            <a:off x="495300" y="8858250"/>
+            <a:ext cx="2209800" cy="342900"/>
           </a:xfrm>
           <a:prstGeom prst="rect">
             <a:avLst/>
@@ -4608,20 +4608,20 @@
               </a:lnSpc>
             </a:pPr>
             <a:r>
-              <a:rPr sz="1200" b="1" i="0">
+              <a:rPr sz="1500" b="1" i="0">
                 <a:solidFill>
                   <a:srgbClr val="31662F"/>
                 </a:solidFill>
                 <a:latin typeface="Montserrat"/>
               </a:rPr>
-              <a:t>Isadora Schmidt</a:t>
+              <a:t>Isadora Shmidt</a:t>
             </a:r>
           </a:p>
         </p:txBody>
       </p:sp>
       <p:pic>
         <p:nvPicPr>
-          <p:cNvPr id="25" name="Picture 24" descr="3113535558271719414.jpg"/>
+          <p:cNvPr id="25" name="Picture 24" descr="746667493973784667.jpg"/>
           <p:cNvPicPr>
             <a:picLocks noChangeAspect="1"/>
           </p:cNvPicPr>
@@ -4635,8 +4635,8 @@
         </p:blipFill>
         <p:spPr>
           <a:xfrm>
-            <a:off x="8016240" y="4080510"/>
-            <a:ext cx="1813560" cy="1813560"/>
+            <a:off x="2819400" y="6915150"/>
+            <a:ext cx="2286000" cy="2286000"/>
           </a:xfrm>
           <a:prstGeom prst="rect">
             <a:avLst/>
@@ -4651,8 +4651,8 @@
         </p:nvSpPr>
         <p:spPr>
           <a:xfrm>
-            <a:off x="8016240" y="5551170"/>
-            <a:ext cx="1813560" cy="342900"/>
+            <a:off x="2819400" y="8858250"/>
+            <a:ext cx="2286000" cy="342900"/>
           </a:xfrm>
           <a:prstGeom prst="rect">
             <a:avLst/>
@@ -4697,8 +4697,8 @@
         </p:nvSpPr>
         <p:spPr>
           <a:xfrm>
-            <a:off x="8054340" y="5551170"/>
-            <a:ext cx="1737360" cy="342900"/>
+            <a:off x="2857500" y="8858250"/>
+            <a:ext cx="2209800" cy="342900"/>
           </a:xfrm>
           <a:prstGeom prst="rect">
             <a:avLst/>
@@ -4717,7 +4717,7 @@
               </a:lnSpc>
             </a:pPr>
             <a:r>
-              <a:rPr sz="1200" b="1" i="0">
+              <a:rPr sz="1500" b="1" i="0">
                 <a:solidFill>
                   <a:srgbClr val="31662F"/>
                 </a:solidFill>
@@ -4730,7 +4730,7 @@
       </p:sp>
       <p:pic>
         <p:nvPicPr>
-          <p:cNvPr id="28" name="Picture 27" descr="5414851247296223470.jpg"/>
+          <p:cNvPr id="28" name="Picture 27" descr="4763296968275485648.jpg"/>
           <p:cNvPicPr>
             <a:picLocks noChangeAspect="1"/>
           </p:cNvPicPr>
@@ -4744,8 +4744,8 @@
         </p:blipFill>
         <p:spPr>
           <a:xfrm>
-            <a:off x="457200" y="5970270"/>
-            <a:ext cx="1813560" cy="1813560"/>
+            <a:off x="5181600" y="6915150"/>
+            <a:ext cx="2286000" cy="2286000"/>
           </a:xfrm>
           <a:prstGeom prst="rect">
             <a:avLst/>
@@ -4760,8 +4760,8 @@
         </p:nvSpPr>
         <p:spPr>
           <a:xfrm>
-            <a:off x="457200" y="7440929"/>
-            <a:ext cx="1813560" cy="342900"/>
+            <a:off x="5181600" y="8858250"/>
+            <a:ext cx="2286000" cy="342900"/>
           </a:xfrm>
           <a:prstGeom prst="rect">
             <a:avLst/>
@@ -4806,8 +4806,8 @@
         </p:nvSpPr>
         <p:spPr>
           <a:xfrm>
-            <a:off x="495300" y="7440929"/>
-            <a:ext cx="1737360" cy="342900"/>
+            <a:off x="5219700" y="8858250"/>
+            <a:ext cx="2209800" cy="342900"/>
           </a:xfrm>
           <a:prstGeom prst="rect">
             <a:avLst/>
@@ -4826,7 +4826,7 @@
               </a:lnSpc>
             </a:pPr>
             <a:r>
-              <a:rPr sz="1200" b="1" i="0">
+              <a:rPr sz="1500" b="1" i="0">
                 <a:solidFill>
                   <a:srgbClr val="31662F"/>
                 </a:solidFill>
@@ -4839,7 +4839,7 @@
       </p:sp>
       <p:pic>
         <p:nvPicPr>
-          <p:cNvPr id="31" name="Picture 30" descr="6759120478498615729.jpg"/>
+          <p:cNvPr id="31" name="Picture 30" descr="5135560565093357647.jpg"/>
           <p:cNvPicPr>
             <a:picLocks noChangeAspect="1"/>
           </p:cNvPicPr>
@@ -4853,8 +4853,8 @@
         </p:blipFill>
         <p:spPr>
           <a:xfrm>
-            <a:off x="2346960" y="5970270"/>
-            <a:ext cx="1813560" cy="1813560"/>
+            <a:off x="7543800" y="6915150"/>
+            <a:ext cx="2286000" cy="2286000"/>
           </a:xfrm>
           <a:prstGeom prst="rect">
             <a:avLst/>
@@ -4869,8 +4869,8 @@
         </p:nvSpPr>
         <p:spPr>
           <a:xfrm>
-            <a:off x="2346960" y="7440929"/>
-            <a:ext cx="1813560" cy="342900"/>
+            <a:off x="7543800" y="8858250"/>
+            <a:ext cx="2286000" cy="342900"/>
           </a:xfrm>
           <a:prstGeom prst="rect">
             <a:avLst/>
@@ -4915,8 +4915,8 @@
         </p:nvSpPr>
         <p:spPr>
           <a:xfrm>
-            <a:off x="2385060" y="7440929"/>
-            <a:ext cx="1737360" cy="342900"/>
+            <a:off x="7581900" y="8858250"/>
+            <a:ext cx="2209800" cy="342900"/>
           </a:xfrm>
           <a:prstGeom prst="rect">
             <a:avLst/>
@@ -4935,7 +4935,7 @@
               </a:lnSpc>
             </a:pPr>
             <a:r>
-              <a:rPr sz="1200" b="1" i="0">
+              <a:rPr sz="1500" b="1" i="0">
                 <a:solidFill>
                   <a:srgbClr val="31662F"/>
                 </a:solidFill>
@@ -4948,7 +4948,7 @@
       </p:sp>
       <p:pic>
         <p:nvPicPr>
-          <p:cNvPr id="34" name="Picture 33" descr="9169552863569812281.jpg"/>
+          <p:cNvPr id="34" name="Picture 33" descr="1228326016823983096.jpg"/>
           <p:cNvPicPr>
             <a:picLocks noChangeAspect="1"/>
           </p:cNvPicPr>
@@ -4962,8 +4962,8 @@
         </p:blipFill>
         <p:spPr>
           <a:xfrm>
-            <a:off x="4236720" y="5970270"/>
-            <a:ext cx="1813560" cy="1813560"/>
+            <a:off x="457200" y="9277350"/>
+            <a:ext cx="2286000" cy="2286000"/>
           </a:xfrm>
           <a:prstGeom prst="rect">
             <a:avLst/>
@@ -4978,8 +4978,8 @@
         </p:nvSpPr>
         <p:spPr>
           <a:xfrm>
-            <a:off x="4236720" y="7440929"/>
-            <a:ext cx="1813560" cy="342900"/>
+            <a:off x="457200" y="11220450"/>
+            <a:ext cx="2286000" cy="342900"/>
           </a:xfrm>
           <a:prstGeom prst="rect">
             <a:avLst/>
@@ -5024,8 +5024,8 @@
         </p:nvSpPr>
         <p:spPr>
           <a:xfrm>
-            <a:off x="4274820" y="7440929"/>
-            <a:ext cx="1737360" cy="342900"/>
+            <a:off x="495300" y="11220450"/>
+            <a:ext cx="2209800" cy="342900"/>
           </a:xfrm>
           <a:prstGeom prst="rect">
             <a:avLst/>
@@ -5044,7 +5044,7 @@
               </a:lnSpc>
             </a:pPr>
             <a:r>
-              <a:rPr sz="1200" b="1" i="0">
+              <a:rPr sz="1500" b="1" i="0">
                 <a:solidFill>
                   <a:srgbClr val="31662F"/>
                 </a:solidFill>
@@ -5057,7 +5057,7 @@
       </p:sp>
       <p:pic>
         <p:nvPicPr>
-          <p:cNvPr id="37" name="Picture 36" descr="6225129540398821112.jpg"/>
+          <p:cNvPr id="37" name="Picture 36" descr="2663829795774334274.jpg"/>
           <p:cNvPicPr>
             <a:picLocks noChangeAspect="1"/>
           </p:cNvPicPr>
@@ -5071,8 +5071,8 @@
         </p:blipFill>
         <p:spPr>
           <a:xfrm>
-            <a:off x="6126480" y="5970270"/>
-            <a:ext cx="1813560" cy="1813560"/>
+            <a:off x="2819400" y="9277350"/>
+            <a:ext cx="2286000" cy="2286000"/>
           </a:xfrm>
           <a:prstGeom prst="rect">
             <a:avLst/>
@@ -5087,8 +5087,8 @@
         </p:nvSpPr>
         <p:spPr>
           <a:xfrm>
-            <a:off x="6126480" y="7440929"/>
-            <a:ext cx="1813560" cy="342900"/>
+            <a:off x="2819400" y="11220450"/>
+            <a:ext cx="2286000" cy="342900"/>
           </a:xfrm>
           <a:prstGeom prst="rect">
             <a:avLst/>
@@ -5133,8 +5133,8 @@
         </p:nvSpPr>
         <p:spPr>
           <a:xfrm>
-            <a:off x="6164580" y="7440929"/>
-            <a:ext cx="1737360" cy="342900"/>
+            <a:off x="2857500" y="11220450"/>
+            <a:ext cx="2209800" cy="342900"/>
           </a:xfrm>
           <a:prstGeom prst="rect">
             <a:avLst/>
@@ -5153,7 +5153,7 @@
               </a:lnSpc>
             </a:pPr>
             <a:r>
-              <a:rPr sz="1200" b="1" i="0">
+              <a:rPr sz="1500" b="1" i="0">
                 <a:solidFill>
                   <a:srgbClr val="31662F"/>
                 </a:solidFill>
@@ -5166,7 +5166,7 @@
       </p:sp>
       <p:pic>
         <p:nvPicPr>
-          <p:cNvPr id="40" name="Picture 39" descr="6957233813328317874.jpg"/>
+          <p:cNvPr id="40" name="Picture 39" descr="8496695976596084521.jpg"/>
           <p:cNvPicPr>
             <a:picLocks noChangeAspect="1"/>
           </p:cNvPicPr>
@@ -5180,8 +5180,8 @@
         </p:blipFill>
         <p:spPr>
           <a:xfrm>
-            <a:off x="8016240" y="5970270"/>
-            <a:ext cx="1813560" cy="1813560"/>
+            <a:off x="5181600" y="9277350"/>
+            <a:ext cx="2286000" cy="2286000"/>
           </a:xfrm>
           <a:prstGeom prst="rect">
             <a:avLst/>
@@ -5196,8 +5196,8 @@
         </p:nvSpPr>
         <p:spPr>
           <a:xfrm>
-            <a:off x="8016240" y="7440929"/>
-            <a:ext cx="1813560" cy="342900"/>
+            <a:off x="5181600" y="11220450"/>
+            <a:ext cx="2286000" cy="342900"/>
           </a:xfrm>
           <a:prstGeom prst="rect">
             <a:avLst/>
@@ -5242,8 +5242,8 @@
         </p:nvSpPr>
         <p:spPr>
           <a:xfrm>
-            <a:off x="8054340" y="7440929"/>
-            <a:ext cx="1737360" cy="342900"/>
+            <a:off x="5219700" y="11220450"/>
+            <a:ext cx="2209800" cy="342900"/>
           </a:xfrm>
           <a:prstGeom prst="rect">
             <a:avLst/>
@@ -5262,7 +5262,7 @@
               </a:lnSpc>
             </a:pPr>
             <a:r>
-              <a:rPr sz="1200" b="1" i="0">
+              <a:rPr sz="1500" b="1" i="0">
                 <a:solidFill>
                   <a:srgbClr val="31662F"/>
                 </a:solidFill>
@@ -5275,7 +5275,7 @@
       </p:sp>
       <p:pic>
         <p:nvPicPr>
-          <p:cNvPr id="43" name="Picture 42" descr="6998284926264825370.jpg"/>
+          <p:cNvPr id="43" name="Picture 42" descr="8052758747183003055.jpg"/>
           <p:cNvPicPr>
             <a:picLocks noChangeAspect="1"/>
           </p:cNvPicPr>
@@ -5289,8 +5289,8 @@
         </p:blipFill>
         <p:spPr>
           <a:xfrm>
-            <a:off x="457200" y="7860030"/>
-            <a:ext cx="1813560" cy="1813560"/>
+            <a:off x="7543800" y="9277350"/>
+            <a:ext cx="2286000" cy="2286000"/>
           </a:xfrm>
           <a:prstGeom prst="rect">
             <a:avLst/>
@@ -5305,8 +5305,8 @@
         </p:nvSpPr>
         <p:spPr>
           <a:xfrm>
-            <a:off x="457200" y="9330690"/>
-            <a:ext cx="1813560" cy="342900"/>
+            <a:off x="7543800" y="11220450"/>
+            <a:ext cx="2286000" cy="342900"/>
           </a:xfrm>
           <a:prstGeom prst="rect">
             <a:avLst/>
@@ -5351,8 +5351,8 @@
         </p:nvSpPr>
         <p:spPr>
           <a:xfrm>
-            <a:off x="495300" y="9330690"/>
-            <a:ext cx="1737360" cy="342900"/>
+            <a:off x="7581900" y="11220450"/>
+            <a:ext cx="2209800" cy="342900"/>
           </a:xfrm>
           <a:prstGeom prst="rect">
             <a:avLst/>
@@ -5371,7 +5371,7 @@
               </a:lnSpc>
             </a:pPr>
             <a:r>
-              <a:rPr sz="1200" b="1" i="0">
+              <a:rPr sz="1500" b="1" i="0">
                 <a:solidFill>
                   <a:srgbClr val="31662F"/>
                 </a:solidFill>
@@ -5382,445 +5382,9 @@
           </a:p>
         </p:txBody>
       </p:sp>
-      <p:pic>
-        <p:nvPicPr>
-          <p:cNvPr id="46" name="Picture 45" descr="2904139003338272881.jpg"/>
-          <p:cNvPicPr>
-            <a:picLocks noChangeAspect="1"/>
-          </p:cNvPicPr>
-          <p:nvPr/>
-        </p:nvPicPr>
-        <p:blipFill>
-          <a:blip r:embed="rId17"/>
-          <a:stretch>
-            <a:fillRect/>
-          </a:stretch>
-        </p:blipFill>
-        <p:spPr>
-          <a:xfrm>
-            <a:off x="2346960" y="7860030"/>
-            <a:ext cx="1813560" cy="1813560"/>
-          </a:xfrm>
-          <a:prstGeom prst="rect">
-            <a:avLst/>
-          </a:prstGeom>
-        </p:spPr>
-      </p:pic>
-      <p:sp>
-        <p:nvSpPr>
-          <p:cNvPr id="47" name="Rectangle 46"/>
-          <p:cNvSpPr/>
-          <p:nvPr/>
-        </p:nvSpPr>
-        <p:spPr>
-          <a:xfrm>
-            <a:off x="2346960" y="9330690"/>
-            <a:ext cx="1813560" cy="342900"/>
-          </a:xfrm>
-          <a:prstGeom prst="rect">
-            <a:avLst/>
-          </a:prstGeom>
-          <a:solidFill>
-            <a:srgbClr val="F3F1EA">
-              <a:alpha val="88000"/>
-            </a:srgbClr>
-          </a:solidFill>
-          <a:ln>
-            <a:noFill/>
-          </a:ln>
-          <a:effectLst/>
-        </p:spPr>
-        <p:style>
-          <a:lnRef idx="1">
-            <a:schemeClr val="accent1"/>
-          </a:lnRef>
-          <a:fillRef idx="3">
-            <a:schemeClr val="accent1"/>
-          </a:fillRef>
-          <a:effectRef idx="2">
-            <a:schemeClr val="accent1"/>
-          </a:effectRef>
-          <a:fontRef idx="minor">
-            <a:schemeClr val="lt1"/>
-          </a:fontRef>
-        </p:style>
-        <p:txBody>
-          <a:bodyPr rtlCol="0" anchor="ctr"/>
-          <a:lstStyle/>
-          <a:p>
-            <a:pPr algn="ctr"/>
-          </a:p>
-        </p:txBody>
-      </p:sp>
-      <p:sp>
-        <p:nvSpPr>
-          <p:cNvPr id="48" name="TextBox 47"/>
-          <p:cNvSpPr txBox="1"/>
-          <p:nvPr/>
-        </p:nvSpPr>
-        <p:spPr>
-          <a:xfrm>
-            <a:off x="2385060" y="9330690"/>
-            <a:ext cx="1737360" cy="342900"/>
-          </a:xfrm>
-          <a:prstGeom prst="rect">
-            <a:avLst/>
-          </a:prstGeom>
-          <a:noFill/>
-        </p:spPr>
-        <p:txBody>
-          <a:bodyPr wrap="square" lIns="0" rIns="0" tIns="0" bIns="0" anchor="ctr">
-            <a:spAutoFit/>
-          </a:bodyPr>
-          <a:lstStyle/>
-          <a:p>
-            <a:pPr algn="ctr">
-              <a:lnSpc>
-                <a:spcPct val="120000"/>
-              </a:lnSpc>
-            </a:pPr>
-            <a:r>
-              <a:rPr sz="1200" b="1" i="0">
-                <a:solidFill>
-                  <a:srgbClr val="31662F"/>
-                </a:solidFill>
-                <a:latin typeface="Montserrat"/>
-              </a:rPr>
-              <a:t>Elina Psara</a:t>
-            </a:r>
-          </a:p>
-        </p:txBody>
-      </p:sp>
-      <p:pic>
-        <p:nvPicPr>
-          <p:cNvPr id="49" name="Picture 48" descr="7454114753255690645.jpg"/>
-          <p:cNvPicPr>
-            <a:picLocks noChangeAspect="1"/>
-          </p:cNvPicPr>
-          <p:nvPr/>
-        </p:nvPicPr>
-        <p:blipFill>
-          <a:blip r:embed="rId18"/>
-          <a:stretch>
-            <a:fillRect/>
-          </a:stretch>
-        </p:blipFill>
-        <p:spPr>
-          <a:xfrm>
-            <a:off x="4236720" y="7860030"/>
-            <a:ext cx="1813560" cy="1813560"/>
-          </a:xfrm>
-          <a:prstGeom prst="rect">
-            <a:avLst/>
-          </a:prstGeom>
-        </p:spPr>
-      </p:pic>
-      <p:sp>
-        <p:nvSpPr>
-          <p:cNvPr id="50" name="Rectangle 49"/>
-          <p:cNvSpPr/>
-          <p:nvPr/>
-        </p:nvSpPr>
-        <p:spPr>
-          <a:xfrm>
-            <a:off x="4236720" y="9330690"/>
-            <a:ext cx="1813560" cy="342900"/>
-          </a:xfrm>
-          <a:prstGeom prst="rect">
-            <a:avLst/>
-          </a:prstGeom>
-          <a:solidFill>
-            <a:srgbClr val="F3F1EA">
-              <a:alpha val="88000"/>
-            </a:srgbClr>
-          </a:solidFill>
-          <a:ln>
-            <a:noFill/>
-          </a:ln>
-          <a:effectLst/>
-        </p:spPr>
-        <p:style>
-          <a:lnRef idx="1">
-            <a:schemeClr val="accent1"/>
-          </a:lnRef>
-          <a:fillRef idx="3">
-            <a:schemeClr val="accent1"/>
-          </a:fillRef>
-          <a:effectRef idx="2">
-            <a:schemeClr val="accent1"/>
-          </a:effectRef>
-          <a:fontRef idx="minor">
-            <a:schemeClr val="lt1"/>
-          </a:fontRef>
-        </p:style>
-        <p:txBody>
-          <a:bodyPr rtlCol="0" anchor="ctr"/>
-          <a:lstStyle/>
-          <a:p>
-            <a:pPr algn="ctr"/>
-          </a:p>
-        </p:txBody>
-      </p:sp>
-      <p:sp>
-        <p:nvSpPr>
-          <p:cNvPr id="51" name="TextBox 50"/>
-          <p:cNvSpPr txBox="1"/>
-          <p:nvPr/>
-        </p:nvSpPr>
-        <p:spPr>
-          <a:xfrm>
-            <a:off x="4274820" y="9330690"/>
-            <a:ext cx="1737360" cy="342900"/>
-          </a:xfrm>
-          <a:prstGeom prst="rect">
-            <a:avLst/>
-          </a:prstGeom>
-          <a:noFill/>
-        </p:spPr>
-        <p:txBody>
-          <a:bodyPr wrap="square" lIns="0" rIns="0" tIns="0" bIns="0" anchor="ctr">
-            <a:spAutoFit/>
-          </a:bodyPr>
-          <a:lstStyle/>
-          <a:p>
-            <a:pPr algn="ctr">
-              <a:lnSpc>
-                <a:spcPct val="120000"/>
-              </a:lnSpc>
-            </a:pPr>
-            <a:r>
-              <a:rPr sz="1200" b="1" i="0">
-                <a:solidFill>
-                  <a:srgbClr val="31662F"/>
-                </a:solidFill>
-                <a:latin typeface="Montserrat"/>
-              </a:rPr>
-              <a:t>Caterina Capri</a:t>
-            </a:r>
-          </a:p>
-        </p:txBody>
-      </p:sp>
-      <p:pic>
-        <p:nvPicPr>
-          <p:cNvPr id="52" name="Picture 51" descr="8055802890071954999.jpg"/>
-          <p:cNvPicPr>
-            <a:picLocks noChangeAspect="1"/>
-          </p:cNvPicPr>
-          <p:nvPr/>
-        </p:nvPicPr>
-        <p:blipFill>
-          <a:blip r:embed="rId19"/>
-          <a:stretch>
-            <a:fillRect/>
-          </a:stretch>
-        </p:blipFill>
-        <p:spPr>
-          <a:xfrm>
-            <a:off x="6126480" y="7860030"/>
-            <a:ext cx="1813560" cy="1813560"/>
-          </a:xfrm>
-          <a:prstGeom prst="rect">
-            <a:avLst/>
-          </a:prstGeom>
-        </p:spPr>
-      </p:pic>
-      <p:sp>
-        <p:nvSpPr>
-          <p:cNvPr id="53" name="Rectangle 52"/>
-          <p:cNvSpPr/>
-          <p:nvPr/>
-        </p:nvSpPr>
-        <p:spPr>
-          <a:xfrm>
-            <a:off x="6126480" y="9330690"/>
-            <a:ext cx="1813560" cy="342900"/>
-          </a:xfrm>
-          <a:prstGeom prst="rect">
-            <a:avLst/>
-          </a:prstGeom>
-          <a:solidFill>
-            <a:srgbClr val="F3F1EA">
-              <a:alpha val="88000"/>
-            </a:srgbClr>
-          </a:solidFill>
-          <a:ln>
-            <a:noFill/>
-          </a:ln>
-          <a:effectLst/>
-        </p:spPr>
-        <p:style>
-          <a:lnRef idx="1">
-            <a:schemeClr val="accent1"/>
-          </a:lnRef>
-          <a:fillRef idx="3">
-            <a:schemeClr val="accent1"/>
-          </a:fillRef>
-          <a:effectRef idx="2">
-            <a:schemeClr val="accent1"/>
-          </a:effectRef>
-          <a:fontRef idx="minor">
-            <a:schemeClr val="lt1"/>
-          </a:fontRef>
-        </p:style>
-        <p:txBody>
-          <a:bodyPr rtlCol="0" anchor="ctr"/>
-          <a:lstStyle/>
-          <a:p>
-            <a:pPr algn="ctr"/>
-          </a:p>
-        </p:txBody>
-      </p:sp>
-      <p:sp>
-        <p:nvSpPr>
-          <p:cNvPr id="54" name="TextBox 53"/>
-          <p:cNvSpPr txBox="1"/>
-          <p:nvPr/>
-        </p:nvSpPr>
-        <p:spPr>
-          <a:xfrm>
-            <a:off x="6164580" y="9330690"/>
-            <a:ext cx="1737360" cy="342900"/>
-          </a:xfrm>
-          <a:prstGeom prst="rect">
-            <a:avLst/>
-          </a:prstGeom>
-          <a:noFill/>
-        </p:spPr>
-        <p:txBody>
-          <a:bodyPr wrap="square" lIns="0" rIns="0" tIns="0" bIns="0" anchor="ctr">
-            <a:spAutoFit/>
-          </a:bodyPr>
-          <a:lstStyle/>
-          <a:p>
-            <a:pPr algn="ctr">
-              <a:lnSpc>
-                <a:spcPct val="120000"/>
-              </a:lnSpc>
-            </a:pPr>
-            <a:r>
-              <a:rPr sz="1200" b="1" i="0">
-                <a:solidFill>
-                  <a:srgbClr val="31662F"/>
-                </a:solidFill>
-                <a:latin typeface="Montserrat"/>
-              </a:rPr>
-              <a:t>Laura Campos</a:t>
-            </a:r>
-          </a:p>
-        </p:txBody>
-      </p:sp>
-      <p:pic>
-        <p:nvPicPr>
-          <p:cNvPr id="55" name="Picture 54" descr="6327792871960472773.jpg"/>
-          <p:cNvPicPr>
-            <a:picLocks noChangeAspect="1"/>
-          </p:cNvPicPr>
-          <p:nvPr/>
-        </p:nvPicPr>
-        <p:blipFill>
-          <a:blip r:embed="rId20"/>
-          <a:stretch>
-            <a:fillRect/>
-          </a:stretch>
-        </p:blipFill>
-        <p:spPr>
-          <a:xfrm>
-            <a:off x="8016240" y="7860030"/>
-            <a:ext cx="1813560" cy="1813560"/>
-          </a:xfrm>
-          <a:prstGeom prst="rect">
-            <a:avLst/>
-          </a:prstGeom>
-        </p:spPr>
-      </p:pic>
-      <p:sp>
-        <p:nvSpPr>
-          <p:cNvPr id="56" name="Rectangle 55"/>
-          <p:cNvSpPr/>
-          <p:nvPr/>
-        </p:nvSpPr>
-        <p:spPr>
-          <a:xfrm>
-            <a:off x="8016240" y="9330690"/>
-            <a:ext cx="1813560" cy="342900"/>
-          </a:xfrm>
-          <a:prstGeom prst="rect">
-            <a:avLst/>
-          </a:prstGeom>
-          <a:solidFill>
-            <a:srgbClr val="F3F1EA">
-              <a:alpha val="88000"/>
-            </a:srgbClr>
-          </a:solidFill>
-          <a:ln>
-            <a:noFill/>
-          </a:ln>
-          <a:effectLst/>
-        </p:spPr>
-        <p:style>
-          <a:lnRef idx="1">
-            <a:schemeClr val="accent1"/>
-          </a:lnRef>
-          <a:fillRef idx="3">
-            <a:schemeClr val="accent1"/>
-          </a:fillRef>
-          <a:effectRef idx="2">
-            <a:schemeClr val="accent1"/>
-          </a:effectRef>
-          <a:fontRef idx="minor">
-            <a:schemeClr val="lt1"/>
-          </a:fontRef>
-        </p:style>
-        <p:txBody>
-          <a:bodyPr rtlCol="0" anchor="ctr"/>
-          <a:lstStyle/>
-          <a:p>
-            <a:pPr algn="ctr"/>
-          </a:p>
-        </p:txBody>
-      </p:sp>
-      <p:sp>
-        <p:nvSpPr>
-          <p:cNvPr id="57" name="TextBox 56"/>
-          <p:cNvSpPr txBox="1"/>
-          <p:nvPr/>
-        </p:nvSpPr>
-        <p:spPr>
-          <a:xfrm>
-            <a:off x="8054340" y="9330690"/>
-            <a:ext cx="1737360" cy="342900"/>
-          </a:xfrm>
-          <a:prstGeom prst="rect">
-            <a:avLst/>
-          </a:prstGeom>
-          <a:noFill/>
-        </p:spPr>
-        <p:txBody>
-          <a:bodyPr wrap="square" lIns="0" rIns="0" tIns="0" bIns="0" anchor="ctr">
-            <a:spAutoFit/>
-          </a:bodyPr>
-          <a:lstStyle/>
-          <a:p>
-            <a:pPr algn="ctr">
-              <a:lnSpc>
-                <a:spcPct val="120000"/>
-              </a:lnSpc>
-            </a:pPr>
-            <a:r>
-              <a:rPr sz="1200" b="1" i="0">
-                <a:solidFill>
-                  <a:srgbClr val="31662F"/>
-                </a:solidFill>
-                <a:latin typeface="Montserrat"/>
-              </a:rPr>
-              <a:t>Nora Levay</a:t>
-            </a:r>
-          </a:p>
-        </p:txBody>
-      </p:sp>
-      <p:sp>
-        <p:nvSpPr>
-          <p:cNvPr id="58" name="TextBox 57"/>
+      <p:sp>
+        <p:nvSpPr>
+          <p:cNvPr id="46" name="TextBox 45"/>
           <p:cNvSpPr txBox="1"/>
           <p:nvPr/>
         </p:nvSpPr>

</xml_diff>

<commit_message>
Teachers' Day grid slide: logo centred under the grid
Co-Authored-By: Claude Opus 5.5 <noreply@anthropic.com>
Claude-Session: https://claude.ai/code/session_014HGzAbxBh54nuyJHG7tse8
</commit_message>
<xml_diff>
--- a/templates/posts/october/05-10-2026-mon-ig-teachers-day-option-1-photo.pptx
+++ b/templates/posts/october/05-10-2026-mon-ig-teachers-day-option-1-photo.pptx
@@ -3589,7 +3589,7 @@
       <p:grpSpPr/>
       <p:pic>
         <p:nvPicPr>
-          <p:cNvPr id="2" name="Picture 1" descr="3532853474161955303.jpg"/>
+          <p:cNvPr id="2" name="Picture 1" descr="4312040359630697809.jpg"/>
           <p:cNvPicPr>
             <a:picLocks noChangeAspect="1"/>
           </p:cNvPicPr>
@@ -3858,7 +3858,7 @@
       </p:sp>
       <p:pic>
         <p:nvPicPr>
-          <p:cNvPr id="4" name="Picture 3" descr="7297811591439890433.jpg"/>
+          <p:cNvPr id="4" name="Picture 3" descr="4325354522426781560.jpg"/>
           <p:cNvPicPr>
             <a:picLocks noChangeAspect="1"/>
           </p:cNvPicPr>
@@ -3967,7 +3967,7 @@
       </p:sp>
       <p:pic>
         <p:nvPicPr>
-          <p:cNvPr id="7" name="Picture 6" descr="8728437986854537801.jpg"/>
+          <p:cNvPr id="7" name="Picture 6" descr="1732553050818676790.jpg"/>
           <p:cNvPicPr>
             <a:picLocks noChangeAspect="1"/>
           </p:cNvPicPr>
@@ -4076,7 +4076,7 @@
       </p:sp>
       <p:pic>
         <p:nvPicPr>
-          <p:cNvPr id="10" name="Picture 9" descr="8499503155804001537.jpg"/>
+          <p:cNvPr id="10" name="Picture 9" descr="6558719580005473315.jpg"/>
           <p:cNvPicPr>
             <a:picLocks noChangeAspect="1"/>
           </p:cNvPicPr>
@@ -4185,7 +4185,7 @@
       </p:sp>
       <p:pic>
         <p:nvPicPr>
-          <p:cNvPr id="13" name="Picture 12" descr="8664505731163078658.jpg"/>
+          <p:cNvPr id="13" name="Picture 12" descr="1213630668745913466.jpg"/>
           <p:cNvPicPr>
             <a:picLocks noChangeAspect="1"/>
           </p:cNvPicPr>
@@ -4294,7 +4294,7 @@
       </p:sp>
       <p:pic>
         <p:nvPicPr>
-          <p:cNvPr id="16" name="Picture 15" descr="7695145214115977211.jpg"/>
+          <p:cNvPr id="16" name="Picture 15" descr="7687647477321729715.jpg"/>
           <p:cNvPicPr>
             <a:picLocks noChangeAspect="1"/>
           </p:cNvPicPr>
@@ -4403,7 +4403,7 @@
       </p:sp>
       <p:pic>
         <p:nvPicPr>
-          <p:cNvPr id="19" name="Picture 18" descr="1311806062584278399.jpg"/>
+          <p:cNvPr id="19" name="Picture 18" descr="5031212317594417618.jpg"/>
           <p:cNvPicPr>
             <a:picLocks noChangeAspect="1"/>
           </p:cNvPicPr>
@@ -4512,7 +4512,7 @@
       </p:sp>
       <p:pic>
         <p:nvPicPr>
-          <p:cNvPr id="22" name="Picture 21" descr="5215010633690581301.jpg"/>
+          <p:cNvPr id="22" name="Picture 21" descr="5273411908651455532.jpg"/>
           <p:cNvPicPr>
             <a:picLocks noChangeAspect="1"/>
           </p:cNvPicPr>
@@ -4621,7 +4621,7 @@
       </p:sp>
       <p:pic>
         <p:nvPicPr>
-          <p:cNvPr id="25" name="Picture 24" descr="746667493973784667.jpg"/>
+          <p:cNvPr id="25" name="Picture 24" descr="5332898434888599316.jpg"/>
           <p:cNvPicPr>
             <a:picLocks noChangeAspect="1"/>
           </p:cNvPicPr>
@@ -4730,7 +4730,7 @@
       </p:sp>
       <p:pic>
         <p:nvPicPr>
-          <p:cNvPr id="28" name="Picture 27" descr="4763296968275485648.jpg"/>
+          <p:cNvPr id="28" name="Picture 27" descr="6311296678588155617.jpg"/>
           <p:cNvPicPr>
             <a:picLocks noChangeAspect="1"/>
           </p:cNvPicPr>
@@ -4839,7 +4839,7 @@
       </p:sp>
       <p:pic>
         <p:nvPicPr>
-          <p:cNvPr id="31" name="Picture 30" descr="5135560565093357647.jpg"/>
+          <p:cNvPr id="31" name="Picture 30" descr="7523051663126606764.jpg"/>
           <p:cNvPicPr>
             <a:picLocks noChangeAspect="1"/>
           </p:cNvPicPr>
@@ -4948,7 +4948,7 @@
       </p:sp>
       <p:pic>
         <p:nvPicPr>
-          <p:cNvPr id="34" name="Picture 33" descr="1228326016823983096.jpg"/>
+          <p:cNvPr id="34" name="Picture 33" descr="5837706495651502879.jpg"/>
           <p:cNvPicPr>
             <a:picLocks noChangeAspect="1"/>
           </p:cNvPicPr>
@@ -5057,7 +5057,7 @@
       </p:sp>
       <p:pic>
         <p:nvPicPr>
-          <p:cNvPr id="37" name="Picture 36" descr="2663829795774334274.jpg"/>
+          <p:cNvPr id="37" name="Picture 36" descr="7992983515775991812.jpg"/>
           <p:cNvPicPr>
             <a:picLocks noChangeAspect="1"/>
           </p:cNvPicPr>
@@ -5166,7 +5166,7 @@
       </p:sp>
       <p:pic>
         <p:nvPicPr>
-          <p:cNvPr id="40" name="Picture 39" descr="8496695976596084521.jpg"/>
+          <p:cNvPr id="40" name="Picture 39" descr="6299019462365137944.jpg"/>
           <p:cNvPicPr>
             <a:picLocks noChangeAspect="1"/>
           </p:cNvPicPr>
@@ -5275,7 +5275,7 @@
       </p:sp>
       <p:pic>
         <p:nvPicPr>
-          <p:cNvPr id="43" name="Picture 42" descr="8052758747183003055.jpg"/>
+          <p:cNvPr id="43" name="Picture 42" descr="9166712994638490770.jpg"/>
           <p:cNvPicPr>
             <a:picLocks noChangeAspect="1"/>
           </p:cNvPicPr>

</xml_diff>

<commit_message>
Teachers' Day grid: plain caption names under photos, logo under the title
Co-Authored-By: Claude Opus 5.5 <noreply@anthropic.com>
Claude-Session: https://claude.ai/code/session_014HGzAbxBh54nuyJHG7tse8
</commit_message>
<xml_diff>
--- a/templates/posts/october/05-10-2026-mon-ig-teachers-day-option-1-photo.pptx
+++ b/templates/posts/october/05-10-2026-mon-ig-teachers-day-option-1-photo.pptx
@@ -3589,7 +3589,7 @@
       <p:grpSpPr/>
       <p:pic>
         <p:nvPicPr>
-          <p:cNvPr id="2" name="Picture 1" descr="4312040359630697809.jpg"/>
+          <p:cNvPr id="2" name="Picture 1" descr="46990578986286380.jpg"/>
           <p:cNvPicPr>
             <a:picLocks noChangeAspect="1"/>
           </p:cNvPicPr>
@@ -3858,7 +3858,7 @@
       </p:sp>
       <p:pic>
         <p:nvPicPr>
-          <p:cNvPr id="4" name="Picture 3" descr="4325354522426781560.jpg"/>
+          <p:cNvPr id="4" name="Picture 3" descr="7767655283041233060.jpg"/>
           <p:cNvPicPr>
             <a:picLocks noChangeAspect="1"/>
           </p:cNvPicPr>
@@ -3967,7 +3967,7 @@
       </p:sp>
       <p:pic>
         <p:nvPicPr>
-          <p:cNvPr id="7" name="Picture 6" descr="1732553050818676790.jpg"/>
+          <p:cNvPr id="7" name="Picture 6" descr="2855909617508751556.jpg"/>
           <p:cNvPicPr>
             <a:picLocks noChangeAspect="1"/>
           </p:cNvPicPr>
@@ -4076,7 +4076,7 @@
       </p:sp>
       <p:pic>
         <p:nvPicPr>
-          <p:cNvPr id="10" name="Picture 9" descr="6558719580005473315.jpg"/>
+          <p:cNvPr id="10" name="Picture 9" descr="3779064170636143037.jpg"/>
           <p:cNvPicPr>
             <a:picLocks noChangeAspect="1"/>
           </p:cNvPicPr>
@@ -4185,7 +4185,7 @@
       </p:sp>
       <p:pic>
         <p:nvPicPr>
-          <p:cNvPr id="13" name="Picture 12" descr="1213630668745913466.jpg"/>
+          <p:cNvPr id="13" name="Picture 12" descr="6194691986289224762.jpg"/>
           <p:cNvPicPr>
             <a:picLocks noChangeAspect="1"/>
           </p:cNvPicPr>
@@ -4294,7 +4294,7 @@
       </p:sp>
       <p:pic>
         <p:nvPicPr>
-          <p:cNvPr id="16" name="Picture 15" descr="7687647477321729715.jpg"/>
+          <p:cNvPr id="16" name="Picture 15" descr="1913719621523367371.jpg"/>
           <p:cNvPicPr>
             <a:picLocks noChangeAspect="1"/>
           </p:cNvPicPr>
@@ -4403,7 +4403,7 @@
       </p:sp>
       <p:pic>
         <p:nvPicPr>
-          <p:cNvPr id="19" name="Picture 18" descr="5031212317594417618.jpg"/>
+          <p:cNvPr id="19" name="Picture 18" descr="1665765394624969327.jpg"/>
           <p:cNvPicPr>
             <a:picLocks noChangeAspect="1"/>
           </p:cNvPicPr>
@@ -4512,7 +4512,7 @@
       </p:sp>
       <p:pic>
         <p:nvPicPr>
-          <p:cNvPr id="22" name="Picture 21" descr="5273411908651455532.jpg"/>
+          <p:cNvPr id="22" name="Picture 21" descr="3518042680015161469.jpg"/>
           <p:cNvPicPr>
             <a:picLocks noChangeAspect="1"/>
           </p:cNvPicPr>
@@ -4621,7 +4621,7 @@
       </p:sp>
       <p:pic>
         <p:nvPicPr>
-          <p:cNvPr id="25" name="Picture 24" descr="5332898434888599316.jpg"/>
+          <p:cNvPr id="25" name="Picture 24" descr="3970960260678623010.jpg"/>
           <p:cNvPicPr>
             <a:picLocks noChangeAspect="1"/>
           </p:cNvPicPr>
@@ -4730,7 +4730,7 @@
       </p:sp>
       <p:pic>
         <p:nvPicPr>
-          <p:cNvPr id="28" name="Picture 27" descr="6311296678588155617.jpg"/>
+          <p:cNvPr id="28" name="Picture 27" descr="8302949435964405591.jpg"/>
           <p:cNvPicPr>
             <a:picLocks noChangeAspect="1"/>
           </p:cNvPicPr>
@@ -4839,7 +4839,7 @@
       </p:sp>
       <p:pic>
         <p:nvPicPr>
-          <p:cNvPr id="31" name="Picture 30" descr="7523051663126606764.jpg"/>
+          <p:cNvPr id="31" name="Picture 30" descr="5449205996364737380.jpg"/>
           <p:cNvPicPr>
             <a:picLocks noChangeAspect="1"/>
           </p:cNvPicPr>
@@ -4948,7 +4948,7 @@
       </p:sp>
       <p:pic>
         <p:nvPicPr>
-          <p:cNvPr id="34" name="Picture 33" descr="5837706495651502879.jpg"/>
+          <p:cNvPr id="34" name="Picture 33" descr="1356165162909352538.jpg"/>
           <p:cNvPicPr>
             <a:picLocks noChangeAspect="1"/>
           </p:cNvPicPr>
@@ -5057,7 +5057,7 @@
       </p:sp>
       <p:pic>
         <p:nvPicPr>
-          <p:cNvPr id="37" name="Picture 36" descr="7992983515775991812.jpg"/>
+          <p:cNvPr id="37" name="Picture 36" descr="304168690878683566.jpg"/>
           <p:cNvPicPr>
             <a:picLocks noChangeAspect="1"/>
           </p:cNvPicPr>
@@ -5166,7 +5166,7 @@
       </p:sp>
       <p:pic>
         <p:nvPicPr>
-          <p:cNvPr id="40" name="Picture 39" descr="6299019462365137944.jpg"/>
+          <p:cNvPr id="40" name="Picture 39" descr="8800070933331447382.jpg"/>
           <p:cNvPicPr>
             <a:picLocks noChangeAspect="1"/>
           </p:cNvPicPr>
@@ -5275,7 +5275,7 @@
       </p:sp>
       <p:pic>
         <p:nvPicPr>
-          <p:cNvPr id="43" name="Picture 42" descr="9166712994638490770.jpg"/>
+          <p:cNvPr id="43" name="Picture 42" descr="882755308084976196.jpg"/>
           <p:cNvPicPr>
             <a:picLocks noChangeAspect="1"/>
           </p:cNvPicPr>

</xml_diff>

<commit_message>
New logo with flowers (Final Oct 2026) replaces the old logo everywhere; old logo files deleted. Teachers' Day v3: scratched-paper texture after Stephanie's Canva, Mentor & Consultant titles
Co-Authored-By: Claude Opus 5.5 <noreply@anthropic.com>
Claude-Session: https://claude.ai/code/session_014HGzAbxBh54nuyJHG7tse8
</commit_message>
<xml_diff>
--- a/templates/posts/october/05-10-2026-mon-ig-teachers-day-option-1-photo.pptx
+++ b/templates/posts/october/05-10-2026-mon-ig-teachers-day-option-1-photo.pptx
@@ -3589,7 +3589,7 @@
       <p:grpSpPr/>
       <p:pic>
         <p:nvPicPr>
-          <p:cNvPr id="2" name="Picture 1" descr="5211807935410590349.jpg"/>
+          <p:cNvPr id="2" name="Picture 1" descr="3396308127317796790.jpg"/>
           <p:cNvPicPr>
             <a:picLocks noChangeAspect="1"/>
           </p:cNvPicPr>
@@ -3858,7 +3858,7 @@
       </p:sp>
       <p:pic>
         <p:nvPicPr>
-          <p:cNvPr id="4" name="Picture 3" descr="5603317114199949942.jpg"/>
+          <p:cNvPr id="4" name="Picture 3" descr="8994635771278737361.jpg"/>
           <p:cNvPicPr>
             <a:picLocks noChangeAspect="1"/>
           </p:cNvPicPr>
@@ -3967,7 +3967,7 @@
       </p:sp>
       <p:pic>
         <p:nvPicPr>
-          <p:cNvPr id="7" name="Picture 6" descr="7830199770994796711.jpg"/>
+          <p:cNvPr id="7" name="Picture 6" descr="3064864148393557809.jpg"/>
           <p:cNvPicPr>
             <a:picLocks noChangeAspect="1"/>
           </p:cNvPicPr>
@@ -4076,7 +4076,7 @@
       </p:sp>
       <p:pic>
         <p:nvPicPr>
-          <p:cNvPr id="10" name="Picture 9" descr="4571667486435294808.jpg"/>
+          <p:cNvPr id="10" name="Picture 9" descr="7815650767561644754.jpg"/>
           <p:cNvPicPr>
             <a:picLocks noChangeAspect="1"/>
           </p:cNvPicPr>
@@ -4185,7 +4185,7 @@
       </p:sp>
       <p:pic>
         <p:nvPicPr>
-          <p:cNvPr id="13" name="Picture 12" descr="9088374418818931136.jpg"/>
+          <p:cNvPr id="13" name="Picture 12" descr="3589319268339702705.jpg"/>
           <p:cNvPicPr>
             <a:picLocks noChangeAspect="1"/>
           </p:cNvPicPr>
@@ -4294,7 +4294,7 @@
       </p:sp>
       <p:pic>
         <p:nvPicPr>
-          <p:cNvPr id="16" name="Picture 15" descr="6594270107413876614.jpg"/>
+          <p:cNvPr id="16" name="Picture 15" descr="3815175066278969693.jpg"/>
           <p:cNvPicPr>
             <a:picLocks noChangeAspect="1"/>
           </p:cNvPicPr>
@@ -4403,7 +4403,7 @@
       </p:sp>
       <p:pic>
         <p:nvPicPr>
-          <p:cNvPr id="19" name="Picture 18" descr="8713409569344051093.jpg"/>
+          <p:cNvPr id="19" name="Picture 18" descr="4614445495298174257.jpg"/>
           <p:cNvPicPr>
             <a:picLocks noChangeAspect="1"/>
           </p:cNvPicPr>
@@ -4512,7 +4512,7 @@
       </p:sp>
       <p:pic>
         <p:nvPicPr>
-          <p:cNvPr id="22" name="Picture 21" descr="55297487836981199.jpg"/>
+          <p:cNvPr id="22" name="Picture 21" descr="8487436485798559110.jpg"/>
           <p:cNvPicPr>
             <a:picLocks noChangeAspect="1"/>
           </p:cNvPicPr>
@@ -4621,7 +4621,7 @@
       </p:sp>
       <p:pic>
         <p:nvPicPr>
-          <p:cNvPr id="25" name="Picture 24" descr="7725558612807332116.jpg"/>
+          <p:cNvPr id="25" name="Picture 24" descr="2456545260107240446.jpg"/>
           <p:cNvPicPr>
             <a:picLocks noChangeAspect="1"/>
           </p:cNvPicPr>
@@ -4730,7 +4730,7 @@
       </p:sp>
       <p:pic>
         <p:nvPicPr>
-          <p:cNvPr id="28" name="Picture 27" descr="891395382056755913.jpg"/>
+          <p:cNvPr id="28" name="Picture 27" descr="9164031694924200788.jpg"/>
           <p:cNvPicPr>
             <a:picLocks noChangeAspect="1"/>
           </p:cNvPicPr>
@@ -4839,7 +4839,7 @@
       </p:sp>
       <p:pic>
         <p:nvPicPr>
-          <p:cNvPr id="31" name="Picture 30" descr="4291221487964845528.jpg"/>
+          <p:cNvPr id="31" name="Picture 30" descr="245352837941254467.jpg"/>
           <p:cNvPicPr>
             <a:picLocks noChangeAspect="1"/>
           </p:cNvPicPr>
@@ -4948,7 +4948,7 @@
       </p:sp>
       <p:pic>
         <p:nvPicPr>
-          <p:cNvPr id="34" name="Picture 33" descr="6542959424271258557.jpg"/>
+          <p:cNvPr id="34" name="Picture 33" descr="7522010873324386665.jpg"/>
           <p:cNvPicPr>
             <a:picLocks noChangeAspect="1"/>
           </p:cNvPicPr>
@@ -5057,7 +5057,7 @@
       </p:sp>
       <p:pic>
         <p:nvPicPr>
-          <p:cNvPr id="37" name="Picture 36" descr="4785911602451428486.jpg"/>
+          <p:cNvPr id="37" name="Picture 36" descr="5925411254870724140.jpg"/>
           <p:cNvPicPr>
             <a:picLocks noChangeAspect="1"/>
           </p:cNvPicPr>
@@ -5166,7 +5166,7 @@
       </p:sp>
       <p:pic>
         <p:nvPicPr>
-          <p:cNvPr id="40" name="Picture 39" descr="2749247239648488048.jpg"/>
+          <p:cNvPr id="40" name="Picture 39" descr="6679412281472379077.jpg"/>
           <p:cNvPicPr>
             <a:picLocks noChangeAspect="1"/>
           </p:cNvPicPr>
@@ -5275,7 +5275,7 @@
       </p:sp>
       <p:pic>
         <p:nvPicPr>
-          <p:cNvPr id="43" name="Picture 42" descr="7116535034098222264.jpg"/>
+          <p:cNvPr id="43" name="Picture 42" descr="3104826297245477543.jpg"/>
           <p:cNvPicPr>
             <a:picLocks noChangeAspect="1"/>
           </p:cNvPicPr>

</xml_diff>